<commit_message>
Thach v2 tuned from scratch on val: no component passes, final = PEG
Round 1 (26 points, 9 components): cone +1.73 and damping +1.32 each rest on one or two val units
(-0.01 / -0.60 without them). Test once for the final config = PEG 68.34 / 61.41 / 76.2. Deck slide 33.

Co-Authored-By: Claude Opus 5.5 <noreply@anthropic.com>
Claude-Session: https://claude.ai/code/session_01HL8W3BdZcU7eyXJvRAQqfT
</commit_message>
<xml_diff>
--- a/results/peg_f/PEG_F.pptx
+++ b/results/peg_f/PEG_F.pptx
@@ -39,9 +39,10 @@
     <p:sldId id="287" r:id="rId33"/>
     <p:sldId id="288" r:id="rId34"/>
     <p:sldId id="289" r:id="rId35"/>
+    <p:sldId id="290" r:id="rId36"/>
   </p:sldIdLst>
   <p:notesMasterIdLst>
-    <p:notesMasterId r:id="rId36"/>
+    <p:notesMasterId r:id="rId37"/>
   </p:notesMasterIdLst>
   <p:sldSz cx="12192000" cy="6858000"/>
   <p:notesSz cx="6858000" cy="12192000"/>
@@ -2823,7 +2824,7 @@
           <a:p>
             <a:r>
               <a:rPr lang="en-US" dirty="0"/>
-              <a:t>Tóm lại năm điều. Một, PEG-F bản đầu tái hiện được, nhưng khi so cùng cấu hình thì mức tăng chỉ +0.49 HOTA, và hai lần đổi ID quyết định gần hết mức tăng đó. Hai, PEG-F bản hai: Table I tái hiện đúng cả mười bốn cấu hình, nhưng Thạch chỉnh và chọn mọi thứ trên test; khi chọn lại trên val bằng luật chốt trước thì không method nào qua. Ba, ở bản hai, M1 đi cùng M5 làm Table III sụt mạnh, từ 76.2 xuống 53.6 trên test và từ 67.6 xuống 37.1 trên val, vì box bị kéo trượt ngang khỏi người. Bốn, PEG+ tăng Rcv trên test +5.6, trên val −0.4, gộp lại +3.2: chỉ giúp khi box co lại lúc coast. Năm, nhìn một mình Table I rất dễ bị đánh lừa, nên lúc nào cũng đo đủ ba bảng, chọn trên val và báo test một lần. Hướng tiếp theo: chọn bằng khoảng tin cậy hoặc cross-validation thay vì ngưỡng cứng; tune tham số của method trên val; nếu giữ M5 thì cú kéo về đèn phải có độ tin cố định, không phụ thuộc độ bất định của Kalman; và M6 đáng thử lại khi có thêm dữ liệu val có người đứng gần đèn. Bài học lớn nhất với mình không phải một con số mà là cách làm: tái hiện trước, so cùng cấu hình, đo cả ba bảng, chọn trên val, và tách từng phần ra để xem phần nào thật sự có tác dụng.</a:t>
+              <a:t>Chọn lại trên val chưa đủ, vì các tham số bên trong method vẫn là số Thạch đã chỉnh trên test. Nên bọn mình tune lại từ đầu, chỉ trên val, với luật viết trước và đưa lên git trước khi chạy. Điểm xuất phát là PEG: bọn mình chép lại logic đổi ID gốc của PEG vào code của Thạch và kiểm tra là khi tắt hết method thì ra đúng từng số của PEG. Phần đổi ID mà Thạch viết lại cũng thành một thành phần để thử. Mỗi vòng, mỗi thành phần được thử với vài giá trị tham số, vòng đầu tổng cộng 26 lượt. Bảng này là giá trị tốt nhất của từng thành phần ở vòng đầu. Chỉ có hai thứ tăng quá ngưỡng: cone của M1, cộng 1.73, và phần hãm vận tốc, cộng 1.32. Nhưng khi bỏ đi một video hoặc một lần chói có lợi nhất, cone còn −0.01 và hãm vận tốc còn −0.60: toàn bộ mức tăng của cone nằm ở hai video, 156 và 147, còn của hãm vận tốc nằm ở một lần chói trong video 332. Phần nở vùng bất định, Re-ID và pool track ngủ không đổi gì khi đứng một mình; neo đèn và tone-map làm giảm. Nên không thành phần nào được nhận, cấu hình cuối cùng chính là PEG, và test một lần cho nó ra đúng số PEG: 68.34, 61.41 và 76.2.</a:t>
             </a:r>
             <a:endParaRPr lang="en-US" dirty="0"/>
           </a:p>
@@ -2911,7 +2912,7 @@
           <a:p>
             <a:r>
               <a:rPr lang="en-US" dirty="0"/>
-              <a:t>Bọn mình xin cảm ơn thầy cô và các bạn đã lắng nghe. Giờ bọn mình xin nhận câu hỏi.</a:t>
+              <a:t>Tóm lại năm điều. Một, PEG-F bản đầu tái hiện được, nhưng khi so cùng cấu hình thì mức tăng chỉ +0.49 HOTA, và hai lần đổi ID quyết định gần hết mức tăng đó. Hai, PEG-F bản hai: Table I tái hiện đúng cả mười bốn cấu hình, nhưng Thạch chỉnh và chọn mọi thứ trên test; khi chọn lại trên val bằng luật chốt trước thì không method nào qua; và khi tune lại tham số từ đầu, chỉ trên val, kết quả vẫn vậy, cấu hình cuối cùng là PEG. Ba, ở bản hai, M1 đi cùng M5 làm Table III sụt mạnh, từ 76.2 xuống 53.6 trên test và từ 67.6 xuống 37.1 trên val, vì box bị kéo trượt ngang khỏi người. Bốn, PEG+ tăng Rcv trên test +5.6, trên val −0.4, gộp lại +3.2: chỉ giúp khi box co lại lúc coast. Năm, nhìn một mình Table I rất dễ bị đánh lừa, nên lúc nào cũng đo đủ ba bảng, chọn trên val và báo test một lần. Hướng tiếp theo: chọn bằng khoảng tin cậy hoặc cross-validation thay vì ngưỡng cứng; thêm dữ liệu val, vì hiện giờ một hai video quyết định mọi mức tăng; nếu giữ M5 thì cú kéo về đèn phải có độ tin cố định, không phụ thuộc độ bất định của Kalman; và M6 đáng thử lại khi có thêm dữ liệu val có người đứng gần đèn. Bài học lớn nhất với mình không phải một con số mà là cách làm: tái hiện trước, so cùng cấu hình, đo cả ba bảng, chọn trên val, và tách từng phần ra để xem phần nào thật sự có tác dụng.</a:t>
             </a:r>
             <a:endParaRPr lang="en-US" dirty="0"/>
           </a:p>
@@ -2935,6 +2936,94 @@
             <a:fld id="{F7021451-1387-4CA6-816F-3879F97B5CBC}" type="slidenum">
               <a:rPr lang="en-US"/>
               <a:t>34</a:t>
+            </a:fld>
+            <a:endParaRPr lang="en-US"/>
+          </a:p>
+        </p:txBody>
+      </p:sp>
+    </p:spTree>
+    <p:extLst>
+      <p:ext uri="{BB962C8B-B14F-4D97-AF65-F5344CB8AC3E}">
+        <p14:creationId xmlns:p14="http://schemas.microsoft.com/office/powerpoint/2010/main" val="1024086991"/>
+      </p:ext>
+    </p:extLst>
+  </p:cSld>
+  <p:clrMapOvr>
+    <a:masterClrMapping/>
+  </p:clrMapOvr>
+</p:notes>
+</file>
+
+<file path=ppt/notesSlides/notesSlide35.xml><?xml version="1.0" encoding="utf-8"?>
+<p:notes xmlns:a="http://schemas.openxmlformats.org/drawingml/2006/main" xmlns:r="http://schemas.openxmlformats.org/officeDocument/2006/relationships" xmlns:p="http://schemas.openxmlformats.org/presentationml/2006/main">
+  <p:cSld>
+    <p:spTree>
+      <p:nvGrpSpPr>
+        <p:cNvPr id="1" name=""/>
+        <p:cNvGrpSpPr/>
+        <p:nvPr/>
+      </p:nvGrpSpPr>
+      <p:grpSpPr>
+        <a:xfrm>
+          <a:off x="0" y="0"/>
+          <a:ext cx="0" cy="0"/>
+          <a:chOff x="0" y="0"/>
+          <a:chExt cx="0" cy="0"/>
+        </a:xfrm>
+      </p:grpSpPr>
+      <p:sp>
+        <p:nvSpPr>
+          <p:cNvPr id="2" name="Slide Image Placeholder 1"/>
+          <p:cNvSpPr>
+            <a:spLocks noGrp="1" noRot="1" noChangeAspect="1"/>
+          </p:cNvSpPr>
+          <p:nvPr>
+            <p:ph type="sldImg"/>
+          </p:nvPr>
+        </p:nvSpPr>
+        <p:spPr/>
+      </p:sp>
+      <p:sp>
+        <p:nvSpPr>
+          <p:cNvPr id="3" name="Notes Placeholder 2"/>
+          <p:cNvSpPr>
+            <a:spLocks noGrp="1"/>
+          </p:cNvSpPr>
+          <p:nvPr>
+            <p:ph type="body" idx="1"/>
+          </p:nvPr>
+        </p:nvSpPr>
+        <p:spPr/>
+        <p:txBody>
+          <a:bodyPr/>
+          <a:lstStyle/>
+          <a:p>
+            <a:r>
+              <a:rPr lang="en-US" dirty="0"/>
+              <a:t>Bọn mình xin cảm ơn thầy cô và các bạn đã lắng nghe. Giờ bọn mình xin nhận câu hỏi.</a:t>
+            </a:r>
+            <a:endParaRPr lang="en-US" dirty="0"/>
+          </a:p>
+        </p:txBody>
+      </p:sp>
+      <p:sp>
+        <p:nvSpPr>
+          <p:cNvPr id="4" name="Slide Number Placeholder 3"/>
+          <p:cNvSpPr>
+            <a:spLocks noGrp="1"/>
+          </p:cNvSpPr>
+          <p:nvPr>
+            <p:ph type="sldNum" sz="quarter" idx="10"/>
+          </p:nvPr>
+        </p:nvSpPr>
+        <p:spPr/>
+        <p:txBody>
+          <a:bodyPr/>
+          <a:lstStyle/>
+          <a:p>
+            <a:fld id="{F7021451-1387-4CA6-816F-3879F97B5CBC}" type="slidenum">
+              <a:rPr lang="en-US"/>
+              <a:t>35</a:t>
             </a:fld>
             <a:endParaRPr lang="en-US"/>
           </a:p>
@@ -33403,7 +33492,7 @@
                 <a:ea typeface="Arial" pitchFamily="34" charset="-122"/>
                 <a:cs typeface="Arial" pitchFamily="34" charset="-120"/>
               </a:rPr>
-              <a:t>TỔNG KẾT</a:t>
+              <a:t>PEG-F v2 · TUNE TRÊN VAL</a:t>
             </a:r>
             <a:endParaRPr lang="en-US" sz="1300" dirty="0"/>
           </a:p>
@@ -33434,7 +33523,7 @@
               <a:buNone/>
             </a:pPr>
             <a:r>
-              <a:rPr lang="en-US" sz="3000" b="1" dirty="0">
+              <a:rPr lang="en-US" sz="2600" b="1" dirty="0">
                 <a:solidFill>
                   <a:srgbClr val="F2F2F2"/>
                 </a:solidFill>
@@ -33442,26 +33531,338 @@
                 <a:ea typeface="Arial" pitchFamily="34" charset="-122"/>
                 <a:cs typeface="Arial" pitchFamily="34" charset="-120"/>
               </a:rPr>
-              <a:t>Kết luận và bài học</a:t>
-            </a:r>
-            <a:endParaRPr lang="en-US" sz="3000" dirty="0"/>
-          </a:p>
-        </p:txBody>
-      </p:sp>
-      <p:sp>
-        <p:nvSpPr>
-          <p:cNvPr id="4" name="Shape 2"/>
+              <a:t>Tune lại tham số trên val từ đầu: vẫn không thành phần nào qua</a:t>
+            </a:r>
+            <a:endParaRPr lang="en-US" sz="2600" dirty="0"/>
+          </a:p>
+        </p:txBody>
+      </p:sp>
+      <p:sp>
+        <p:nvSpPr>
+          <p:cNvPr id="4" name="Text 2"/>
+          <p:cNvSpPr txBox="1"/>
+          <p:nvPr/>
+        </p:nvSpPr>
+        <p:spPr>
+          <a:xfrm>
+            <a:off x="548640" y="1325880"/>
+            <a:ext cx="11064240" cy="320040"/>
+          </a:xfrm>
+          <a:prstGeom prst="rect">
+            <a:avLst/>
+          </a:prstGeom>
+          <a:noFill/>
+          <a:ln/>
+        </p:spPr>
+        <p:txBody>
+          <a:bodyPr wrap="square" lIns="0" tIns="0" rIns="0" bIns="0" rtlCol="0" anchor="t"/>
+          <a:lstStyle/>
+          <a:p>
+            <a:pPr indent="0" marL="0">
+              <a:buNone/>
+            </a:pPr>
+            <a:r>
+              <a:rPr lang="en-US" sz="1300" dirty="0">
+                <a:solidFill>
+                  <a:srgbClr val="A3A8B0"/>
+                </a:solidFill>
+                <a:latin typeface="Arial" pitchFamily="34" charset="0"/>
+                <a:ea typeface="Arial" pitchFamily="34" charset="-122"/>
+                <a:cs typeface="Arial" pitchFamily="34" charset="-120"/>
+              </a:rPr>
+              <a:t>Xuất phát = PEG (đã kiểm: ra đúng từng số). Vòng 1 thử 26 giá trị tham số của 9 thành phần; mỗi dòng = giá trị tốt nhất của một thành phần.</a:t>
+            </a:r>
+            <a:endParaRPr lang="en-US" sz="1300" dirty="0"/>
+          </a:p>
+        </p:txBody>
+      </p:sp>
+      <p:sp>
+        <p:nvSpPr>
+          <p:cNvPr id="5" name="Text 3"/>
+          <p:cNvSpPr txBox="1"/>
+          <p:nvPr/>
+        </p:nvSpPr>
+        <p:spPr>
+          <a:xfrm>
+            <a:off x="777240" y="1691640"/>
+            <a:ext cx="3200400" cy="274320"/>
+          </a:xfrm>
+          <a:prstGeom prst="rect">
+            <a:avLst/>
+          </a:prstGeom>
+          <a:noFill/>
+          <a:ln/>
+        </p:spPr>
+        <p:txBody>
+          <a:bodyPr wrap="square" lIns="0" tIns="0" rIns="0" bIns="0" rtlCol="0" anchor="t"/>
+          <a:lstStyle/>
+          <a:p>
+            <a:pPr algn="l" indent="0" marL="0">
+              <a:buNone/>
+            </a:pPr>
+            <a:r>
+              <a:rPr lang="en-US" sz="1100" b="1" dirty="0">
+                <a:solidFill>
+                  <a:srgbClr val="A3A8B0"/>
+                </a:solidFill>
+                <a:latin typeface="Arial" pitchFamily="34" charset="0"/>
+                <a:ea typeface="Arial" pitchFamily="34" charset="-122"/>
+                <a:cs typeface="Arial" pitchFamily="34" charset="-120"/>
+              </a:rPr>
+              <a:t>thành phần</a:t>
+            </a:r>
+            <a:endParaRPr lang="en-US" sz="1100" dirty="0"/>
+          </a:p>
+        </p:txBody>
+      </p:sp>
+      <p:sp>
+        <p:nvSpPr>
+          <p:cNvPr id="6" name="Text 4"/>
+          <p:cNvSpPr txBox="1"/>
+          <p:nvPr/>
+        </p:nvSpPr>
+        <p:spPr>
+          <a:xfrm>
+            <a:off x="3977640" y="1691640"/>
+            <a:ext cx="2011680" cy="274320"/>
+          </a:xfrm>
+          <a:prstGeom prst="rect">
+            <a:avLst/>
+          </a:prstGeom>
+          <a:noFill/>
+          <a:ln/>
+        </p:spPr>
+        <p:txBody>
+          <a:bodyPr wrap="square" lIns="0" tIns="0" rIns="0" bIns="0" rtlCol="0" anchor="t"/>
+          <a:lstStyle/>
+          <a:p>
+            <a:pPr algn="l" indent="0" marL="0">
+              <a:buNone/>
+            </a:pPr>
+            <a:r>
+              <a:rPr lang="en-US" sz="1100" b="1" dirty="0">
+                <a:solidFill>
+                  <a:srgbClr val="A3A8B0"/>
+                </a:solidFill>
+                <a:latin typeface="Arial" pitchFamily="34" charset="0"/>
+                <a:ea typeface="Arial" pitchFamily="34" charset="-122"/>
+                <a:cs typeface="Arial" pitchFamily="34" charset="-120"/>
+              </a:rPr>
+              <a:t>tham số tốt nhất</a:t>
+            </a:r>
+            <a:endParaRPr lang="en-US" sz="1100" dirty="0"/>
+          </a:p>
+        </p:txBody>
+      </p:sp>
+      <p:sp>
+        <p:nvSpPr>
+          <p:cNvPr id="7" name="Text 5"/>
+          <p:cNvSpPr txBox="1"/>
+          <p:nvPr/>
+        </p:nvSpPr>
+        <p:spPr>
+          <a:xfrm>
+            <a:off x="5989320" y="1691640"/>
+            <a:ext cx="1005840" cy="274320"/>
+          </a:xfrm>
+          <a:prstGeom prst="rect">
+            <a:avLst/>
+          </a:prstGeom>
+          <a:noFill/>
+          <a:ln/>
+        </p:spPr>
+        <p:txBody>
+          <a:bodyPr wrap="square" lIns="0" tIns="0" rIns="0" bIns="0" rtlCol="0" anchor="t"/>
+          <a:lstStyle/>
+          <a:p>
+            <a:pPr algn="ctr" indent="0" marL="0">
+              <a:buNone/>
+            </a:pPr>
+            <a:r>
+              <a:rPr lang="en-US" sz="1100" b="1" dirty="0">
+                <a:solidFill>
+                  <a:srgbClr val="A3A8B0"/>
+                </a:solidFill>
+                <a:latin typeface="Arial" pitchFamily="34" charset="0"/>
+                <a:ea typeface="Arial" pitchFamily="34" charset="-122"/>
+                <a:cs typeface="Arial" pitchFamily="34" charset="-120"/>
+              </a:rPr>
+              <a:t>ΔT1 HOTA</a:t>
+            </a:r>
+            <a:endParaRPr lang="en-US" sz="1100" dirty="0"/>
+          </a:p>
+        </p:txBody>
+      </p:sp>
+      <p:sp>
+        <p:nvSpPr>
+          <p:cNvPr id="8" name="Text 6"/>
+          <p:cNvSpPr txBox="1"/>
+          <p:nvPr/>
+        </p:nvSpPr>
+        <p:spPr>
+          <a:xfrm>
+            <a:off x="6995160" y="1691640"/>
+            <a:ext cx="1005840" cy="274320"/>
+          </a:xfrm>
+          <a:prstGeom prst="rect">
+            <a:avLst/>
+          </a:prstGeom>
+          <a:noFill/>
+          <a:ln/>
+        </p:spPr>
+        <p:txBody>
+          <a:bodyPr wrap="square" lIns="0" tIns="0" rIns="0" bIns="0" rtlCol="0" anchor="t"/>
+          <a:lstStyle/>
+          <a:p>
+            <a:pPr algn="ctr" indent="0" marL="0">
+              <a:buNone/>
+            </a:pPr>
+            <a:r>
+              <a:rPr lang="en-US" sz="1100" b="1" dirty="0">
+                <a:solidFill>
+                  <a:srgbClr val="A3A8B0"/>
+                </a:solidFill>
+                <a:latin typeface="Arial" pitchFamily="34" charset="0"/>
+                <a:ea typeface="Arial" pitchFamily="34" charset="-122"/>
+                <a:cs typeface="Arial" pitchFamily="34" charset="-120"/>
+              </a:rPr>
+              <a:t>ΔT2 HOTA</a:t>
+            </a:r>
+            <a:endParaRPr lang="en-US" sz="1100" dirty="0"/>
+          </a:p>
+        </p:txBody>
+      </p:sp>
+      <p:sp>
+        <p:nvSpPr>
+          <p:cNvPr id="9" name="Text 7"/>
+          <p:cNvSpPr txBox="1"/>
+          <p:nvPr/>
+        </p:nvSpPr>
+        <p:spPr>
+          <a:xfrm>
+            <a:off x="8001000" y="1691640"/>
+            <a:ext cx="960120" cy="274320"/>
+          </a:xfrm>
+          <a:prstGeom prst="rect">
+            <a:avLst/>
+          </a:prstGeom>
+          <a:noFill/>
+          <a:ln/>
+        </p:spPr>
+        <p:txBody>
+          <a:bodyPr wrap="square" lIns="0" tIns="0" rIns="0" bIns="0" rtlCol="0" anchor="t"/>
+          <a:lstStyle/>
+          <a:p>
+            <a:pPr algn="ctr" indent="0" marL="0">
+              <a:buNone/>
+            </a:pPr>
+            <a:r>
+              <a:rPr lang="en-US" sz="1100" b="1" dirty="0">
+                <a:solidFill>
+                  <a:srgbClr val="A3A8B0"/>
+                </a:solidFill>
+                <a:latin typeface="Arial" pitchFamily="34" charset="0"/>
+                <a:ea typeface="Arial" pitchFamily="34" charset="-122"/>
+                <a:cs typeface="Arial" pitchFamily="34" charset="-120"/>
+              </a:rPr>
+              <a:t>ΔT3 Rcv</a:t>
+            </a:r>
+            <a:endParaRPr lang="en-US" sz="1100" dirty="0"/>
+          </a:p>
+        </p:txBody>
+      </p:sp>
+      <p:sp>
+        <p:nvSpPr>
+          <p:cNvPr id="10" name="Text 8"/>
+          <p:cNvSpPr txBox="1"/>
+          <p:nvPr/>
+        </p:nvSpPr>
+        <p:spPr>
+          <a:xfrm>
+            <a:off x="8961120" y="1691640"/>
+            <a:ext cx="960120" cy="274320"/>
+          </a:xfrm>
+          <a:prstGeom prst="rect">
+            <a:avLst/>
+          </a:prstGeom>
+          <a:noFill/>
+          <a:ln/>
+        </p:spPr>
+        <p:txBody>
+          <a:bodyPr wrap="square" lIns="0" tIns="0" rIns="0" bIns="0" rtlCol="0" anchor="t"/>
+          <a:lstStyle/>
+          <a:p>
+            <a:pPr algn="ctr" indent="0" marL="0">
+              <a:buNone/>
+            </a:pPr>
+            <a:r>
+              <a:rPr lang="en-US" sz="1100" b="1" dirty="0">
+                <a:solidFill>
+                  <a:srgbClr val="A3A8B0"/>
+                </a:solidFill>
+                <a:latin typeface="Arial" pitchFamily="34" charset="0"/>
+                <a:ea typeface="Arial" pitchFamily="34" charset="-122"/>
+                <a:cs typeface="Arial" pitchFamily="34" charset="-120"/>
+              </a:rPr>
+              <a:t>tổng</a:t>
+            </a:r>
+            <a:endParaRPr lang="en-US" sz="1100" dirty="0"/>
+          </a:p>
+        </p:txBody>
+      </p:sp>
+      <p:sp>
+        <p:nvSpPr>
+          <p:cNvPr id="11" name="Text 9"/>
+          <p:cNvSpPr txBox="1"/>
+          <p:nvPr/>
+        </p:nvSpPr>
+        <p:spPr>
+          <a:xfrm>
+            <a:off x="9921240" y="1691640"/>
+            <a:ext cx="1691640" cy="274320"/>
+          </a:xfrm>
+          <a:prstGeom prst="rect">
+            <a:avLst/>
+          </a:prstGeom>
+          <a:noFill/>
+          <a:ln/>
+        </p:spPr>
+        <p:txBody>
+          <a:bodyPr wrap="square" lIns="0" tIns="0" rIns="0" bIns="0" rtlCol="0" anchor="t"/>
+          <a:lstStyle/>
+          <a:p>
+            <a:pPr algn="ctr" indent="0" marL="0">
+              <a:buNone/>
+            </a:pPr>
+            <a:r>
+              <a:rPr lang="en-US" sz="1100" b="1" dirty="0">
+                <a:solidFill>
+                  <a:srgbClr val="A3A8B0"/>
+                </a:solidFill>
+                <a:latin typeface="Arial" pitchFamily="34" charset="0"/>
+                <a:ea typeface="Arial" pitchFamily="34" charset="-122"/>
+                <a:cs typeface="Arial" pitchFamily="34" charset="-120"/>
+              </a:rPr>
+              <a:t>bỏ 1 video / lần chói</a:t>
+            </a:r>
+            <a:endParaRPr lang="en-US" sz="1100" dirty="0"/>
+          </a:p>
+        </p:txBody>
+      </p:sp>
+      <p:sp>
+        <p:nvSpPr>
+          <p:cNvPr id="12" name="Shape 10"/>
           <p:cNvSpPr/>
           <p:nvPr/>
         </p:nvSpPr>
         <p:spPr>
           <a:xfrm>
-            <a:off x="548640" y="1508760"/>
-            <a:ext cx="5486400" cy="4480560"/>
+            <a:off x="548640" y="2011680"/>
+            <a:ext cx="11091672" cy="338328"/>
           </a:xfrm>
           <a:prstGeom prst="roundRect">
             <a:avLst>
-              <a:gd name="adj" fmla="val 2449"/>
+              <a:gd name="adj" fmla="val 32432"/>
             </a:avLst>
           </a:prstGeom>
           <a:solidFill>
@@ -33477,73 +33878,69 @@
       </p:sp>
       <p:sp>
         <p:nvSpPr>
-          <p:cNvPr id="5" name="Text 3"/>
-          <p:cNvSpPr txBox="1"/>
-          <p:nvPr/>
-        </p:nvSpPr>
-        <p:spPr>
-          <a:xfrm>
-            <a:off x="822960" y="1600200"/>
-            <a:ext cx="4937760" cy="365760"/>
-          </a:xfrm>
-          <a:prstGeom prst="rect">
-            <a:avLst/>
-          </a:prstGeom>
-          <a:noFill/>
-          <a:ln/>
-        </p:spPr>
-        <p:txBody>
-          <a:bodyPr wrap="square" lIns="0" tIns="0" rIns="0" bIns="0" rtlCol="0" anchor="t"/>
-          <a:lstStyle/>
-          <a:p>
-            <a:pPr indent="0" marL="0">
-              <a:buNone/>
-            </a:pPr>
-            <a:r>
-              <a:rPr lang="en-US" sz="2000" b="1" dirty="0">
-                <a:solidFill>
-                  <a:srgbClr val="F2A900"/>
-                </a:solidFill>
-                <a:latin typeface="Arial" pitchFamily="34" charset="0"/>
-                <a:ea typeface="Arial" pitchFamily="34" charset="-122"/>
-                <a:cs typeface="Arial" pitchFamily="34" charset="-120"/>
-              </a:rPr>
-              <a:t>Kết quả</a:t>
-            </a:r>
-            <a:endParaRPr lang="en-US" sz="2000" dirty="0"/>
-          </a:p>
-        </p:txBody>
-      </p:sp>
-      <p:sp>
-        <p:nvSpPr>
-          <p:cNvPr id="6" name="Text 4"/>
-          <p:cNvSpPr txBox="1"/>
-          <p:nvPr/>
-        </p:nvSpPr>
-        <p:spPr>
-          <a:xfrm>
-            <a:off x="822960" y="2103120"/>
-            <a:ext cx="4983480" cy="3749040"/>
-          </a:xfrm>
-          <a:prstGeom prst="rect">
-            <a:avLst/>
-          </a:prstGeom>
-          <a:noFill/>
-          <a:ln/>
-        </p:spPr>
-        <p:txBody>
-          <a:bodyPr wrap="square" lIns="0" tIns="0" rIns="0" bIns="0" rtlCol="0" anchor="t"/>
-          <a:lstStyle/>
-          <a:p>
-            <a:pPr marL="342900" indent="-342900">
-              <a:spcAft>
-                <a:spcPts val="800"/>
-              </a:spcAft>
-              <a:buSzPct val="100000"/>
-              <a:buChar char="•"/>
-            </a:pPr>
-            <a:r>
-              <a:rPr lang="en-US" sz="1500" dirty="0">
+          <p:cNvPr id="13" name="Text 11"/>
+          <p:cNvSpPr txBox="1"/>
+          <p:nvPr/>
+        </p:nvSpPr>
+        <p:spPr>
+          <a:xfrm>
+            <a:off x="777240" y="2011680"/>
+            <a:ext cx="3200400" cy="338328"/>
+          </a:xfrm>
+          <a:prstGeom prst="rect">
+            <a:avLst/>
+          </a:prstGeom>
+          <a:noFill/>
+          <a:ln/>
+        </p:spPr>
+        <p:txBody>
+          <a:bodyPr wrap="square" lIns="0" tIns="0" rIns="0" bIns="0" rtlCol="0" anchor="ctr"/>
+          <a:lstStyle/>
+          <a:p>
+            <a:pPr algn="l" indent="0" marL="0">
+              <a:buNone/>
+            </a:pPr>
+            <a:r>
+              <a:rPr lang="en-US" sz="1300" b="1" dirty="0">
+                <a:solidFill>
+                  <a:srgbClr val="9B6EE8"/>
+                </a:solidFill>
+                <a:latin typeface="Arial" pitchFamily="34" charset="0"/>
+                <a:ea typeface="Arial" pitchFamily="34" charset="-122"/>
+                <a:cs typeface="Arial" pitchFamily="34" charset="-120"/>
+              </a:rPr>
+              <a:t>M1 · cone khớp lại ID</a:t>
+            </a:r>
+            <a:endParaRPr lang="en-US" sz="1300" dirty="0"/>
+          </a:p>
+        </p:txBody>
+      </p:sp>
+      <p:sp>
+        <p:nvSpPr>
+          <p:cNvPr id="14" name="Text 12"/>
+          <p:cNvSpPr txBox="1"/>
+          <p:nvPr/>
+        </p:nvSpPr>
+        <p:spPr>
+          <a:xfrm>
+            <a:off x="3977640" y="2011680"/>
+            <a:ext cx="2011680" cy="338328"/>
+          </a:xfrm>
+          <a:prstGeom prst="rect">
+            <a:avLst/>
+          </a:prstGeom>
+          <a:noFill/>
+          <a:ln/>
+        </p:spPr>
+        <p:txBody>
+          <a:bodyPr wrap="square" lIns="0" tIns="0" rIns="0" bIns="0" rtlCol="0" anchor="ctr"/>
+          <a:lstStyle/>
+          <a:p>
+            <a:pPr algn="l" indent="0" marL="0">
+              <a:buNone/>
+            </a:pPr>
+            <a:r>
+              <a:rPr lang="en-US" sz="1200" dirty="0">
                 <a:solidFill>
                   <a:srgbClr val="F2F2F2"/>
                 </a:solidFill>
@@ -33551,20 +33948,116 @@
                 <a:ea typeface="Arial" pitchFamily="34" charset="-122"/>
                 <a:cs typeface="Arial" pitchFamily="34" charset="-120"/>
               </a:rPr>
-              <a:t>PEG-F v1: tái hiện được, nhưng cùng cấu hình chỉ +0.49 HOTA; 2 lần đổi ID quyết định bảng.</a:t>
-            </a:r>
-            <a:endParaRPr lang="en-US" sz="1500" dirty="0"/>
-          </a:p>
-          <a:p>
-            <a:pPr marL="342900" indent="-342900">
-              <a:spcAft>
-                <a:spcPts val="800"/>
-              </a:spcAft>
-              <a:buSzPct val="100000"/>
-              <a:buChar char="•"/>
-            </a:pPr>
-            <a:r>
-              <a:rPr lang="en-US" sz="1500" dirty="0">
+              <a:t>χ² 5.99, 0.04h</a:t>
+            </a:r>
+            <a:endParaRPr lang="en-US" sz="1200" dirty="0"/>
+          </a:p>
+        </p:txBody>
+      </p:sp>
+      <p:sp>
+        <p:nvSpPr>
+          <p:cNvPr id="15" name="Text 13"/>
+          <p:cNvSpPr txBox="1"/>
+          <p:nvPr/>
+        </p:nvSpPr>
+        <p:spPr>
+          <a:xfrm>
+            <a:off x="5989320" y="2011680"/>
+            <a:ext cx="1005840" cy="338328"/>
+          </a:xfrm>
+          <a:prstGeom prst="rect">
+            <a:avLst/>
+          </a:prstGeom>
+          <a:noFill/>
+          <a:ln/>
+        </p:spPr>
+        <p:txBody>
+          <a:bodyPr wrap="square" lIns="0" tIns="0" rIns="0" bIns="0" rtlCol="0" anchor="ctr"/>
+          <a:lstStyle/>
+          <a:p>
+            <a:pPr algn="ctr" indent="0" marL="0">
+              <a:buNone/>
+            </a:pPr>
+            <a:r>
+              <a:rPr lang="en-US" sz="1200" dirty="0">
+                <a:solidFill>
+                  <a:srgbClr val="19A35F"/>
+                </a:solidFill>
+                <a:latin typeface="Arial" pitchFamily="34" charset="0"/>
+                <a:ea typeface="Arial" pitchFamily="34" charset="-122"/>
+                <a:cs typeface="Arial" pitchFamily="34" charset="-120"/>
+              </a:rPr>
+              <a:t>+0.42</a:t>
+            </a:r>
+            <a:endParaRPr lang="en-US" sz="1200" dirty="0"/>
+          </a:p>
+        </p:txBody>
+      </p:sp>
+      <p:sp>
+        <p:nvSpPr>
+          <p:cNvPr id="16" name="Text 14"/>
+          <p:cNvSpPr txBox="1"/>
+          <p:nvPr/>
+        </p:nvSpPr>
+        <p:spPr>
+          <a:xfrm>
+            <a:off x="6995160" y="2011680"/>
+            <a:ext cx="1005840" cy="338328"/>
+          </a:xfrm>
+          <a:prstGeom prst="rect">
+            <a:avLst/>
+          </a:prstGeom>
+          <a:noFill/>
+          <a:ln/>
+        </p:spPr>
+        <p:txBody>
+          <a:bodyPr wrap="square" lIns="0" tIns="0" rIns="0" bIns="0" rtlCol="0" anchor="ctr"/>
+          <a:lstStyle/>
+          <a:p>
+            <a:pPr algn="ctr" indent="0" marL="0">
+              <a:buNone/>
+            </a:pPr>
+            <a:r>
+              <a:rPr lang="en-US" sz="1200" dirty="0">
+                <a:solidFill>
+                  <a:srgbClr val="19A35F"/>
+                </a:solidFill>
+                <a:latin typeface="Arial" pitchFamily="34" charset="0"/>
+                <a:ea typeface="Arial" pitchFamily="34" charset="-122"/>
+                <a:cs typeface="Arial" pitchFamily="34" charset="-120"/>
+              </a:rPr>
+              <a:t>+1.31</a:t>
+            </a:r>
+            <a:endParaRPr lang="en-US" sz="1200" dirty="0"/>
+          </a:p>
+        </p:txBody>
+      </p:sp>
+      <p:sp>
+        <p:nvSpPr>
+          <p:cNvPr id="17" name="Text 15"/>
+          <p:cNvSpPr txBox="1"/>
+          <p:nvPr/>
+        </p:nvSpPr>
+        <p:spPr>
+          <a:xfrm>
+            <a:off x="8001000" y="2011680"/>
+            <a:ext cx="960120" cy="338328"/>
+          </a:xfrm>
+          <a:prstGeom prst="rect">
+            <a:avLst/>
+          </a:prstGeom>
+          <a:noFill/>
+          <a:ln/>
+        </p:spPr>
+        <p:txBody>
+          <a:bodyPr wrap="square" lIns="0" tIns="0" rIns="0" bIns="0" rtlCol="0" anchor="ctr"/>
+          <a:lstStyle/>
+          <a:p>
+            <a:pPr algn="ctr" indent="0" marL="0">
+              <a:buNone/>
+            </a:pPr>
+            <a:r>
+              <a:rPr lang="en-US" sz="1200" dirty="0">
                 <a:solidFill>
                   <a:srgbClr val="F2F2F2"/>
                 </a:solidFill>
@@ -33572,89 +34065,2504 @@
                 <a:ea typeface="Arial" pitchFamily="34" charset="-122"/>
                 <a:cs typeface="Arial" pitchFamily="34" charset="-120"/>
               </a:rPr>
-              <a:t>PEG-F v2: Table I đúng 14/14 cấu hình, nhưng Thạch chỉnh và chọn trên test. Trên val không method nào qua luật.</a:t>
-            </a:r>
-            <a:endParaRPr lang="en-US" sz="1500" dirty="0"/>
-          </a:p>
-          <a:p>
-            <a:pPr marL="342900" indent="-342900">
-              <a:spcAft>
-                <a:spcPts val="800"/>
-              </a:spcAft>
-              <a:buSzPct val="100000"/>
-              <a:buChar char="•"/>
-            </a:pPr>
-            <a:r>
-              <a:rPr lang="en-US" sz="1500" dirty="0">
-                <a:solidFill>
-                  <a:srgbClr val="F2F2F2"/>
-                </a:solidFill>
-                <a:latin typeface="Arial" pitchFamily="34" charset="0"/>
-                <a:ea typeface="Arial" pitchFamily="34" charset="-122"/>
-                <a:cs typeface="Arial" pitchFamily="34" charset="-120"/>
-              </a:rPr>
-              <a:t>v2: M1 × M5 làm Table III sụt (76.2 → 53.6 test, 67.6 → 37.1 val): box trượt ngang.</a:t>
-            </a:r>
-            <a:endParaRPr lang="en-US" sz="1500" dirty="0"/>
-          </a:p>
-          <a:p>
-            <a:pPr marL="342900" indent="-342900">
-              <a:spcAft>
-                <a:spcPts val="800"/>
-              </a:spcAft>
-              <a:buSzPct val="100000"/>
-              <a:buChar char="•"/>
-            </a:pPr>
-            <a:r>
-              <a:rPr lang="en-US" sz="1500" dirty="0">
-                <a:solidFill>
-                  <a:srgbClr val="F2F2F2"/>
-                </a:solidFill>
-                <a:latin typeface="Arial" pitchFamily="34" charset="0"/>
-                <a:ea typeface="Arial" pitchFamily="34" charset="-122"/>
-                <a:cs typeface="Arial" pitchFamily="34" charset="-120"/>
-              </a:rPr>
-              <a:t>PEG+: Rcv test +5.6, val −0.4, gộp +3.2: chỉ giúp khi box co lại lúc coast.</a:t>
-            </a:r>
-            <a:endParaRPr lang="en-US" sz="1500" dirty="0"/>
-          </a:p>
-          <a:p>
-            <a:pPr marL="342900" indent="-342900">
-              <a:spcAft>
-                <a:spcPts val="800"/>
-              </a:spcAft>
-              <a:buSzPct val="100000"/>
-              <a:buChar char="•"/>
-            </a:pPr>
-            <a:r>
-              <a:rPr lang="en-US" sz="1500" dirty="0">
-                <a:solidFill>
-                  <a:srgbClr val="F2F2F2"/>
-                </a:solidFill>
-                <a:latin typeface="Arial" pitchFamily="34" charset="0"/>
-                <a:ea typeface="Arial" pitchFamily="34" charset="-122"/>
-                <a:cs typeface="Arial" pitchFamily="34" charset="-120"/>
-              </a:rPr>
-              <a:t>Table I một mình dễ đánh lừa → luôn đo đủ 3 bảng, chọn trên val, báo test 1 lần.</a:t>
-            </a:r>
-            <a:endParaRPr lang="en-US" sz="1500" dirty="0"/>
-          </a:p>
-        </p:txBody>
-      </p:sp>
-      <p:sp>
-        <p:nvSpPr>
-          <p:cNvPr id="7" name="Shape 5"/>
+              <a:t>±0.0</a:t>
+            </a:r>
+            <a:endParaRPr lang="en-US" sz="1200" dirty="0"/>
+          </a:p>
+        </p:txBody>
+      </p:sp>
+      <p:sp>
+        <p:nvSpPr>
+          <p:cNvPr id="18" name="Text 16"/>
+          <p:cNvSpPr txBox="1"/>
+          <p:nvPr/>
+        </p:nvSpPr>
+        <p:spPr>
+          <a:xfrm>
+            <a:off x="8961120" y="2011680"/>
+            <a:ext cx="960120" cy="338328"/>
+          </a:xfrm>
+          <a:prstGeom prst="rect">
+            <a:avLst/>
+          </a:prstGeom>
+          <a:noFill/>
+          <a:ln/>
+        </p:spPr>
+        <p:txBody>
+          <a:bodyPr wrap="square" lIns="0" tIns="0" rIns="0" bIns="0" rtlCol="0" anchor="ctr"/>
+          <a:lstStyle/>
+          <a:p>
+            <a:pPr algn="ctr" indent="0" marL="0">
+              <a:buNone/>
+            </a:pPr>
+            <a:r>
+              <a:rPr lang="en-US" sz="1200" b="1" dirty="0">
+                <a:solidFill>
+                  <a:srgbClr val="19A35F"/>
+                </a:solidFill>
+                <a:latin typeface="Arial" pitchFamily="34" charset="0"/>
+                <a:ea typeface="Arial" pitchFamily="34" charset="-122"/>
+                <a:cs typeface="Arial" pitchFamily="34" charset="-120"/>
+              </a:rPr>
+              <a:t>+1.73</a:t>
+            </a:r>
+            <a:endParaRPr lang="en-US" sz="1200" dirty="0"/>
+          </a:p>
+        </p:txBody>
+      </p:sp>
+      <p:sp>
+        <p:nvSpPr>
+          <p:cNvPr id="19" name="Text 17"/>
+          <p:cNvSpPr txBox="1"/>
+          <p:nvPr/>
+        </p:nvSpPr>
+        <p:spPr>
+          <a:xfrm>
+            <a:off x="9921240" y="2011680"/>
+            <a:ext cx="1691640" cy="338328"/>
+          </a:xfrm>
+          <a:prstGeom prst="rect">
+            <a:avLst/>
+          </a:prstGeom>
+          <a:noFill/>
+          <a:ln/>
+        </p:spPr>
+        <p:txBody>
+          <a:bodyPr wrap="square" lIns="0" tIns="0" rIns="0" bIns="0" rtlCol="0" anchor="ctr"/>
+          <a:lstStyle/>
+          <a:p>
+            <a:pPr algn="ctr" indent="0" marL="0">
+              <a:buNone/>
+            </a:pPr>
+            <a:r>
+              <a:rPr lang="en-US" sz="1200" dirty="0">
+                <a:solidFill>
+                  <a:srgbClr val="E66767"/>
+                </a:solidFill>
+                <a:latin typeface="Arial" pitchFamily="34" charset="0"/>
+                <a:ea typeface="Arial" pitchFamily="34" charset="-122"/>
+                <a:cs typeface="Arial" pitchFamily="34" charset="-120"/>
+              </a:rPr>
+              <a:t>còn −0.01</a:t>
+            </a:r>
+            <a:endParaRPr lang="en-US" sz="1200" dirty="0"/>
+          </a:p>
+        </p:txBody>
+      </p:sp>
+      <p:sp>
+        <p:nvSpPr>
+          <p:cNvPr id="20" name="Shape 18"/>
           <p:cNvSpPr/>
           <p:nvPr/>
         </p:nvSpPr>
         <p:spPr>
           <a:xfrm>
-            <a:off x="6199632" y="1508760"/>
-            <a:ext cx="5440680" cy="4480560"/>
+            <a:off x="548640" y="2395728"/>
+            <a:ext cx="11091672" cy="338328"/>
           </a:xfrm>
           <a:prstGeom prst="roundRect">
             <a:avLst>
-              <a:gd name="adj" fmla="val 2449"/>
+              <a:gd name="adj" fmla="val 32432"/>
+            </a:avLst>
+          </a:prstGeom>
+          <a:solidFill>
+            <a:srgbClr val="22252B"/>
+          </a:solidFill>
+          <a:ln w="12700">
+            <a:solidFill>
+              <a:srgbClr val="22252B"/>
+            </a:solidFill>
+            <a:prstDash val="solid"/>
+          </a:ln>
+        </p:spPr>
+      </p:sp>
+      <p:sp>
+        <p:nvSpPr>
+          <p:cNvPr id="21" name="Text 19"/>
+          <p:cNvSpPr txBox="1"/>
+          <p:nvPr/>
+        </p:nvSpPr>
+        <p:spPr>
+          <a:xfrm>
+            <a:off x="777240" y="2395728"/>
+            <a:ext cx="3200400" cy="338328"/>
+          </a:xfrm>
+          <a:prstGeom prst="rect">
+            <a:avLst/>
+          </a:prstGeom>
+          <a:noFill/>
+          <a:ln/>
+        </p:spPr>
+        <p:txBody>
+          <a:bodyPr wrap="square" lIns="0" tIns="0" rIns="0" bIns="0" rtlCol="0" anchor="ctr"/>
+          <a:lstStyle/>
+          <a:p>
+            <a:pPr algn="l" indent="0" marL="0">
+              <a:buNone/>
+            </a:pPr>
+            <a:r>
+              <a:rPr lang="en-US" sz="1300" b="1" dirty="0">
+                <a:solidFill>
+                  <a:srgbClr val="9B6EE8"/>
+                </a:solidFill>
+                <a:latin typeface="Arial" pitchFamily="34" charset="0"/>
+                <a:ea typeface="Arial" pitchFamily="34" charset="-122"/>
+                <a:cs typeface="Arial" pitchFamily="34" charset="-120"/>
+              </a:rPr>
+              <a:t>M1 · hãm vận tốc ×0.88</a:t>
+            </a:r>
+            <a:endParaRPr lang="en-US" sz="1300" dirty="0"/>
+          </a:p>
+        </p:txBody>
+      </p:sp>
+      <p:sp>
+        <p:nvSpPr>
+          <p:cNvPr id="22" name="Text 20"/>
+          <p:cNvSpPr txBox="1"/>
+          <p:nvPr/>
+        </p:nvSpPr>
+        <p:spPr>
+          <a:xfrm>
+            <a:off x="3977640" y="2395728"/>
+            <a:ext cx="2011680" cy="338328"/>
+          </a:xfrm>
+          <a:prstGeom prst="rect">
+            <a:avLst/>
+          </a:prstGeom>
+          <a:noFill/>
+          <a:ln/>
+        </p:spPr>
+        <p:txBody>
+          <a:bodyPr wrap="square" lIns="0" tIns="0" rIns="0" bIns="0" rtlCol="0" anchor="ctr"/>
+          <a:lstStyle/>
+          <a:p>
+            <a:pPr algn="l" indent="0" marL="0">
+              <a:buNone/>
+            </a:pPr>
+            <a:r>
+              <a:rPr lang="en-US" sz="1200" dirty="0">
+                <a:solidFill>
+                  <a:srgbClr val="F2F2F2"/>
+                </a:solidFill>
+                <a:latin typeface="Arial" pitchFamily="34" charset="0"/>
+                <a:ea typeface="Arial" pitchFamily="34" charset="-122"/>
+                <a:cs typeface="Arial" pitchFamily="34" charset="-120"/>
+              </a:rPr>
+              <a:t>bật</a:t>
+            </a:r>
+            <a:endParaRPr lang="en-US" sz="1200" dirty="0"/>
+          </a:p>
+        </p:txBody>
+      </p:sp>
+      <p:sp>
+        <p:nvSpPr>
+          <p:cNvPr id="23" name="Text 21"/>
+          <p:cNvSpPr txBox="1"/>
+          <p:nvPr/>
+        </p:nvSpPr>
+        <p:spPr>
+          <a:xfrm>
+            <a:off x="5989320" y="2395728"/>
+            <a:ext cx="1005840" cy="338328"/>
+          </a:xfrm>
+          <a:prstGeom prst="rect">
+            <a:avLst/>
+          </a:prstGeom>
+          <a:noFill/>
+          <a:ln/>
+        </p:spPr>
+        <p:txBody>
+          <a:bodyPr wrap="square" lIns="0" tIns="0" rIns="0" bIns="0" rtlCol="0" anchor="ctr"/>
+          <a:lstStyle/>
+          <a:p>
+            <a:pPr algn="ctr" indent="0" marL="0">
+              <a:buNone/>
+            </a:pPr>
+            <a:r>
+              <a:rPr lang="en-US" sz="1200" dirty="0">
+                <a:solidFill>
+                  <a:srgbClr val="F2F2F2"/>
+                </a:solidFill>
+                <a:latin typeface="Arial" pitchFamily="34" charset="0"/>
+                <a:ea typeface="Arial" pitchFamily="34" charset="-122"/>
+                <a:cs typeface="Arial" pitchFamily="34" charset="-120"/>
+              </a:rPr>
+              <a:t>±0.00</a:t>
+            </a:r>
+            <a:endParaRPr lang="en-US" sz="1200" dirty="0"/>
+          </a:p>
+        </p:txBody>
+      </p:sp>
+      <p:sp>
+        <p:nvSpPr>
+          <p:cNvPr id="24" name="Text 22"/>
+          <p:cNvSpPr txBox="1"/>
+          <p:nvPr/>
+        </p:nvSpPr>
+        <p:spPr>
+          <a:xfrm>
+            <a:off x="6995160" y="2395728"/>
+            <a:ext cx="1005840" cy="338328"/>
+          </a:xfrm>
+          <a:prstGeom prst="rect">
+            <a:avLst/>
+          </a:prstGeom>
+          <a:noFill/>
+          <a:ln/>
+        </p:spPr>
+        <p:txBody>
+          <a:bodyPr wrap="square" lIns="0" tIns="0" rIns="0" bIns="0" rtlCol="0" anchor="ctr"/>
+          <a:lstStyle/>
+          <a:p>
+            <a:pPr algn="ctr" indent="0" marL="0">
+              <a:buNone/>
+            </a:pPr>
+            <a:r>
+              <a:rPr lang="en-US" sz="1200" dirty="0">
+                <a:solidFill>
+                  <a:srgbClr val="E66767"/>
+                </a:solidFill>
+                <a:latin typeface="Arial" pitchFamily="34" charset="0"/>
+                <a:ea typeface="Arial" pitchFamily="34" charset="-122"/>
+                <a:cs typeface="Arial" pitchFamily="34" charset="-120"/>
+              </a:rPr>
+              <a:t>−0.48</a:t>
+            </a:r>
+            <a:endParaRPr lang="en-US" sz="1200" dirty="0"/>
+          </a:p>
+        </p:txBody>
+      </p:sp>
+      <p:sp>
+        <p:nvSpPr>
+          <p:cNvPr id="25" name="Text 23"/>
+          <p:cNvSpPr txBox="1"/>
+          <p:nvPr/>
+        </p:nvSpPr>
+        <p:spPr>
+          <a:xfrm>
+            <a:off x="8001000" y="2395728"/>
+            <a:ext cx="960120" cy="338328"/>
+          </a:xfrm>
+          <a:prstGeom prst="rect">
+            <a:avLst/>
+          </a:prstGeom>
+          <a:noFill/>
+          <a:ln/>
+        </p:spPr>
+        <p:txBody>
+          <a:bodyPr wrap="square" lIns="0" tIns="0" rIns="0" bIns="0" rtlCol="0" anchor="ctr"/>
+          <a:lstStyle/>
+          <a:p>
+            <a:pPr algn="ctr" indent="0" marL="0">
+              <a:buNone/>
+            </a:pPr>
+            <a:r>
+              <a:rPr lang="en-US" sz="1200" dirty="0">
+                <a:solidFill>
+                  <a:srgbClr val="19A35F"/>
+                </a:solidFill>
+                <a:latin typeface="Arial" pitchFamily="34" charset="0"/>
+                <a:ea typeface="Arial" pitchFamily="34" charset="-122"/>
+                <a:cs typeface="Arial" pitchFamily="34" charset="-120"/>
+              </a:rPr>
+              <a:t>+1.8</a:t>
+            </a:r>
+            <a:endParaRPr lang="en-US" sz="1200" dirty="0"/>
+          </a:p>
+        </p:txBody>
+      </p:sp>
+      <p:sp>
+        <p:nvSpPr>
+          <p:cNvPr id="26" name="Text 24"/>
+          <p:cNvSpPr txBox="1"/>
+          <p:nvPr/>
+        </p:nvSpPr>
+        <p:spPr>
+          <a:xfrm>
+            <a:off x="8961120" y="2395728"/>
+            <a:ext cx="960120" cy="338328"/>
+          </a:xfrm>
+          <a:prstGeom prst="rect">
+            <a:avLst/>
+          </a:prstGeom>
+          <a:noFill/>
+          <a:ln/>
+        </p:spPr>
+        <p:txBody>
+          <a:bodyPr wrap="square" lIns="0" tIns="0" rIns="0" bIns="0" rtlCol="0" anchor="ctr"/>
+          <a:lstStyle/>
+          <a:p>
+            <a:pPr algn="ctr" indent="0" marL="0">
+              <a:buNone/>
+            </a:pPr>
+            <a:r>
+              <a:rPr lang="en-US" sz="1200" b="1" dirty="0">
+                <a:solidFill>
+                  <a:srgbClr val="19A35F"/>
+                </a:solidFill>
+                <a:latin typeface="Arial" pitchFamily="34" charset="0"/>
+                <a:ea typeface="Arial" pitchFamily="34" charset="-122"/>
+                <a:cs typeface="Arial" pitchFamily="34" charset="-120"/>
+              </a:rPr>
+              <a:t>+1.32</a:t>
+            </a:r>
+            <a:endParaRPr lang="en-US" sz="1200" dirty="0"/>
+          </a:p>
+        </p:txBody>
+      </p:sp>
+      <p:sp>
+        <p:nvSpPr>
+          <p:cNvPr id="27" name="Text 25"/>
+          <p:cNvSpPr txBox="1"/>
+          <p:nvPr/>
+        </p:nvSpPr>
+        <p:spPr>
+          <a:xfrm>
+            <a:off x="9921240" y="2395728"/>
+            <a:ext cx="1691640" cy="338328"/>
+          </a:xfrm>
+          <a:prstGeom prst="rect">
+            <a:avLst/>
+          </a:prstGeom>
+          <a:noFill/>
+          <a:ln/>
+        </p:spPr>
+        <p:txBody>
+          <a:bodyPr wrap="square" lIns="0" tIns="0" rIns="0" bIns="0" rtlCol="0" anchor="ctr"/>
+          <a:lstStyle/>
+          <a:p>
+            <a:pPr algn="ctr" indent="0" marL="0">
+              <a:buNone/>
+            </a:pPr>
+            <a:r>
+              <a:rPr lang="en-US" sz="1200" dirty="0">
+                <a:solidFill>
+                  <a:srgbClr val="E66767"/>
+                </a:solidFill>
+                <a:latin typeface="Arial" pitchFamily="34" charset="0"/>
+                <a:ea typeface="Arial" pitchFamily="34" charset="-122"/>
+                <a:cs typeface="Arial" pitchFamily="34" charset="-120"/>
+              </a:rPr>
+              <a:t>còn −0.60</a:t>
+            </a:r>
+            <a:endParaRPr lang="en-US" sz="1200" dirty="0"/>
+          </a:p>
+        </p:txBody>
+      </p:sp>
+      <p:sp>
+        <p:nvSpPr>
+          <p:cNvPr id="28" name="Shape 26"/>
+          <p:cNvSpPr/>
+          <p:nvPr/>
+        </p:nvSpPr>
+        <p:spPr>
+          <a:xfrm>
+            <a:off x="548640" y="2779776"/>
+            <a:ext cx="11091672" cy="338328"/>
+          </a:xfrm>
+          <a:prstGeom prst="roundRect">
+            <a:avLst>
+              <a:gd name="adj" fmla="val 32432"/>
+            </a:avLst>
+          </a:prstGeom>
+          <a:solidFill>
+            <a:srgbClr val="22252B"/>
+          </a:solidFill>
+          <a:ln w="12700">
+            <a:solidFill>
+              <a:srgbClr val="22252B"/>
+            </a:solidFill>
+            <a:prstDash val="solid"/>
+          </a:ln>
+        </p:spPr>
+      </p:sp>
+      <p:sp>
+        <p:nvSpPr>
+          <p:cNvPr id="29" name="Text 27"/>
+          <p:cNvSpPr txBox="1"/>
+          <p:nvPr/>
+        </p:nvSpPr>
+        <p:spPr>
+          <a:xfrm>
+            <a:off x="777240" y="2779776"/>
+            <a:ext cx="3200400" cy="338328"/>
+          </a:xfrm>
+          <a:prstGeom prst="rect">
+            <a:avLst/>
+          </a:prstGeom>
+          <a:noFill/>
+          <a:ln/>
+        </p:spPr>
+        <p:txBody>
+          <a:bodyPr wrap="square" lIns="0" tIns="0" rIns="0" bIns="0" rtlCol="0" anchor="ctr"/>
+          <a:lstStyle/>
+          <a:p>
+            <a:pPr algn="l" indent="0" marL="0">
+              <a:buNone/>
+            </a:pPr>
+            <a:r>
+              <a:rPr lang="en-US" sz="1300" b="1" dirty="0">
+                <a:solidFill>
+                  <a:srgbClr val="9B6EE8"/>
+                </a:solidFill>
+                <a:latin typeface="Arial" pitchFamily="34" charset="0"/>
+                <a:ea typeface="Arial" pitchFamily="34" charset="-122"/>
+                <a:cs typeface="Arial" pitchFamily="34" charset="-120"/>
+              </a:rPr>
+              <a:t>M3 · h động / TTL</a:t>
+            </a:r>
+            <a:endParaRPr lang="en-US" sz="1300" dirty="0"/>
+          </a:p>
+        </p:txBody>
+      </p:sp>
+      <p:sp>
+        <p:nvSpPr>
+          <p:cNvPr id="30" name="Text 28"/>
+          <p:cNvSpPr txBox="1"/>
+          <p:nvPr/>
+        </p:nvSpPr>
+        <p:spPr>
+          <a:xfrm>
+            <a:off x="3977640" y="2779776"/>
+            <a:ext cx="2011680" cy="338328"/>
+          </a:xfrm>
+          <a:prstGeom prst="rect">
+            <a:avLst/>
+          </a:prstGeom>
+          <a:noFill/>
+          <a:ln/>
+        </p:spPr>
+        <p:txBody>
+          <a:bodyPr wrap="square" lIns="0" tIns="0" rIns="0" bIns="0" rtlCol="0" anchor="ctr"/>
+          <a:lstStyle/>
+          <a:p>
+            <a:pPr algn="l" indent="0" marL="0">
+              <a:buNone/>
+            </a:pPr>
+            <a:r>
+              <a:rPr lang="en-US" sz="1200" dirty="0">
+                <a:solidFill>
+                  <a:srgbClr val="F2F2F2"/>
+                </a:solidFill>
+                <a:latin typeface="Arial" pitchFamily="34" charset="0"/>
+                <a:ea typeface="Arial" pitchFamily="34" charset="-122"/>
+                <a:cs typeface="Arial" pitchFamily="34" charset="-120"/>
+              </a:rPr>
+              <a:t>0.03, TTL tắt</a:t>
+            </a:r>
+            <a:endParaRPr lang="en-US" sz="1200" dirty="0"/>
+          </a:p>
+        </p:txBody>
+      </p:sp>
+      <p:sp>
+        <p:nvSpPr>
+          <p:cNvPr id="31" name="Text 29"/>
+          <p:cNvSpPr txBox="1"/>
+          <p:nvPr/>
+        </p:nvSpPr>
+        <p:spPr>
+          <a:xfrm>
+            <a:off x="5989320" y="2779776"/>
+            <a:ext cx="1005840" cy="338328"/>
+          </a:xfrm>
+          <a:prstGeom prst="rect">
+            <a:avLst/>
+          </a:prstGeom>
+          <a:noFill/>
+          <a:ln/>
+        </p:spPr>
+        <p:txBody>
+          <a:bodyPr wrap="square" lIns="0" tIns="0" rIns="0" bIns="0" rtlCol="0" anchor="ctr"/>
+          <a:lstStyle/>
+          <a:p>
+            <a:pPr algn="ctr" indent="0" marL="0">
+              <a:buNone/>
+            </a:pPr>
+            <a:r>
+              <a:rPr lang="en-US" sz="1200" dirty="0">
+                <a:solidFill>
+                  <a:srgbClr val="F2F2F2"/>
+                </a:solidFill>
+                <a:latin typeface="Arial" pitchFamily="34" charset="0"/>
+                <a:ea typeface="Arial" pitchFamily="34" charset="-122"/>
+                <a:cs typeface="Arial" pitchFamily="34" charset="-120"/>
+              </a:rPr>
+              <a:t>+0.04</a:t>
+            </a:r>
+            <a:endParaRPr lang="en-US" sz="1200" dirty="0"/>
+          </a:p>
+        </p:txBody>
+      </p:sp>
+      <p:sp>
+        <p:nvSpPr>
+          <p:cNvPr id="32" name="Text 30"/>
+          <p:cNvSpPr txBox="1"/>
+          <p:nvPr/>
+        </p:nvSpPr>
+        <p:spPr>
+          <a:xfrm>
+            <a:off x="6995160" y="2779776"/>
+            <a:ext cx="1005840" cy="338328"/>
+          </a:xfrm>
+          <a:prstGeom prst="rect">
+            <a:avLst/>
+          </a:prstGeom>
+          <a:noFill/>
+          <a:ln/>
+        </p:spPr>
+        <p:txBody>
+          <a:bodyPr wrap="square" lIns="0" tIns="0" rIns="0" bIns="0" rtlCol="0" anchor="ctr"/>
+          <a:lstStyle/>
+          <a:p>
+            <a:pPr algn="ctr" indent="0" marL="0">
+              <a:buNone/>
+            </a:pPr>
+            <a:r>
+              <a:rPr lang="en-US" sz="1200" dirty="0">
+                <a:solidFill>
+                  <a:srgbClr val="F2F2F2"/>
+                </a:solidFill>
+                <a:latin typeface="Arial" pitchFamily="34" charset="0"/>
+                <a:ea typeface="Arial" pitchFamily="34" charset="-122"/>
+                <a:cs typeface="Arial" pitchFamily="34" charset="-120"/>
+              </a:rPr>
+              <a:t>±0.00</a:t>
+            </a:r>
+            <a:endParaRPr lang="en-US" sz="1200" dirty="0"/>
+          </a:p>
+        </p:txBody>
+      </p:sp>
+      <p:sp>
+        <p:nvSpPr>
+          <p:cNvPr id="33" name="Text 31"/>
+          <p:cNvSpPr txBox="1"/>
+          <p:nvPr/>
+        </p:nvSpPr>
+        <p:spPr>
+          <a:xfrm>
+            <a:off x="8001000" y="2779776"/>
+            <a:ext cx="960120" cy="338328"/>
+          </a:xfrm>
+          <a:prstGeom prst="rect">
+            <a:avLst/>
+          </a:prstGeom>
+          <a:noFill/>
+          <a:ln/>
+        </p:spPr>
+        <p:txBody>
+          <a:bodyPr wrap="square" lIns="0" tIns="0" rIns="0" bIns="0" rtlCol="0" anchor="ctr"/>
+          <a:lstStyle/>
+          <a:p>
+            <a:pPr algn="ctr" indent="0" marL="0">
+              <a:buNone/>
+            </a:pPr>
+            <a:r>
+              <a:rPr lang="en-US" sz="1200" dirty="0">
+                <a:solidFill>
+                  <a:srgbClr val="F2F2F2"/>
+                </a:solidFill>
+                <a:latin typeface="Arial" pitchFamily="34" charset="0"/>
+                <a:ea typeface="Arial" pitchFamily="34" charset="-122"/>
+                <a:cs typeface="Arial" pitchFamily="34" charset="-120"/>
+              </a:rPr>
+              <a:t>±0.0</a:t>
+            </a:r>
+            <a:endParaRPr lang="en-US" sz="1200" dirty="0"/>
+          </a:p>
+        </p:txBody>
+      </p:sp>
+      <p:sp>
+        <p:nvSpPr>
+          <p:cNvPr id="34" name="Text 32"/>
+          <p:cNvSpPr txBox="1"/>
+          <p:nvPr/>
+        </p:nvSpPr>
+        <p:spPr>
+          <a:xfrm>
+            <a:off x="8961120" y="2779776"/>
+            <a:ext cx="960120" cy="338328"/>
+          </a:xfrm>
+          <a:prstGeom prst="rect">
+            <a:avLst/>
+          </a:prstGeom>
+          <a:noFill/>
+          <a:ln/>
+        </p:spPr>
+        <p:txBody>
+          <a:bodyPr wrap="square" lIns="0" tIns="0" rIns="0" bIns="0" rtlCol="0" anchor="ctr"/>
+          <a:lstStyle/>
+          <a:p>
+            <a:pPr algn="ctr" indent="0" marL="0">
+              <a:buNone/>
+            </a:pPr>
+            <a:r>
+              <a:rPr lang="en-US" sz="1200" b="1" dirty="0">
+                <a:solidFill>
+                  <a:srgbClr val="F2F2F2"/>
+                </a:solidFill>
+                <a:latin typeface="Arial" pitchFamily="34" charset="0"/>
+                <a:ea typeface="Arial" pitchFamily="34" charset="-122"/>
+                <a:cs typeface="Arial" pitchFamily="34" charset="-120"/>
+              </a:rPr>
+              <a:t>+0.04</a:t>
+            </a:r>
+            <a:endParaRPr lang="en-US" sz="1200" dirty="0"/>
+          </a:p>
+        </p:txBody>
+      </p:sp>
+      <p:sp>
+        <p:nvSpPr>
+          <p:cNvPr id="35" name="Text 33"/>
+          <p:cNvSpPr txBox="1"/>
+          <p:nvPr/>
+        </p:nvSpPr>
+        <p:spPr>
+          <a:xfrm>
+            <a:off x="9921240" y="2779776"/>
+            <a:ext cx="1691640" cy="338328"/>
+          </a:xfrm>
+          <a:prstGeom prst="rect">
+            <a:avLst/>
+          </a:prstGeom>
+          <a:noFill/>
+          <a:ln/>
+        </p:spPr>
+        <p:txBody>
+          <a:bodyPr wrap="square" lIns="0" tIns="0" rIns="0" bIns="0" rtlCol="0" anchor="ctr"/>
+          <a:lstStyle/>
+          <a:p>
+            <a:pPr algn="ctr" indent="0" marL="0">
+              <a:buNone/>
+            </a:pPr>
+            <a:r>
+              <a:rPr lang="en-US" sz="1200" dirty="0">
+                <a:solidFill>
+                  <a:srgbClr val="A3A8B0"/>
+                </a:solidFill>
+                <a:latin typeface="Arial" pitchFamily="34" charset="0"/>
+                <a:ea typeface="Arial" pitchFamily="34" charset="-122"/>
+                <a:cs typeface="Arial" pitchFamily="34" charset="-120"/>
+              </a:rPr>
+              <a:t>tăng &lt; 0.5</a:t>
+            </a:r>
+            <a:endParaRPr lang="en-US" sz="1200" dirty="0"/>
+          </a:p>
+        </p:txBody>
+      </p:sp>
+      <p:sp>
+        <p:nvSpPr>
+          <p:cNvPr id="36" name="Shape 34"/>
+          <p:cNvSpPr/>
+          <p:nvPr/>
+        </p:nvSpPr>
+        <p:spPr>
+          <a:xfrm>
+            <a:off x="548640" y="3163824"/>
+            <a:ext cx="11091672" cy="338328"/>
+          </a:xfrm>
+          <a:prstGeom prst="roundRect">
+            <a:avLst>
+              <a:gd name="adj" fmla="val 32432"/>
+            </a:avLst>
+          </a:prstGeom>
+          <a:solidFill>
+            <a:srgbClr val="22252B"/>
+          </a:solidFill>
+          <a:ln w="12700">
+            <a:solidFill>
+              <a:srgbClr val="22252B"/>
+            </a:solidFill>
+            <a:prstDash val="solid"/>
+          </a:ln>
+        </p:spPr>
+      </p:sp>
+      <p:sp>
+        <p:nvSpPr>
+          <p:cNvPr id="37" name="Text 35"/>
+          <p:cNvSpPr txBox="1"/>
+          <p:nvPr/>
+        </p:nvSpPr>
+        <p:spPr>
+          <a:xfrm>
+            <a:off x="777240" y="3163824"/>
+            <a:ext cx="3200400" cy="338328"/>
+          </a:xfrm>
+          <a:prstGeom prst="rect">
+            <a:avLst/>
+          </a:prstGeom>
+          <a:noFill/>
+          <a:ln/>
+        </p:spPr>
+        <p:txBody>
+          <a:bodyPr wrap="square" lIns="0" tIns="0" rIns="0" bIns="0" rtlCol="0" anchor="ctr"/>
+          <a:lstStyle/>
+          <a:p>
+            <a:pPr algn="l" indent="0" marL="0">
+              <a:buNone/>
+            </a:pPr>
+            <a:r>
+              <a:rPr lang="en-US" sz="1300" b="1" dirty="0">
+                <a:solidFill>
+                  <a:srgbClr val="9B6EE8"/>
+                </a:solidFill>
+                <a:latin typeface="Arial" pitchFamily="34" charset="0"/>
+                <a:ea typeface="Arial" pitchFamily="34" charset="-122"/>
+                <a:cs typeface="Arial" pitchFamily="34" charset="-120"/>
+              </a:rPr>
+              <a:t>M1 · nở vùng bất định</a:t>
+            </a:r>
+            <a:endParaRPr lang="en-US" sz="1300" dirty="0"/>
+          </a:p>
+        </p:txBody>
+      </p:sp>
+      <p:sp>
+        <p:nvSpPr>
+          <p:cNvPr id="38" name="Text 36"/>
+          <p:cNvSpPr txBox="1"/>
+          <p:nvPr/>
+        </p:nvSpPr>
+        <p:spPr>
+          <a:xfrm>
+            <a:off x="3977640" y="3163824"/>
+            <a:ext cx="2011680" cy="338328"/>
+          </a:xfrm>
+          <a:prstGeom prst="rect">
+            <a:avLst/>
+          </a:prstGeom>
+          <a:noFill/>
+          <a:ln/>
+        </p:spPr>
+        <p:txBody>
+          <a:bodyPr wrap="square" lIns="0" tIns="0" rIns="0" bIns="0" rtlCol="0" anchor="ctr"/>
+          <a:lstStyle/>
+          <a:p>
+            <a:pPr algn="l" indent="0" marL="0">
+              <a:buNone/>
+            </a:pPr>
+            <a:r>
+              <a:rPr lang="en-US" sz="1200" dirty="0">
+                <a:solidFill>
+                  <a:srgbClr val="F2F2F2"/>
+                </a:solidFill>
+                <a:latin typeface="Arial" pitchFamily="34" charset="0"/>
+                <a:ea typeface="Arial" pitchFamily="34" charset="-122"/>
+                <a:cs typeface="Arial" pitchFamily="34" charset="-120"/>
+              </a:rPr>
+              <a:t>mọi giá trị: không đổi gì</a:t>
+            </a:r>
+            <a:endParaRPr lang="en-US" sz="1200" dirty="0"/>
+          </a:p>
+        </p:txBody>
+      </p:sp>
+      <p:sp>
+        <p:nvSpPr>
+          <p:cNvPr id="39" name="Text 37"/>
+          <p:cNvSpPr txBox="1"/>
+          <p:nvPr/>
+        </p:nvSpPr>
+        <p:spPr>
+          <a:xfrm>
+            <a:off x="5989320" y="3163824"/>
+            <a:ext cx="1005840" cy="338328"/>
+          </a:xfrm>
+          <a:prstGeom prst="rect">
+            <a:avLst/>
+          </a:prstGeom>
+          <a:noFill/>
+          <a:ln/>
+        </p:spPr>
+        <p:txBody>
+          <a:bodyPr wrap="square" lIns="0" tIns="0" rIns="0" bIns="0" rtlCol="0" anchor="ctr"/>
+          <a:lstStyle/>
+          <a:p>
+            <a:pPr algn="ctr" indent="0" marL="0">
+              <a:buNone/>
+            </a:pPr>
+            <a:r>
+              <a:rPr lang="en-US" sz="1200" dirty="0">
+                <a:solidFill>
+                  <a:srgbClr val="F2F2F2"/>
+                </a:solidFill>
+                <a:latin typeface="Arial" pitchFamily="34" charset="0"/>
+                <a:ea typeface="Arial" pitchFamily="34" charset="-122"/>
+                <a:cs typeface="Arial" pitchFamily="34" charset="-120"/>
+              </a:rPr>
+              <a:t>±0.00</a:t>
+            </a:r>
+            <a:endParaRPr lang="en-US" sz="1200" dirty="0"/>
+          </a:p>
+        </p:txBody>
+      </p:sp>
+      <p:sp>
+        <p:nvSpPr>
+          <p:cNvPr id="40" name="Text 38"/>
+          <p:cNvSpPr txBox="1"/>
+          <p:nvPr/>
+        </p:nvSpPr>
+        <p:spPr>
+          <a:xfrm>
+            <a:off x="6995160" y="3163824"/>
+            <a:ext cx="1005840" cy="338328"/>
+          </a:xfrm>
+          <a:prstGeom prst="rect">
+            <a:avLst/>
+          </a:prstGeom>
+          <a:noFill/>
+          <a:ln/>
+        </p:spPr>
+        <p:txBody>
+          <a:bodyPr wrap="square" lIns="0" tIns="0" rIns="0" bIns="0" rtlCol="0" anchor="ctr"/>
+          <a:lstStyle/>
+          <a:p>
+            <a:pPr algn="ctr" indent="0" marL="0">
+              <a:buNone/>
+            </a:pPr>
+            <a:r>
+              <a:rPr lang="en-US" sz="1200" dirty="0">
+                <a:solidFill>
+                  <a:srgbClr val="F2F2F2"/>
+                </a:solidFill>
+                <a:latin typeface="Arial" pitchFamily="34" charset="0"/>
+                <a:ea typeface="Arial" pitchFamily="34" charset="-122"/>
+                <a:cs typeface="Arial" pitchFamily="34" charset="-120"/>
+              </a:rPr>
+              <a:t>±0.00</a:t>
+            </a:r>
+            <a:endParaRPr lang="en-US" sz="1200" dirty="0"/>
+          </a:p>
+        </p:txBody>
+      </p:sp>
+      <p:sp>
+        <p:nvSpPr>
+          <p:cNvPr id="41" name="Text 39"/>
+          <p:cNvSpPr txBox="1"/>
+          <p:nvPr/>
+        </p:nvSpPr>
+        <p:spPr>
+          <a:xfrm>
+            <a:off x="8001000" y="3163824"/>
+            <a:ext cx="960120" cy="338328"/>
+          </a:xfrm>
+          <a:prstGeom prst="rect">
+            <a:avLst/>
+          </a:prstGeom>
+          <a:noFill/>
+          <a:ln/>
+        </p:spPr>
+        <p:txBody>
+          <a:bodyPr wrap="square" lIns="0" tIns="0" rIns="0" bIns="0" rtlCol="0" anchor="ctr"/>
+          <a:lstStyle/>
+          <a:p>
+            <a:pPr algn="ctr" indent="0" marL="0">
+              <a:buNone/>
+            </a:pPr>
+            <a:r>
+              <a:rPr lang="en-US" sz="1200" dirty="0">
+                <a:solidFill>
+                  <a:srgbClr val="F2F2F2"/>
+                </a:solidFill>
+                <a:latin typeface="Arial" pitchFamily="34" charset="0"/>
+                <a:ea typeface="Arial" pitchFamily="34" charset="-122"/>
+                <a:cs typeface="Arial" pitchFamily="34" charset="-120"/>
+              </a:rPr>
+              <a:t>±0.0</a:t>
+            </a:r>
+            <a:endParaRPr lang="en-US" sz="1200" dirty="0"/>
+          </a:p>
+        </p:txBody>
+      </p:sp>
+      <p:sp>
+        <p:nvSpPr>
+          <p:cNvPr id="42" name="Text 40"/>
+          <p:cNvSpPr txBox="1"/>
+          <p:nvPr/>
+        </p:nvSpPr>
+        <p:spPr>
+          <a:xfrm>
+            <a:off x="8961120" y="3163824"/>
+            <a:ext cx="960120" cy="338328"/>
+          </a:xfrm>
+          <a:prstGeom prst="rect">
+            <a:avLst/>
+          </a:prstGeom>
+          <a:noFill/>
+          <a:ln/>
+        </p:spPr>
+        <p:txBody>
+          <a:bodyPr wrap="square" lIns="0" tIns="0" rIns="0" bIns="0" rtlCol="0" anchor="ctr"/>
+          <a:lstStyle/>
+          <a:p>
+            <a:pPr algn="ctr" indent="0" marL="0">
+              <a:buNone/>
+            </a:pPr>
+            <a:r>
+              <a:rPr lang="en-US" sz="1200" b="1" dirty="0">
+                <a:solidFill>
+                  <a:srgbClr val="F2F2F2"/>
+                </a:solidFill>
+                <a:latin typeface="Arial" pitchFamily="34" charset="0"/>
+                <a:ea typeface="Arial" pitchFamily="34" charset="-122"/>
+                <a:cs typeface="Arial" pitchFamily="34" charset="-120"/>
+              </a:rPr>
+              <a:t>±0.00</a:t>
+            </a:r>
+            <a:endParaRPr lang="en-US" sz="1200" dirty="0"/>
+          </a:p>
+        </p:txBody>
+      </p:sp>
+      <p:sp>
+        <p:nvSpPr>
+          <p:cNvPr id="43" name="Text 41"/>
+          <p:cNvSpPr txBox="1"/>
+          <p:nvPr/>
+        </p:nvSpPr>
+        <p:spPr>
+          <a:xfrm>
+            <a:off x="9921240" y="3163824"/>
+            <a:ext cx="1691640" cy="338328"/>
+          </a:xfrm>
+          <a:prstGeom prst="rect">
+            <a:avLst/>
+          </a:prstGeom>
+          <a:noFill/>
+          <a:ln/>
+        </p:spPr>
+        <p:txBody>
+          <a:bodyPr wrap="square" lIns="0" tIns="0" rIns="0" bIns="0" rtlCol="0" anchor="ctr"/>
+          <a:lstStyle/>
+          <a:p>
+            <a:pPr algn="ctr" indent="0" marL="0">
+              <a:buNone/>
+            </a:pPr>
+            <a:r>
+              <a:rPr lang="en-US" sz="1200" dirty="0">
+                <a:solidFill>
+                  <a:srgbClr val="A3A8B0"/>
+                </a:solidFill>
+                <a:latin typeface="Arial" pitchFamily="34" charset="0"/>
+                <a:ea typeface="Arial" pitchFamily="34" charset="-122"/>
+                <a:cs typeface="Arial" pitchFamily="34" charset="-120"/>
+              </a:rPr>
+              <a:t>tăng &lt; 0.5</a:t>
+            </a:r>
+            <a:endParaRPr lang="en-US" sz="1200" dirty="0"/>
+          </a:p>
+        </p:txBody>
+      </p:sp>
+      <p:sp>
+        <p:nvSpPr>
+          <p:cNvPr id="44" name="Shape 42"/>
+          <p:cNvSpPr/>
+          <p:nvPr/>
+        </p:nvSpPr>
+        <p:spPr>
+          <a:xfrm>
+            <a:off x="548640" y="3547872"/>
+            <a:ext cx="11091672" cy="338328"/>
+          </a:xfrm>
+          <a:prstGeom prst="roundRect">
+            <a:avLst>
+              <a:gd name="adj" fmla="val 32432"/>
+            </a:avLst>
+          </a:prstGeom>
+          <a:solidFill>
+            <a:srgbClr val="22252B"/>
+          </a:solidFill>
+          <a:ln w="12700">
+            <a:solidFill>
+              <a:srgbClr val="22252B"/>
+            </a:solidFill>
+            <a:prstDash val="solid"/>
+          </a:ln>
+        </p:spPr>
+      </p:sp>
+      <p:sp>
+        <p:nvSpPr>
+          <p:cNvPr id="45" name="Text 43"/>
+          <p:cNvSpPr txBox="1"/>
+          <p:nvPr/>
+        </p:nvSpPr>
+        <p:spPr>
+          <a:xfrm>
+            <a:off x="777240" y="3547872"/>
+            <a:ext cx="3200400" cy="338328"/>
+          </a:xfrm>
+          <a:prstGeom prst="rect">
+            <a:avLst/>
+          </a:prstGeom>
+          <a:noFill/>
+          <a:ln/>
+        </p:spPr>
+        <p:txBody>
+          <a:bodyPr wrap="square" lIns="0" tIns="0" rIns="0" bIns="0" rtlCol="0" anchor="ctr"/>
+          <a:lstStyle/>
+          <a:p>
+            <a:pPr algn="l" indent="0" marL="0">
+              <a:buNone/>
+            </a:pPr>
+            <a:r>
+              <a:rPr lang="en-US" sz="1300" b="1" dirty="0">
+                <a:solidFill>
+                  <a:srgbClr val="9B6EE8"/>
+                </a:solidFill>
+                <a:latin typeface="Arial" pitchFamily="34" charset="0"/>
+                <a:ea typeface="Arial" pitchFamily="34" charset="-122"/>
+                <a:cs typeface="Arial" pitchFamily="34" charset="-120"/>
+              </a:rPr>
+              <a:t>M2 · Re-ID</a:t>
+            </a:r>
+            <a:endParaRPr lang="en-US" sz="1300" dirty="0"/>
+          </a:p>
+        </p:txBody>
+      </p:sp>
+      <p:sp>
+        <p:nvSpPr>
+          <p:cNvPr id="46" name="Text 44"/>
+          <p:cNvSpPr txBox="1"/>
+          <p:nvPr/>
+        </p:nvSpPr>
+        <p:spPr>
+          <a:xfrm>
+            <a:off x="3977640" y="3547872"/>
+            <a:ext cx="2011680" cy="338328"/>
+          </a:xfrm>
+          <a:prstGeom prst="rect">
+            <a:avLst/>
+          </a:prstGeom>
+          <a:noFill/>
+          <a:ln/>
+        </p:spPr>
+        <p:txBody>
+          <a:bodyPr wrap="square" lIns="0" tIns="0" rIns="0" bIns="0" rtlCol="0" anchor="ctr"/>
+          <a:lstStyle/>
+          <a:p>
+            <a:pPr algn="l" indent="0" marL="0">
+              <a:buNone/>
+            </a:pPr>
+            <a:r>
+              <a:rPr lang="en-US" sz="1200" dirty="0">
+                <a:solidFill>
+                  <a:srgbClr val="F2F2F2"/>
+                </a:solidFill>
+                <a:latin typeface="Arial" pitchFamily="34" charset="0"/>
+                <a:ea typeface="Arial" pitchFamily="34" charset="-122"/>
+                <a:cs typeface="Arial" pitchFamily="34" charset="-120"/>
+              </a:rPr>
+              <a:t>mọi giá trị: không đổi gì</a:t>
+            </a:r>
+            <a:endParaRPr lang="en-US" sz="1200" dirty="0"/>
+          </a:p>
+        </p:txBody>
+      </p:sp>
+      <p:sp>
+        <p:nvSpPr>
+          <p:cNvPr id="47" name="Text 45"/>
+          <p:cNvSpPr txBox="1"/>
+          <p:nvPr/>
+        </p:nvSpPr>
+        <p:spPr>
+          <a:xfrm>
+            <a:off x="5989320" y="3547872"/>
+            <a:ext cx="1005840" cy="338328"/>
+          </a:xfrm>
+          <a:prstGeom prst="rect">
+            <a:avLst/>
+          </a:prstGeom>
+          <a:noFill/>
+          <a:ln/>
+        </p:spPr>
+        <p:txBody>
+          <a:bodyPr wrap="square" lIns="0" tIns="0" rIns="0" bIns="0" rtlCol="0" anchor="ctr"/>
+          <a:lstStyle/>
+          <a:p>
+            <a:pPr algn="ctr" indent="0" marL="0">
+              <a:buNone/>
+            </a:pPr>
+            <a:r>
+              <a:rPr lang="en-US" sz="1200" dirty="0">
+                <a:solidFill>
+                  <a:srgbClr val="F2F2F2"/>
+                </a:solidFill>
+                <a:latin typeface="Arial" pitchFamily="34" charset="0"/>
+                <a:ea typeface="Arial" pitchFamily="34" charset="-122"/>
+                <a:cs typeface="Arial" pitchFamily="34" charset="-120"/>
+              </a:rPr>
+              <a:t>±0.00</a:t>
+            </a:r>
+            <a:endParaRPr lang="en-US" sz="1200" dirty="0"/>
+          </a:p>
+        </p:txBody>
+      </p:sp>
+      <p:sp>
+        <p:nvSpPr>
+          <p:cNvPr id="48" name="Text 46"/>
+          <p:cNvSpPr txBox="1"/>
+          <p:nvPr/>
+        </p:nvSpPr>
+        <p:spPr>
+          <a:xfrm>
+            <a:off x="6995160" y="3547872"/>
+            <a:ext cx="1005840" cy="338328"/>
+          </a:xfrm>
+          <a:prstGeom prst="rect">
+            <a:avLst/>
+          </a:prstGeom>
+          <a:noFill/>
+          <a:ln/>
+        </p:spPr>
+        <p:txBody>
+          <a:bodyPr wrap="square" lIns="0" tIns="0" rIns="0" bIns="0" rtlCol="0" anchor="ctr"/>
+          <a:lstStyle/>
+          <a:p>
+            <a:pPr algn="ctr" indent="0" marL="0">
+              <a:buNone/>
+            </a:pPr>
+            <a:r>
+              <a:rPr lang="en-US" sz="1200" dirty="0">
+                <a:solidFill>
+                  <a:srgbClr val="F2F2F2"/>
+                </a:solidFill>
+                <a:latin typeface="Arial" pitchFamily="34" charset="0"/>
+                <a:ea typeface="Arial" pitchFamily="34" charset="-122"/>
+                <a:cs typeface="Arial" pitchFamily="34" charset="-120"/>
+              </a:rPr>
+              <a:t>±0.00</a:t>
+            </a:r>
+            <a:endParaRPr lang="en-US" sz="1200" dirty="0"/>
+          </a:p>
+        </p:txBody>
+      </p:sp>
+      <p:sp>
+        <p:nvSpPr>
+          <p:cNvPr id="49" name="Text 47"/>
+          <p:cNvSpPr txBox="1"/>
+          <p:nvPr/>
+        </p:nvSpPr>
+        <p:spPr>
+          <a:xfrm>
+            <a:off x="8001000" y="3547872"/>
+            <a:ext cx="960120" cy="338328"/>
+          </a:xfrm>
+          <a:prstGeom prst="rect">
+            <a:avLst/>
+          </a:prstGeom>
+          <a:noFill/>
+          <a:ln/>
+        </p:spPr>
+        <p:txBody>
+          <a:bodyPr wrap="square" lIns="0" tIns="0" rIns="0" bIns="0" rtlCol="0" anchor="ctr"/>
+          <a:lstStyle/>
+          <a:p>
+            <a:pPr algn="ctr" indent="0" marL="0">
+              <a:buNone/>
+            </a:pPr>
+            <a:r>
+              <a:rPr lang="en-US" sz="1200" dirty="0">
+                <a:solidFill>
+                  <a:srgbClr val="F2F2F2"/>
+                </a:solidFill>
+                <a:latin typeface="Arial" pitchFamily="34" charset="0"/>
+                <a:ea typeface="Arial" pitchFamily="34" charset="-122"/>
+                <a:cs typeface="Arial" pitchFamily="34" charset="-120"/>
+              </a:rPr>
+              <a:t>±0.0</a:t>
+            </a:r>
+            <a:endParaRPr lang="en-US" sz="1200" dirty="0"/>
+          </a:p>
+        </p:txBody>
+      </p:sp>
+      <p:sp>
+        <p:nvSpPr>
+          <p:cNvPr id="50" name="Text 48"/>
+          <p:cNvSpPr txBox="1"/>
+          <p:nvPr/>
+        </p:nvSpPr>
+        <p:spPr>
+          <a:xfrm>
+            <a:off x="8961120" y="3547872"/>
+            <a:ext cx="960120" cy="338328"/>
+          </a:xfrm>
+          <a:prstGeom prst="rect">
+            <a:avLst/>
+          </a:prstGeom>
+          <a:noFill/>
+          <a:ln/>
+        </p:spPr>
+        <p:txBody>
+          <a:bodyPr wrap="square" lIns="0" tIns="0" rIns="0" bIns="0" rtlCol="0" anchor="ctr"/>
+          <a:lstStyle/>
+          <a:p>
+            <a:pPr algn="ctr" indent="0" marL="0">
+              <a:buNone/>
+            </a:pPr>
+            <a:r>
+              <a:rPr lang="en-US" sz="1200" b="1" dirty="0">
+                <a:solidFill>
+                  <a:srgbClr val="F2F2F2"/>
+                </a:solidFill>
+                <a:latin typeface="Arial" pitchFamily="34" charset="0"/>
+                <a:ea typeface="Arial" pitchFamily="34" charset="-122"/>
+                <a:cs typeface="Arial" pitchFamily="34" charset="-120"/>
+              </a:rPr>
+              <a:t>±0.00</a:t>
+            </a:r>
+            <a:endParaRPr lang="en-US" sz="1200" dirty="0"/>
+          </a:p>
+        </p:txBody>
+      </p:sp>
+      <p:sp>
+        <p:nvSpPr>
+          <p:cNvPr id="51" name="Text 49"/>
+          <p:cNvSpPr txBox="1"/>
+          <p:nvPr/>
+        </p:nvSpPr>
+        <p:spPr>
+          <a:xfrm>
+            <a:off x="9921240" y="3547872"/>
+            <a:ext cx="1691640" cy="338328"/>
+          </a:xfrm>
+          <a:prstGeom prst="rect">
+            <a:avLst/>
+          </a:prstGeom>
+          <a:noFill/>
+          <a:ln/>
+        </p:spPr>
+        <p:txBody>
+          <a:bodyPr wrap="square" lIns="0" tIns="0" rIns="0" bIns="0" rtlCol="0" anchor="ctr"/>
+          <a:lstStyle/>
+          <a:p>
+            <a:pPr algn="ctr" indent="0" marL="0">
+              <a:buNone/>
+            </a:pPr>
+            <a:r>
+              <a:rPr lang="en-US" sz="1200" dirty="0">
+                <a:solidFill>
+                  <a:srgbClr val="A3A8B0"/>
+                </a:solidFill>
+                <a:latin typeface="Arial" pitchFamily="34" charset="0"/>
+                <a:ea typeface="Arial" pitchFamily="34" charset="-122"/>
+                <a:cs typeface="Arial" pitchFamily="34" charset="-120"/>
+              </a:rPr>
+              <a:t>tăng &lt; 0.5</a:t>
+            </a:r>
+            <a:endParaRPr lang="en-US" sz="1200" dirty="0"/>
+          </a:p>
+        </p:txBody>
+      </p:sp>
+      <p:sp>
+        <p:nvSpPr>
+          <p:cNvPr id="52" name="Shape 50"/>
+          <p:cNvSpPr/>
+          <p:nvPr/>
+        </p:nvSpPr>
+        <p:spPr>
+          <a:xfrm>
+            <a:off x="548640" y="3931920"/>
+            <a:ext cx="11091672" cy="338328"/>
+          </a:xfrm>
+          <a:prstGeom prst="roundRect">
+            <a:avLst>
+              <a:gd name="adj" fmla="val 32432"/>
+            </a:avLst>
+          </a:prstGeom>
+          <a:solidFill>
+            <a:srgbClr val="22252B"/>
+          </a:solidFill>
+          <a:ln w="12700">
+            <a:solidFill>
+              <a:srgbClr val="22252B"/>
+            </a:solidFill>
+            <a:prstDash val="solid"/>
+          </a:ln>
+        </p:spPr>
+      </p:sp>
+      <p:sp>
+        <p:nvSpPr>
+          <p:cNvPr id="53" name="Text 51"/>
+          <p:cNvSpPr txBox="1"/>
+          <p:nvPr/>
+        </p:nvSpPr>
+        <p:spPr>
+          <a:xfrm>
+            <a:off x="777240" y="3931920"/>
+            <a:ext cx="3200400" cy="338328"/>
+          </a:xfrm>
+          <a:prstGeom prst="rect">
+            <a:avLst/>
+          </a:prstGeom>
+          <a:noFill/>
+          <a:ln/>
+        </p:spPr>
+        <p:txBody>
+          <a:bodyPr wrap="square" lIns="0" tIns="0" rIns="0" bIns="0" rtlCol="0" anchor="ctr"/>
+          <a:lstStyle/>
+          <a:p>
+            <a:pPr algn="l" indent="0" marL="0">
+              <a:buNone/>
+            </a:pPr>
+            <a:r>
+              <a:rPr lang="en-US" sz="1300" b="1" dirty="0">
+                <a:solidFill>
+                  <a:srgbClr val="9B6EE8"/>
+                </a:solidFill>
+                <a:latin typeface="Arial" pitchFamily="34" charset="0"/>
+                <a:ea typeface="Arial" pitchFamily="34" charset="-122"/>
+                <a:cs typeface="Arial" pitchFamily="34" charset="-120"/>
+              </a:rPr>
+              <a:t>M4 · pool track ngủ</a:t>
+            </a:r>
+            <a:endParaRPr lang="en-US" sz="1300" dirty="0"/>
+          </a:p>
+        </p:txBody>
+      </p:sp>
+      <p:sp>
+        <p:nvSpPr>
+          <p:cNvPr id="54" name="Text 52"/>
+          <p:cNvSpPr txBox="1"/>
+          <p:nvPr/>
+        </p:nvSpPr>
+        <p:spPr>
+          <a:xfrm>
+            <a:off x="3977640" y="3931920"/>
+            <a:ext cx="2011680" cy="338328"/>
+          </a:xfrm>
+          <a:prstGeom prst="rect">
+            <a:avLst/>
+          </a:prstGeom>
+          <a:noFill/>
+          <a:ln/>
+        </p:spPr>
+        <p:txBody>
+          <a:bodyPr wrap="square" lIns="0" tIns="0" rIns="0" bIns="0" rtlCol="0" anchor="ctr"/>
+          <a:lstStyle/>
+          <a:p>
+            <a:pPr algn="l" indent="0" marL="0">
+              <a:buNone/>
+            </a:pPr>
+            <a:r>
+              <a:rPr lang="en-US" sz="1200" dirty="0">
+                <a:solidFill>
+                  <a:srgbClr val="F2F2F2"/>
+                </a:solidFill>
+                <a:latin typeface="Arial" pitchFamily="34" charset="0"/>
+                <a:ea typeface="Arial" pitchFamily="34" charset="-122"/>
+                <a:cs typeface="Arial" pitchFamily="34" charset="-120"/>
+              </a:rPr>
+              <a:t>mọi giá trị: không đổi gì</a:t>
+            </a:r>
+            <a:endParaRPr lang="en-US" sz="1200" dirty="0"/>
+          </a:p>
+        </p:txBody>
+      </p:sp>
+      <p:sp>
+        <p:nvSpPr>
+          <p:cNvPr id="55" name="Text 53"/>
+          <p:cNvSpPr txBox="1"/>
+          <p:nvPr/>
+        </p:nvSpPr>
+        <p:spPr>
+          <a:xfrm>
+            <a:off x="5989320" y="3931920"/>
+            <a:ext cx="1005840" cy="338328"/>
+          </a:xfrm>
+          <a:prstGeom prst="rect">
+            <a:avLst/>
+          </a:prstGeom>
+          <a:noFill/>
+          <a:ln/>
+        </p:spPr>
+        <p:txBody>
+          <a:bodyPr wrap="square" lIns="0" tIns="0" rIns="0" bIns="0" rtlCol="0" anchor="ctr"/>
+          <a:lstStyle/>
+          <a:p>
+            <a:pPr algn="ctr" indent="0" marL="0">
+              <a:buNone/>
+            </a:pPr>
+            <a:r>
+              <a:rPr lang="en-US" sz="1200" dirty="0">
+                <a:solidFill>
+                  <a:srgbClr val="F2F2F2"/>
+                </a:solidFill>
+                <a:latin typeface="Arial" pitchFamily="34" charset="0"/>
+                <a:ea typeface="Arial" pitchFamily="34" charset="-122"/>
+                <a:cs typeface="Arial" pitchFamily="34" charset="-120"/>
+              </a:rPr>
+              <a:t>±0.00</a:t>
+            </a:r>
+            <a:endParaRPr lang="en-US" sz="1200" dirty="0"/>
+          </a:p>
+        </p:txBody>
+      </p:sp>
+      <p:sp>
+        <p:nvSpPr>
+          <p:cNvPr id="56" name="Text 54"/>
+          <p:cNvSpPr txBox="1"/>
+          <p:nvPr/>
+        </p:nvSpPr>
+        <p:spPr>
+          <a:xfrm>
+            <a:off x="6995160" y="3931920"/>
+            <a:ext cx="1005840" cy="338328"/>
+          </a:xfrm>
+          <a:prstGeom prst="rect">
+            <a:avLst/>
+          </a:prstGeom>
+          <a:noFill/>
+          <a:ln/>
+        </p:spPr>
+        <p:txBody>
+          <a:bodyPr wrap="square" lIns="0" tIns="0" rIns="0" bIns="0" rtlCol="0" anchor="ctr"/>
+          <a:lstStyle/>
+          <a:p>
+            <a:pPr algn="ctr" indent="0" marL="0">
+              <a:buNone/>
+            </a:pPr>
+            <a:r>
+              <a:rPr lang="en-US" sz="1200" dirty="0">
+                <a:solidFill>
+                  <a:srgbClr val="F2F2F2"/>
+                </a:solidFill>
+                <a:latin typeface="Arial" pitchFamily="34" charset="0"/>
+                <a:ea typeface="Arial" pitchFamily="34" charset="-122"/>
+                <a:cs typeface="Arial" pitchFamily="34" charset="-120"/>
+              </a:rPr>
+              <a:t>±0.00</a:t>
+            </a:r>
+            <a:endParaRPr lang="en-US" sz="1200" dirty="0"/>
+          </a:p>
+        </p:txBody>
+      </p:sp>
+      <p:sp>
+        <p:nvSpPr>
+          <p:cNvPr id="57" name="Text 55"/>
+          <p:cNvSpPr txBox="1"/>
+          <p:nvPr/>
+        </p:nvSpPr>
+        <p:spPr>
+          <a:xfrm>
+            <a:off x="8001000" y="3931920"/>
+            <a:ext cx="960120" cy="338328"/>
+          </a:xfrm>
+          <a:prstGeom prst="rect">
+            <a:avLst/>
+          </a:prstGeom>
+          <a:noFill/>
+          <a:ln/>
+        </p:spPr>
+        <p:txBody>
+          <a:bodyPr wrap="square" lIns="0" tIns="0" rIns="0" bIns="0" rtlCol="0" anchor="ctr"/>
+          <a:lstStyle/>
+          <a:p>
+            <a:pPr algn="ctr" indent="0" marL="0">
+              <a:buNone/>
+            </a:pPr>
+            <a:r>
+              <a:rPr lang="en-US" sz="1200" dirty="0">
+                <a:solidFill>
+                  <a:srgbClr val="F2F2F2"/>
+                </a:solidFill>
+                <a:latin typeface="Arial" pitchFamily="34" charset="0"/>
+                <a:ea typeface="Arial" pitchFamily="34" charset="-122"/>
+                <a:cs typeface="Arial" pitchFamily="34" charset="-120"/>
+              </a:rPr>
+              <a:t>±0.0</a:t>
+            </a:r>
+            <a:endParaRPr lang="en-US" sz="1200" dirty="0"/>
+          </a:p>
+        </p:txBody>
+      </p:sp>
+      <p:sp>
+        <p:nvSpPr>
+          <p:cNvPr id="58" name="Text 56"/>
+          <p:cNvSpPr txBox="1"/>
+          <p:nvPr/>
+        </p:nvSpPr>
+        <p:spPr>
+          <a:xfrm>
+            <a:off x="8961120" y="3931920"/>
+            <a:ext cx="960120" cy="338328"/>
+          </a:xfrm>
+          <a:prstGeom prst="rect">
+            <a:avLst/>
+          </a:prstGeom>
+          <a:noFill/>
+          <a:ln/>
+        </p:spPr>
+        <p:txBody>
+          <a:bodyPr wrap="square" lIns="0" tIns="0" rIns="0" bIns="0" rtlCol="0" anchor="ctr"/>
+          <a:lstStyle/>
+          <a:p>
+            <a:pPr algn="ctr" indent="0" marL="0">
+              <a:buNone/>
+            </a:pPr>
+            <a:r>
+              <a:rPr lang="en-US" sz="1200" b="1" dirty="0">
+                <a:solidFill>
+                  <a:srgbClr val="F2F2F2"/>
+                </a:solidFill>
+                <a:latin typeface="Arial" pitchFamily="34" charset="0"/>
+                <a:ea typeface="Arial" pitchFamily="34" charset="-122"/>
+                <a:cs typeface="Arial" pitchFamily="34" charset="-120"/>
+              </a:rPr>
+              <a:t>±0.00</a:t>
+            </a:r>
+            <a:endParaRPr lang="en-US" sz="1200" dirty="0"/>
+          </a:p>
+        </p:txBody>
+      </p:sp>
+      <p:sp>
+        <p:nvSpPr>
+          <p:cNvPr id="59" name="Text 57"/>
+          <p:cNvSpPr txBox="1"/>
+          <p:nvPr/>
+        </p:nvSpPr>
+        <p:spPr>
+          <a:xfrm>
+            <a:off x="9921240" y="3931920"/>
+            <a:ext cx="1691640" cy="338328"/>
+          </a:xfrm>
+          <a:prstGeom prst="rect">
+            <a:avLst/>
+          </a:prstGeom>
+          <a:noFill/>
+          <a:ln/>
+        </p:spPr>
+        <p:txBody>
+          <a:bodyPr wrap="square" lIns="0" tIns="0" rIns="0" bIns="0" rtlCol="0" anchor="ctr"/>
+          <a:lstStyle/>
+          <a:p>
+            <a:pPr algn="ctr" indent="0" marL="0">
+              <a:buNone/>
+            </a:pPr>
+            <a:r>
+              <a:rPr lang="en-US" sz="1200" dirty="0">
+                <a:solidFill>
+                  <a:srgbClr val="A3A8B0"/>
+                </a:solidFill>
+                <a:latin typeface="Arial" pitchFamily="34" charset="0"/>
+                <a:ea typeface="Arial" pitchFamily="34" charset="-122"/>
+                <a:cs typeface="Arial" pitchFamily="34" charset="-120"/>
+              </a:rPr>
+              <a:t>tăng &lt; 0.5</a:t>
+            </a:r>
+            <a:endParaRPr lang="en-US" sz="1200" dirty="0"/>
+          </a:p>
+        </p:txBody>
+      </p:sp>
+      <p:sp>
+        <p:nvSpPr>
+          <p:cNvPr id="60" name="Shape 58"/>
+          <p:cNvSpPr/>
+          <p:nvPr/>
+        </p:nvSpPr>
+        <p:spPr>
+          <a:xfrm>
+            <a:off x="548640" y="4315968"/>
+            <a:ext cx="11091672" cy="338328"/>
+          </a:xfrm>
+          <a:prstGeom prst="roundRect">
+            <a:avLst>
+              <a:gd name="adj" fmla="val 32432"/>
+            </a:avLst>
+          </a:prstGeom>
+          <a:solidFill>
+            <a:srgbClr val="22252B"/>
+          </a:solidFill>
+          <a:ln w="12700">
+            <a:solidFill>
+              <a:srgbClr val="22252B"/>
+            </a:solidFill>
+            <a:prstDash val="solid"/>
+          </a:ln>
+        </p:spPr>
+      </p:sp>
+      <p:sp>
+        <p:nvSpPr>
+          <p:cNvPr id="61" name="Text 59"/>
+          <p:cNvSpPr txBox="1"/>
+          <p:nvPr/>
+        </p:nvSpPr>
+        <p:spPr>
+          <a:xfrm>
+            <a:off x="777240" y="4315968"/>
+            <a:ext cx="3200400" cy="338328"/>
+          </a:xfrm>
+          <a:prstGeom prst="rect">
+            <a:avLst/>
+          </a:prstGeom>
+          <a:noFill/>
+          <a:ln/>
+        </p:spPr>
+        <p:txBody>
+          <a:bodyPr wrap="square" lIns="0" tIns="0" rIns="0" bIns="0" rtlCol="0" anchor="ctr"/>
+          <a:lstStyle/>
+          <a:p>
+            <a:pPr algn="l" indent="0" marL="0">
+              <a:buNone/>
+            </a:pPr>
+            <a:r>
+              <a:rPr lang="en-US" sz="1300" b="1" dirty="0">
+                <a:solidFill>
+                  <a:srgbClr val="9B6EE8"/>
+                </a:solidFill>
+                <a:latin typeface="Arial" pitchFamily="34" charset="0"/>
+                <a:ea typeface="Arial" pitchFamily="34" charset="-122"/>
+                <a:cs typeface="Arial" pitchFamily="34" charset="-120"/>
+              </a:rPr>
+              <a:t>M5 · neo đèn</a:t>
+            </a:r>
+            <a:endParaRPr lang="en-US" sz="1300" dirty="0"/>
+          </a:p>
+        </p:txBody>
+      </p:sp>
+      <p:sp>
+        <p:nvSpPr>
+          <p:cNvPr id="62" name="Text 60"/>
+          <p:cNvSpPr txBox="1"/>
+          <p:nvPr/>
+        </p:nvSpPr>
+        <p:spPr>
+          <a:xfrm>
+            <a:off x="3977640" y="4315968"/>
+            <a:ext cx="2011680" cy="338328"/>
+          </a:xfrm>
+          <a:prstGeom prst="rect">
+            <a:avLst/>
+          </a:prstGeom>
+          <a:noFill/>
+          <a:ln/>
+        </p:spPr>
+        <p:txBody>
+          <a:bodyPr wrap="square" lIns="0" tIns="0" rIns="0" bIns="0" rtlCol="0" anchor="ctr"/>
+          <a:lstStyle/>
+          <a:p>
+            <a:pPr algn="l" indent="0" marL="0">
+              <a:buNone/>
+            </a:pPr>
+            <a:r>
+              <a:rPr lang="en-US" sz="1200" dirty="0">
+                <a:solidFill>
+                  <a:srgbClr val="F2F2F2"/>
+                </a:solidFill>
+                <a:latin typeface="Arial" pitchFamily="34" charset="0"/>
+                <a:ea typeface="Arial" pitchFamily="34" charset="-122"/>
+                <a:cs typeface="Arial" pitchFamily="34" charset="-120"/>
+              </a:rPr>
+              <a:t>R ×96</a:t>
+            </a:r>
+            <a:endParaRPr lang="en-US" sz="1200" dirty="0"/>
+          </a:p>
+        </p:txBody>
+      </p:sp>
+      <p:sp>
+        <p:nvSpPr>
+          <p:cNvPr id="63" name="Text 61"/>
+          <p:cNvSpPr txBox="1"/>
+          <p:nvPr/>
+        </p:nvSpPr>
+        <p:spPr>
+          <a:xfrm>
+            <a:off x="5989320" y="4315968"/>
+            <a:ext cx="1005840" cy="338328"/>
+          </a:xfrm>
+          <a:prstGeom prst="rect">
+            <a:avLst/>
+          </a:prstGeom>
+          <a:noFill/>
+          <a:ln/>
+        </p:spPr>
+        <p:txBody>
+          <a:bodyPr wrap="square" lIns="0" tIns="0" rIns="0" bIns="0" rtlCol="0" anchor="ctr"/>
+          <a:lstStyle/>
+          <a:p>
+            <a:pPr algn="ctr" indent="0" marL="0">
+              <a:buNone/>
+            </a:pPr>
+            <a:r>
+              <a:rPr lang="en-US" sz="1200" dirty="0">
+                <a:solidFill>
+                  <a:srgbClr val="F2F2F2"/>
+                </a:solidFill>
+                <a:latin typeface="Arial" pitchFamily="34" charset="0"/>
+                <a:ea typeface="Arial" pitchFamily="34" charset="-122"/>
+                <a:cs typeface="Arial" pitchFamily="34" charset="-120"/>
+              </a:rPr>
+              <a:t>+0.02</a:t>
+            </a:r>
+            <a:endParaRPr lang="en-US" sz="1200" dirty="0"/>
+          </a:p>
+        </p:txBody>
+      </p:sp>
+      <p:sp>
+        <p:nvSpPr>
+          <p:cNvPr id="64" name="Text 62"/>
+          <p:cNvSpPr txBox="1"/>
+          <p:nvPr/>
+        </p:nvSpPr>
+        <p:spPr>
+          <a:xfrm>
+            <a:off x="6995160" y="4315968"/>
+            <a:ext cx="1005840" cy="338328"/>
+          </a:xfrm>
+          <a:prstGeom prst="rect">
+            <a:avLst/>
+          </a:prstGeom>
+          <a:noFill/>
+          <a:ln/>
+        </p:spPr>
+        <p:txBody>
+          <a:bodyPr wrap="square" lIns="0" tIns="0" rIns="0" bIns="0" rtlCol="0" anchor="ctr"/>
+          <a:lstStyle/>
+          <a:p>
+            <a:pPr algn="ctr" indent="0" marL="0">
+              <a:buNone/>
+            </a:pPr>
+            <a:r>
+              <a:rPr lang="en-US" sz="1200" dirty="0">
+                <a:solidFill>
+                  <a:srgbClr val="E66767"/>
+                </a:solidFill>
+                <a:latin typeface="Arial" pitchFamily="34" charset="0"/>
+                <a:ea typeface="Arial" pitchFamily="34" charset="-122"/>
+                <a:cs typeface="Arial" pitchFamily="34" charset="-120"/>
+              </a:rPr>
+              <a:t>−0.07</a:t>
+            </a:r>
+            <a:endParaRPr lang="en-US" sz="1200" dirty="0"/>
+          </a:p>
+        </p:txBody>
+      </p:sp>
+      <p:sp>
+        <p:nvSpPr>
+          <p:cNvPr id="65" name="Text 63"/>
+          <p:cNvSpPr txBox="1"/>
+          <p:nvPr/>
+        </p:nvSpPr>
+        <p:spPr>
+          <a:xfrm>
+            <a:off x="8001000" y="4315968"/>
+            <a:ext cx="960120" cy="338328"/>
+          </a:xfrm>
+          <a:prstGeom prst="rect">
+            <a:avLst/>
+          </a:prstGeom>
+          <a:noFill/>
+          <a:ln/>
+        </p:spPr>
+        <p:txBody>
+          <a:bodyPr wrap="square" lIns="0" tIns="0" rIns="0" bIns="0" rtlCol="0" anchor="ctr"/>
+          <a:lstStyle/>
+          <a:p>
+            <a:pPr algn="ctr" indent="0" marL="0">
+              <a:buNone/>
+            </a:pPr>
+            <a:r>
+              <a:rPr lang="en-US" sz="1200" dirty="0">
+                <a:solidFill>
+                  <a:srgbClr val="E66767"/>
+                </a:solidFill>
+                <a:latin typeface="Arial" pitchFamily="34" charset="0"/>
+                <a:ea typeface="Arial" pitchFamily="34" charset="-122"/>
+                <a:cs typeface="Arial" pitchFamily="34" charset="-120"/>
+              </a:rPr>
+              <a:t>−0.2</a:t>
+            </a:r>
+            <a:endParaRPr lang="en-US" sz="1200" dirty="0"/>
+          </a:p>
+        </p:txBody>
+      </p:sp>
+      <p:sp>
+        <p:nvSpPr>
+          <p:cNvPr id="66" name="Text 64"/>
+          <p:cNvSpPr txBox="1"/>
+          <p:nvPr/>
+        </p:nvSpPr>
+        <p:spPr>
+          <a:xfrm>
+            <a:off x="8961120" y="4315968"/>
+            <a:ext cx="960120" cy="338328"/>
+          </a:xfrm>
+          <a:prstGeom prst="rect">
+            <a:avLst/>
+          </a:prstGeom>
+          <a:noFill/>
+          <a:ln/>
+        </p:spPr>
+        <p:txBody>
+          <a:bodyPr wrap="square" lIns="0" tIns="0" rIns="0" bIns="0" rtlCol="0" anchor="ctr"/>
+          <a:lstStyle/>
+          <a:p>
+            <a:pPr algn="ctr" indent="0" marL="0">
+              <a:buNone/>
+            </a:pPr>
+            <a:r>
+              <a:rPr lang="en-US" sz="1200" b="1" dirty="0">
+                <a:solidFill>
+                  <a:srgbClr val="E66767"/>
+                </a:solidFill>
+                <a:latin typeface="Arial" pitchFamily="34" charset="0"/>
+                <a:ea typeface="Arial" pitchFamily="34" charset="-122"/>
+                <a:cs typeface="Arial" pitchFamily="34" charset="-120"/>
+              </a:rPr>
+              <a:t>−0.25</a:t>
+            </a:r>
+            <a:endParaRPr lang="en-US" sz="1200" dirty="0"/>
+          </a:p>
+        </p:txBody>
+      </p:sp>
+      <p:sp>
+        <p:nvSpPr>
+          <p:cNvPr id="67" name="Text 65"/>
+          <p:cNvSpPr txBox="1"/>
+          <p:nvPr/>
+        </p:nvSpPr>
+        <p:spPr>
+          <a:xfrm>
+            <a:off x="9921240" y="4315968"/>
+            <a:ext cx="1691640" cy="338328"/>
+          </a:xfrm>
+          <a:prstGeom prst="rect">
+            <a:avLst/>
+          </a:prstGeom>
+          <a:noFill/>
+          <a:ln/>
+        </p:spPr>
+        <p:txBody>
+          <a:bodyPr wrap="square" lIns="0" tIns="0" rIns="0" bIns="0" rtlCol="0" anchor="ctr"/>
+          <a:lstStyle/>
+          <a:p>
+            <a:pPr algn="ctr" indent="0" marL="0">
+              <a:buNone/>
+            </a:pPr>
+            <a:r>
+              <a:rPr lang="en-US" sz="1200" dirty="0">
+                <a:solidFill>
+                  <a:srgbClr val="A3A8B0"/>
+                </a:solidFill>
+                <a:latin typeface="Arial" pitchFamily="34" charset="0"/>
+                <a:ea typeface="Arial" pitchFamily="34" charset="-122"/>
+                <a:cs typeface="Arial" pitchFamily="34" charset="-120"/>
+              </a:rPr>
+              <a:t>tăng &lt; 0.5</a:t>
+            </a:r>
+            <a:endParaRPr lang="en-US" sz="1200" dirty="0"/>
+          </a:p>
+        </p:txBody>
+      </p:sp>
+      <p:sp>
+        <p:nvSpPr>
+          <p:cNvPr id="68" name="Shape 66"/>
+          <p:cNvSpPr/>
+          <p:nvPr/>
+        </p:nvSpPr>
+        <p:spPr>
+          <a:xfrm>
+            <a:off x="548640" y="4700016"/>
+            <a:ext cx="11091672" cy="338328"/>
+          </a:xfrm>
+          <a:prstGeom prst="roundRect">
+            <a:avLst>
+              <a:gd name="adj" fmla="val 32432"/>
+            </a:avLst>
+          </a:prstGeom>
+          <a:solidFill>
+            <a:srgbClr val="22252B"/>
+          </a:solidFill>
+          <a:ln w="12700">
+            <a:solidFill>
+              <a:srgbClr val="22252B"/>
+            </a:solidFill>
+            <a:prstDash val="solid"/>
+          </a:ln>
+        </p:spPr>
+      </p:sp>
+      <p:sp>
+        <p:nvSpPr>
+          <p:cNvPr id="69" name="Text 67"/>
+          <p:cNvSpPr txBox="1"/>
+          <p:nvPr/>
+        </p:nvSpPr>
+        <p:spPr>
+          <a:xfrm>
+            <a:off x="777240" y="4700016"/>
+            <a:ext cx="3200400" cy="338328"/>
+          </a:xfrm>
+          <a:prstGeom prst="rect">
+            <a:avLst/>
+          </a:prstGeom>
+          <a:noFill/>
+          <a:ln/>
+        </p:spPr>
+        <p:txBody>
+          <a:bodyPr wrap="square" lIns="0" tIns="0" rIns="0" bIns="0" rtlCol="0" anchor="ctr"/>
+          <a:lstStyle/>
+          <a:p>
+            <a:pPr algn="l" indent="0" marL="0">
+              <a:buNone/>
+            </a:pPr>
+            <a:r>
+              <a:rPr lang="en-US" sz="1300" b="1" dirty="0">
+                <a:solidFill>
+                  <a:srgbClr val="9B6EE8"/>
+                </a:solidFill>
+                <a:latin typeface="Arial" pitchFamily="34" charset="0"/>
+                <a:ea typeface="Arial" pitchFamily="34" charset="-122"/>
+                <a:cs typeface="Arial" pitchFamily="34" charset="-120"/>
+              </a:rPr>
+              <a:t>Đổi-ID viết lại (luôn bật ở base)</a:t>
+            </a:r>
+            <a:endParaRPr lang="en-US" sz="1300" dirty="0"/>
+          </a:p>
+        </p:txBody>
+      </p:sp>
+      <p:sp>
+        <p:nvSpPr>
+          <p:cNvPr id="70" name="Text 68"/>
+          <p:cNvSpPr txBox="1"/>
+          <p:nvPr/>
+        </p:nvSpPr>
+        <p:spPr>
+          <a:xfrm>
+            <a:off x="3977640" y="4700016"/>
+            <a:ext cx="2011680" cy="338328"/>
+          </a:xfrm>
+          <a:prstGeom prst="rect">
+            <a:avLst/>
+          </a:prstGeom>
+          <a:noFill/>
+          <a:ln/>
+        </p:spPr>
+        <p:txBody>
+          <a:bodyPr wrap="square" lIns="0" tIns="0" rIns="0" bIns="0" rtlCol="0" anchor="ctr"/>
+          <a:lstStyle/>
+          <a:p>
+            <a:pPr algn="l" indent="0" marL="0">
+              <a:buNone/>
+            </a:pPr>
+            <a:r>
+              <a:rPr lang="en-US" sz="1200" dirty="0">
+                <a:solidFill>
+                  <a:srgbClr val="F2F2F2"/>
+                </a:solidFill>
+                <a:latin typeface="Arial" pitchFamily="34" charset="0"/>
+                <a:ea typeface="Arial" pitchFamily="34" charset="-122"/>
+                <a:cs typeface="Arial" pitchFamily="34" charset="-120"/>
+              </a:rPr>
+              <a:t>bật</a:t>
+            </a:r>
+            <a:endParaRPr lang="en-US" sz="1200" dirty="0"/>
+          </a:p>
+        </p:txBody>
+      </p:sp>
+      <p:sp>
+        <p:nvSpPr>
+          <p:cNvPr id="71" name="Text 69"/>
+          <p:cNvSpPr txBox="1"/>
+          <p:nvPr/>
+        </p:nvSpPr>
+        <p:spPr>
+          <a:xfrm>
+            <a:off x="5989320" y="4700016"/>
+            <a:ext cx="1005840" cy="338328"/>
+          </a:xfrm>
+          <a:prstGeom prst="rect">
+            <a:avLst/>
+          </a:prstGeom>
+          <a:noFill/>
+          <a:ln/>
+        </p:spPr>
+        <p:txBody>
+          <a:bodyPr wrap="square" lIns="0" tIns="0" rIns="0" bIns="0" rtlCol="0" anchor="ctr"/>
+          <a:lstStyle/>
+          <a:p>
+            <a:pPr algn="ctr" indent="0" marL="0">
+              <a:buNone/>
+            </a:pPr>
+            <a:r>
+              <a:rPr lang="en-US" sz="1200" dirty="0">
+                <a:solidFill>
+                  <a:srgbClr val="E66767"/>
+                </a:solidFill>
+                <a:latin typeface="Arial" pitchFamily="34" charset="0"/>
+                <a:ea typeface="Arial" pitchFamily="34" charset="-122"/>
+                <a:cs typeface="Arial" pitchFamily="34" charset="-120"/>
+              </a:rPr>
+              <a:t>−0.26</a:t>
+            </a:r>
+            <a:endParaRPr lang="en-US" sz="1200" dirty="0"/>
+          </a:p>
+        </p:txBody>
+      </p:sp>
+      <p:sp>
+        <p:nvSpPr>
+          <p:cNvPr id="72" name="Text 70"/>
+          <p:cNvSpPr txBox="1"/>
+          <p:nvPr/>
+        </p:nvSpPr>
+        <p:spPr>
+          <a:xfrm>
+            <a:off x="6995160" y="4700016"/>
+            <a:ext cx="1005840" cy="338328"/>
+          </a:xfrm>
+          <a:prstGeom prst="rect">
+            <a:avLst/>
+          </a:prstGeom>
+          <a:noFill/>
+          <a:ln/>
+        </p:spPr>
+        <p:txBody>
+          <a:bodyPr wrap="square" lIns="0" tIns="0" rIns="0" bIns="0" rtlCol="0" anchor="ctr"/>
+          <a:lstStyle/>
+          <a:p>
+            <a:pPr algn="ctr" indent="0" marL="0">
+              <a:buNone/>
+            </a:pPr>
+            <a:r>
+              <a:rPr lang="en-US" sz="1200" dirty="0">
+                <a:solidFill>
+                  <a:srgbClr val="F2F2F2"/>
+                </a:solidFill>
+                <a:latin typeface="Arial" pitchFamily="34" charset="0"/>
+                <a:ea typeface="Arial" pitchFamily="34" charset="-122"/>
+                <a:cs typeface="Arial" pitchFamily="34" charset="-120"/>
+              </a:rPr>
+              <a:t>±0.00</a:t>
+            </a:r>
+            <a:endParaRPr lang="en-US" sz="1200" dirty="0"/>
+          </a:p>
+        </p:txBody>
+      </p:sp>
+      <p:sp>
+        <p:nvSpPr>
+          <p:cNvPr id="73" name="Text 71"/>
+          <p:cNvSpPr txBox="1"/>
+          <p:nvPr/>
+        </p:nvSpPr>
+        <p:spPr>
+          <a:xfrm>
+            <a:off x="8001000" y="4700016"/>
+            <a:ext cx="960120" cy="338328"/>
+          </a:xfrm>
+          <a:prstGeom prst="rect">
+            <a:avLst/>
+          </a:prstGeom>
+          <a:noFill/>
+          <a:ln/>
+        </p:spPr>
+        <p:txBody>
+          <a:bodyPr wrap="square" lIns="0" tIns="0" rIns="0" bIns="0" rtlCol="0" anchor="ctr"/>
+          <a:lstStyle/>
+          <a:p>
+            <a:pPr algn="ctr" indent="0" marL="0">
+              <a:buNone/>
+            </a:pPr>
+            <a:r>
+              <a:rPr lang="en-US" sz="1200" dirty="0">
+                <a:solidFill>
+                  <a:srgbClr val="F2F2F2"/>
+                </a:solidFill>
+                <a:latin typeface="Arial" pitchFamily="34" charset="0"/>
+                <a:ea typeface="Arial" pitchFamily="34" charset="-122"/>
+                <a:cs typeface="Arial" pitchFamily="34" charset="-120"/>
+              </a:rPr>
+              <a:t>±0.0</a:t>
+            </a:r>
+            <a:endParaRPr lang="en-US" sz="1200" dirty="0"/>
+          </a:p>
+        </p:txBody>
+      </p:sp>
+      <p:sp>
+        <p:nvSpPr>
+          <p:cNvPr id="74" name="Text 72"/>
+          <p:cNvSpPr txBox="1"/>
+          <p:nvPr/>
+        </p:nvSpPr>
+        <p:spPr>
+          <a:xfrm>
+            <a:off x="8961120" y="4700016"/>
+            <a:ext cx="960120" cy="338328"/>
+          </a:xfrm>
+          <a:prstGeom prst="rect">
+            <a:avLst/>
+          </a:prstGeom>
+          <a:noFill/>
+          <a:ln/>
+        </p:spPr>
+        <p:txBody>
+          <a:bodyPr wrap="square" lIns="0" tIns="0" rIns="0" bIns="0" rtlCol="0" anchor="ctr"/>
+          <a:lstStyle/>
+          <a:p>
+            <a:pPr algn="ctr" indent="0" marL="0">
+              <a:buNone/>
+            </a:pPr>
+            <a:r>
+              <a:rPr lang="en-US" sz="1200" b="1" dirty="0">
+                <a:solidFill>
+                  <a:srgbClr val="E66767"/>
+                </a:solidFill>
+                <a:latin typeface="Arial" pitchFamily="34" charset="0"/>
+                <a:ea typeface="Arial" pitchFamily="34" charset="-122"/>
+                <a:cs typeface="Arial" pitchFamily="34" charset="-120"/>
+              </a:rPr>
+              <a:t>−0.26</a:t>
+            </a:r>
+            <a:endParaRPr lang="en-US" sz="1200" dirty="0"/>
+          </a:p>
+        </p:txBody>
+      </p:sp>
+      <p:sp>
+        <p:nvSpPr>
+          <p:cNvPr id="75" name="Text 73"/>
+          <p:cNvSpPr txBox="1"/>
+          <p:nvPr/>
+        </p:nvSpPr>
+        <p:spPr>
+          <a:xfrm>
+            <a:off x="9921240" y="4700016"/>
+            <a:ext cx="1691640" cy="338328"/>
+          </a:xfrm>
+          <a:prstGeom prst="rect">
+            <a:avLst/>
+          </a:prstGeom>
+          <a:noFill/>
+          <a:ln/>
+        </p:spPr>
+        <p:txBody>
+          <a:bodyPr wrap="square" lIns="0" tIns="0" rIns="0" bIns="0" rtlCol="0" anchor="ctr"/>
+          <a:lstStyle/>
+          <a:p>
+            <a:pPr algn="ctr" indent="0" marL="0">
+              <a:buNone/>
+            </a:pPr>
+            <a:r>
+              <a:rPr lang="en-US" sz="1200" dirty="0">
+                <a:solidFill>
+                  <a:srgbClr val="A3A8B0"/>
+                </a:solidFill>
+                <a:latin typeface="Arial" pitchFamily="34" charset="0"/>
+                <a:ea typeface="Arial" pitchFamily="34" charset="-122"/>
+                <a:cs typeface="Arial" pitchFamily="34" charset="-120"/>
+              </a:rPr>
+              <a:t>tăng &lt; 0.5</a:t>
+            </a:r>
+            <a:endParaRPr lang="en-US" sz="1200" dirty="0"/>
+          </a:p>
+        </p:txBody>
+      </p:sp>
+      <p:sp>
+        <p:nvSpPr>
+          <p:cNvPr id="76" name="Shape 74"/>
+          <p:cNvSpPr/>
+          <p:nvPr/>
+        </p:nvSpPr>
+        <p:spPr>
+          <a:xfrm>
+            <a:off x="548640" y="5084064"/>
+            <a:ext cx="11091672" cy="338328"/>
+          </a:xfrm>
+          <a:prstGeom prst="roundRect">
+            <a:avLst>
+              <a:gd name="adj" fmla="val 32432"/>
+            </a:avLst>
+          </a:prstGeom>
+          <a:solidFill>
+            <a:srgbClr val="22252B"/>
+          </a:solidFill>
+          <a:ln w="12700">
+            <a:solidFill>
+              <a:srgbClr val="22252B"/>
+            </a:solidFill>
+            <a:prstDash val="solid"/>
+          </a:ln>
+        </p:spPr>
+      </p:sp>
+      <p:sp>
+        <p:nvSpPr>
+          <p:cNvPr id="77" name="Text 75"/>
+          <p:cNvSpPr txBox="1"/>
+          <p:nvPr/>
+        </p:nvSpPr>
+        <p:spPr>
+          <a:xfrm>
+            <a:off x="777240" y="5084064"/>
+            <a:ext cx="3200400" cy="338328"/>
+          </a:xfrm>
+          <a:prstGeom prst="rect">
+            <a:avLst/>
+          </a:prstGeom>
+          <a:noFill/>
+          <a:ln/>
+        </p:spPr>
+        <p:txBody>
+          <a:bodyPr wrap="square" lIns="0" tIns="0" rIns="0" bIns="0" rtlCol="0" anchor="ctr"/>
+          <a:lstStyle/>
+          <a:p>
+            <a:pPr algn="l" indent="0" marL="0">
+              <a:buNone/>
+            </a:pPr>
+            <a:r>
+              <a:rPr lang="en-US" sz="1300" b="1" dirty="0">
+                <a:solidFill>
+                  <a:srgbClr val="9B6EE8"/>
+                </a:solidFill>
+                <a:latin typeface="Arial" pitchFamily="34" charset="0"/>
+                <a:ea typeface="Arial" pitchFamily="34" charset="-122"/>
+                <a:cs typeface="Arial" pitchFamily="34" charset="-120"/>
+              </a:rPr>
+              <a:t>M6 · tone-map</a:t>
+            </a:r>
+            <a:endParaRPr lang="en-US" sz="1300" dirty="0"/>
+          </a:p>
+        </p:txBody>
+      </p:sp>
+      <p:sp>
+        <p:nvSpPr>
+          <p:cNvPr id="78" name="Text 76"/>
+          <p:cNvSpPr txBox="1"/>
+          <p:nvPr/>
+        </p:nvSpPr>
+        <p:spPr>
+          <a:xfrm>
+            <a:off x="3977640" y="5084064"/>
+            <a:ext cx="2011680" cy="338328"/>
+          </a:xfrm>
+          <a:prstGeom prst="rect">
+            <a:avLst/>
+          </a:prstGeom>
+          <a:noFill/>
+          <a:ln/>
+        </p:spPr>
+        <p:txBody>
+          <a:bodyPr wrap="square" lIns="0" tIns="0" rIns="0" bIns="0" rtlCol="0" anchor="ctr"/>
+          <a:lstStyle/>
+          <a:p>
+            <a:pPr algn="l" indent="0" marL="0">
+              <a:buNone/>
+            </a:pPr>
+            <a:r>
+              <a:rPr lang="en-US" sz="1200" dirty="0">
+                <a:solidFill>
+                  <a:srgbClr val="F2F2F2"/>
+                </a:solidFill>
+                <a:latin typeface="Arial" pitchFamily="34" charset="0"/>
+                <a:ea typeface="Arial" pitchFamily="34" charset="-122"/>
+                <a:cs typeface="Arial" pitchFamily="34" charset="-120"/>
+              </a:rPr>
+              <a:t>bật</a:t>
+            </a:r>
+            <a:endParaRPr lang="en-US" sz="1200" dirty="0"/>
+          </a:p>
+        </p:txBody>
+      </p:sp>
+      <p:sp>
+        <p:nvSpPr>
+          <p:cNvPr id="79" name="Text 77"/>
+          <p:cNvSpPr txBox="1"/>
+          <p:nvPr/>
+        </p:nvSpPr>
+        <p:spPr>
+          <a:xfrm>
+            <a:off x="5989320" y="5084064"/>
+            <a:ext cx="1005840" cy="338328"/>
+          </a:xfrm>
+          <a:prstGeom prst="rect">
+            <a:avLst/>
+          </a:prstGeom>
+          <a:noFill/>
+          <a:ln/>
+        </p:spPr>
+        <p:txBody>
+          <a:bodyPr wrap="square" lIns="0" tIns="0" rIns="0" bIns="0" rtlCol="0" anchor="ctr"/>
+          <a:lstStyle/>
+          <a:p>
+            <a:pPr algn="ctr" indent="0" marL="0">
+              <a:buNone/>
+            </a:pPr>
+            <a:r>
+              <a:rPr lang="en-US" sz="1200" dirty="0">
+                <a:solidFill>
+                  <a:srgbClr val="E66767"/>
+                </a:solidFill>
+                <a:latin typeface="Arial" pitchFamily="34" charset="0"/>
+                <a:ea typeface="Arial" pitchFamily="34" charset="-122"/>
+                <a:cs typeface="Arial" pitchFamily="34" charset="-120"/>
+              </a:rPr>
+              <a:t>−0.10</a:t>
+            </a:r>
+            <a:endParaRPr lang="en-US" sz="1200" dirty="0"/>
+          </a:p>
+        </p:txBody>
+      </p:sp>
+      <p:sp>
+        <p:nvSpPr>
+          <p:cNvPr id="80" name="Text 78"/>
+          <p:cNvSpPr txBox="1"/>
+          <p:nvPr/>
+        </p:nvSpPr>
+        <p:spPr>
+          <a:xfrm>
+            <a:off x="6995160" y="5084064"/>
+            <a:ext cx="1005840" cy="338328"/>
+          </a:xfrm>
+          <a:prstGeom prst="rect">
+            <a:avLst/>
+          </a:prstGeom>
+          <a:noFill/>
+          <a:ln/>
+        </p:spPr>
+        <p:txBody>
+          <a:bodyPr wrap="square" lIns="0" tIns="0" rIns="0" bIns="0" rtlCol="0" anchor="ctr"/>
+          <a:lstStyle/>
+          <a:p>
+            <a:pPr algn="ctr" indent="0" marL="0">
+              <a:buNone/>
+            </a:pPr>
+            <a:r>
+              <a:rPr lang="en-US" sz="1200" dirty="0">
+                <a:solidFill>
+                  <a:srgbClr val="E66767"/>
+                </a:solidFill>
+                <a:latin typeface="Arial" pitchFamily="34" charset="0"/>
+                <a:ea typeface="Arial" pitchFamily="34" charset="-122"/>
+                <a:cs typeface="Arial" pitchFamily="34" charset="-120"/>
+              </a:rPr>
+              <a:t>−0.73</a:t>
+            </a:r>
+            <a:endParaRPr lang="en-US" sz="1200" dirty="0"/>
+          </a:p>
+        </p:txBody>
+      </p:sp>
+      <p:sp>
+        <p:nvSpPr>
+          <p:cNvPr id="81" name="Text 79"/>
+          <p:cNvSpPr txBox="1"/>
+          <p:nvPr/>
+        </p:nvSpPr>
+        <p:spPr>
+          <a:xfrm>
+            <a:off x="8001000" y="5084064"/>
+            <a:ext cx="960120" cy="338328"/>
+          </a:xfrm>
+          <a:prstGeom prst="rect">
+            <a:avLst/>
+          </a:prstGeom>
+          <a:noFill/>
+          <a:ln/>
+        </p:spPr>
+        <p:txBody>
+          <a:bodyPr wrap="square" lIns="0" tIns="0" rIns="0" bIns="0" rtlCol="0" anchor="ctr"/>
+          <a:lstStyle/>
+          <a:p>
+            <a:pPr algn="ctr" indent="0" marL="0">
+              <a:buNone/>
+            </a:pPr>
+            <a:r>
+              <a:rPr lang="en-US" sz="1200" dirty="0">
+                <a:solidFill>
+                  <a:srgbClr val="E66767"/>
+                </a:solidFill>
+                <a:latin typeface="Arial" pitchFamily="34" charset="0"/>
+                <a:ea typeface="Arial" pitchFamily="34" charset="-122"/>
+                <a:cs typeface="Arial" pitchFamily="34" charset="-120"/>
+              </a:rPr>
+              <a:t>−0.7</a:t>
+            </a:r>
+            <a:endParaRPr lang="en-US" sz="1200" dirty="0"/>
+          </a:p>
+        </p:txBody>
+      </p:sp>
+      <p:sp>
+        <p:nvSpPr>
+          <p:cNvPr id="82" name="Text 80"/>
+          <p:cNvSpPr txBox="1"/>
+          <p:nvPr/>
+        </p:nvSpPr>
+        <p:spPr>
+          <a:xfrm>
+            <a:off x="8961120" y="5084064"/>
+            <a:ext cx="960120" cy="338328"/>
+          </a:xfrm>
+          <a:prstGeom prst="rect">
+            <a:avLst/>
+          </a:prstGeom>
+          <a:noFill/>
+          <a:ln/>
+        </p:spPr>
+        <p:txBody>
+          <a:bodyPr wrap="square" lIns="0" tIns="0" rIns="0" bIns="0" rtlCol="0" anchor="ctr"/>
+          <a:lstStyle/>
+          <a:p>
+            <a:pPr algn="ctr" indent="0" marL="0">
+              <a:buNone/>
+            </a:pPr>
+            <a:r>
+              <a:rPr lang="en-US" sz="1200" b="1" dirty="0">
+                <a:solidFill>
+                  <a:srgbClr val="E66767"/>
+                </a:solidFill>
+                <a:latin typeface="Arial" pitchFamily="34" charset="0"/>
+                <a:ea typeface="Arial" pitchFamily="34" charset="-122"/>
+                <a:cs typeface="Arial" pitchFamily="34" charset="-120"/>
+              </a:rPr>
+              <a:t>−1.53</a:t>
+            </a:r>
+            <a:endParaRPr lang="en-US" sz="1200" dirty="0"/>
+          </a:p>
+        </p:txBody>
+      </p:sp>
+      <p:sp>
+        <p:nvSpPr>
+          <p:cNvPr id="83" name="Text 81"/>
+          <p:cNvSpPr txBox="1"/>
+          <p:nvPr/>
+        </p:nvSpPr>
+        <p:spPr>
+          <a:xfrm>
+            <a:off x="9921240" y="5084064"/>
+            <a:ext cx="1691640" cy="338328"/>
+          </a:xfrm>
+          <a:prstGeom prst="rect">
+            <a:avLst/>
+          </a:prstGeom>
+          <a:noFill/>
+          <a:ln/>
+        </p:spPr>
+        <p:txBody>
+          <a:bodyPr wrap="square" lIns="0" tIns="0" rIns="0" bIns="0" rtlCol="0" anchor="ctr"/>
+          <a:lstStyle/>
+          <a:p>
+            <a:pPr algn="ctr" indent="0" marL="0">
+              <a:buNone/>
+            </a:pPr>
+            <a:r>
+              <a:rPr lang="en-US" sz="1200" dirty="0">
+                <a:solidFill>
+                  <a:srgbClr val="A3A8B0"/>
+                </a:solidFill>
+                <a:latin typeface="Arial" pitchFamily="34" charset="0"/>
+                <a:ea typeface="Arial" pitchFamily="34" charset="-122"/>
+                <a:cs typeface="Arial" pitchFamily="34" charset="-120"/>
+              </a:rPr>
+              <a:t>giảm &gt; 0.5</a:t>
+            </a:r>
+            <a:endParaRPr lang="en-US" sz="1200" dirty="0"/>
+          </a:p>
+        </p:txBody>
+      </p:sp>
+      <p:sp>
+        <p:nvSpPr>
+          <p:cNvPr id="84" name="Shape 82"/>
+          <p:cNvSpPr/>
+          <p:nvPr/>
+        </p:nvSpPr>
+        <p:spPr>
+          <a:xfrm>
+            <a:off x="548640" y="5541264"/>
+            <a:ext cx="11091672" cy="749808"/>
+          </a:xfrm>
+          <a:prstGeom prst="roundRect">
+            <a:avLst>
+              <a:gd name="adj" fmla="val 14634"/>
             </a:avLst>
           </a:prstGeom>
           <a:solidFill>
@@ -33670,74 +36578,69 @@
       </p:sp>
       <p:sp>
         <p:nvSpPr>
-          <p:cNvPr id="8" name="Text 6"/>
-          <p:cNvSpPr txBox="1"/>
-          <p:nvPr/>
-        </p:nvSpPr>
-        <p:spPr>
-          <a:xfrm>
-            <a:off x="6473952" y="1600200"/>
-            <a:ext cx="4937760" cy="365760"/>
-          </a:xfrm>
-          <a:prstGeom prst="rect">
-            <a:avLst/>
-          </a:prstGeom>
-          <a:noFill/>
-          <a:ln/>
-        </p:spPr>
-        <p:txBody>
-          <a:bodyPr wrap="square" lIns="0" tIns="0" rIns="0" bIns="0" rtlCol="0" anchor="t"/>
+          <p:cNvPr id="85" name="Shape 83"/>
+          <p:cNvSpPr/>
+          <p:nvPr/>
+        </p:nvSpPr>
+        <p:spPr>
+          <a:xfrm>
+            <a:off x="548640" y="5541264"/>
+            <a:ext cx="91440" cy="749808"/>
+          </a:xfrm>
+          <a:prstGeom prst="rect">
+            <a:avLst/>
+          </a:prstGeom>
+          <a:solidFill>
+            <a:srgbClr val="F2A900"/>
+          </a:solidFill>
+          <a:ln w="12700">
+            <a:solidFill>
+              <a:srgbClr val="F2A900"/>
+            </a:solidFill>
+            <a:prstDash val="solid"/>
+          </a:ln>
+        </p:spPr>
+      </p:sp>
+      <p:sp>
+        <p:nvSpPr>
+          <p:cNvPr id="86" name="Text 84"/>
+          <p:cNvSpPr txBox="1"/>
+          <p:nvPr/>
+        </p:nvSpPr>
+        <p:spPr>
+          <a:xfrm>
+            <a:off x="822960" y="5541264"/>
+            <a:ext cx="10698480" cy="749808"/>
+          </a:xfrm>
+          <a:prstGeom prst="rect">
+            <a:avLst/>
+          </a:prstGeom>
+          <a:noFill/>
+          <a:ln/>
+        </p:spPr>
+        <p:txBody>
+          <a:bodyPr wrap="square" lIns="0" tIns="0" rIns="0" bIns="0" rtlCol="0" anchor="ctr"/>
           <a:lstStyle/>
           <a:p>
             <a:pPr indent="0" marL="0">
               <a:buNone/>
             </a:pPr>
             <a:r>
-              <a:rPr lang="en-US" sz="2000" b="1" dirty="0">
-                <a:solidFill>
-                  <a:srgbClr val="19A35F"/>
-                </a:solidFill>
-                <a:latin typeface="Arial" pitchFamily="34" charset="0"/>
-                <a:ea typeface="Arial" pitchFamily="34" charset="-122"/>
-                <a:cs typeface="Arial" pitchFamily="34" charset="-120"/>
-              </a:rPr>
-              <a:t>Hướng tiếp theo</a:t>
-            </a:r>
-            <a:endParaRPr lang="en-US" sz="2000" dirty="0"/>
-          </a:p>
-        </p:txBody>
-      </p:sp>
-      <p:sp>
-        <p:nvSpPr>
-          <p:cNvPr id="9" name="Text 7"/>
-          <p:cNvSpPr txBox="1"/>
-          <p:nvPr/>
-        </p:nvSpPr>
-        <p:spPr>
-          <a:xfrm>
-            <a:off x="6473952" y="2103120"/>
-            <a:ext cx="4937760" cy="3749040"/>
-          </a:xfrm>
-          <a:prstGeom prst="rect">
-            <a:avLst/>
-          </a:prstGeom>
-          <a:noFill/>
-          <a:ln/>
-        </p:spPr>
-        <p:txBody>
-          <a:bodyPr wrap="square" lIns="0" tIns="0" rIns="0" bIns="0" rtlCol="0" anchor="t"/>
-          <a:lstStyle/>
-          <a:p>
-            <a:pPr marL="342900" indent="-342900">
-              <a:spcAft>
-                <a:spcPts val="1800"/>
-              </a:spcAft>
-              <a:buSzPct val="100000"/>
-              <a:buFont typeface="+mj-lt"/>
-              <a:buAutoNum type="arabicPeriod" startAt="1"/>
-            </a:pPr>
-            <a:r>
-              <a:rPr lang="en-US" sz="1900" dirty="0">
+              <a:rPr lang="en-US" sz="1300" b="1" dirty="0">
+                <a:solidFill>
+                  <a:srgbClr val="F2A900"/>
+                </a:solidFill>
+                <a:latin typeface="Arial" pitchFamily="34" charset="0"/>
+                <a:ea typeface="Arial" pitchFamily="34" charset="-122"/>
+                <a:cs typeface="Arial" pitchFamily="34" charset="-120"/>
+              </a:rPr>
+              <a:t>Kết quả: giữ PEG. </a:t>
+            </a:r>
+            <a:pPr indent="0" marL="0">
+              <a:buNone/>
+            </a:pPr>
+            <a:r>
+              <a:rPr lang="en-US" sz="1300" dirty="0">
                 <a:solidFill>
                   <a:srgbClr val="F2F2F2"/>
                 </a:solidFill>
@@ -33745,81 +36648,15 @@
                 <a:ea typeface="Arial" pitchFamily="34" charset="-122"/>
                 <a:cs typeface="Arial" pitchFamily="34" charset="-120"/>
               </a:rPr>
-              <a:t>Chọn bằng khoảng tin cậy hoặc cross-validation, không bằng ngưỡng cứng</a:t>
-            </a:r>
-            <a:endParaRPr lang="en-US" sz="1900" dirty="0"/>
-          </a:p>
-          <a:p>
-            <a:pPr marL="342900" indent="-342900">
-              <a:spcAft>
-                <a:spcPts val="1800"/>
-              </a:spcAft>
-              <a:buSzPct val="100000"/>
-              <a:buFont typeface="+mj-lt"/>
-              <a:buAutoNum type="arabicPeriod" startAt="1"/>
-            </a:pPr>
-            <a:r>
-              <a:rPr lang="en-US" sz="1900" dirty="0">
-                <a:solidFill>
-                  <a:srgbClr val="F2F2F2"/>
-                </a:solidFill>
-                <a:latin typeface="Arial" pitchFamily="34" charset="0"/>
-                <a:ea typeface="Arial" pitchFamily="34" charset="-122"/>
-                <a:cs typeface="Arial" pitchFamily="34" charset="-120"/>
-              </a:rPr>
-              <a:t>Tune tham số của method trên val, không trên test</a:t>
-            </a:r>
-            <a:endParaRPr lang="en-US" sz="1900" dirty="0"/>
-          </a:p>
-          <a:p>
-            <a:pPr marL="342900" indent="-342900">
-              <a:spcAft>
-                <a:spcPts val="1800"/>
-              </a:spcAft>
-              <a:buSzPct val="100000"/>
-              <a:buFont typeface="+mj-lt"/>
-              <a:buAutoNum type="arabicPeriod" startAt="1"/>
-            </a:pPr>
-            <a:r>
-              <a:rPr lang="en-US" sz="1900" dirty="0">
-                <a:solidFill>
-                  <a:srgbClr val="F2F2F2"/>
-                </a:solidFill>
-                <a:latin typeface="Arial" pitchFamily="34" charset="0"/>
-                <a:ea typeface="Arial" pitchFamily="34" charset="-122"/>
-                <a:cs typeface="Arial" pitchFamily="34" charset="-120"/>
-              </a:rPr>
-              <a:t>Neo đèn (M5) với độ tin không phụ thuộc độ bất định Kalman</a:t>
-            </a:r>
-            <a:endParaRPr lang="en-US" sz="1900" dirty="0"/>
-          </a:p>
-          <a:p>
-            <a:pPr marL="342900" indent="-342900">
-              <a:spcAft>
-                <a:spcPts val="1800"/>
-              </a:spcAft>
-              <a:buSzPct val="100000"/>
-              <a:buFont typeface="+mj-lt"/>
-              <a:buAutoNum type="arabicPeriod" startAt="1"/>
-            </a:pPr>
-            <a:r>
-              <a:rPr lang="en-US" sz="1900" dirty="0">
-                <a:solidFill>
-                  <a:srgbClr val="F2F2F2"/>
-                </a:solidFill>
-                <a:latin typeface="Arial" pitchFamily="34" charset="0"/>
-                <a:ea typeface="Arial" pitchFamily="34" charset="-122"/>
-                <a:cs typeface="Arial" pitchFamily="34" charset="-120"/>
-              </a:rPr>
-              <a:t>M6 (tone-map): thử lại khi val có nhiều ca chói quanh người hơn</a:t>
-            </a:r>
-            <a:endParaRPr lang="en-US" sz="1900" dirty="0"/>
-          </a:p>
-        </p:txBody>
-      </p:sp>
-      <p:sp>
-        <p:nvSpPr>
-          <p:cNvPr id="10" name="Shape 8"/>
+              <a:t>Cone (M1) tăng nhờ đúng 1 video T1 (156) + 1 video T2 (147); hãm vận tốc tăng nhờ 1 lần chói (video 332). Test một lần cho cấu hình cuối = PEG: 68.34 · 61.41 · 76.2.</a:t>
+            </a:r>
+            <a:endParaRPr lang="en-US" sz="1300" dirty="0"/>
+          </a:p>
+        </p:txBody>
+      </p:sp>
+      <p:sp>
+        <p:nvSpPr>
+          <p:cNvPr id="87" name="Shape 85"/>
           <p:cNvSpPr/>
           <p:nvPr/>
         </p:nvSpPr>
@@ -33834,13 +36671,13 @@
             </a:avLst>
           </a:prstGeom>
           <a:solidFill>
-            <a:srgbClr val="19A35F">
+            <a:srgbClr val="9B6EE8">
               <a:alpha val="22000"/>
             </a:srgbClr>
           </a:solidFill>
           <a:ln w="15875">
             <a:solidFill>
-              <a:srgbClr val="19A35F"/>
+              <a:srgbClr val="9B6EE8"/>
             </a:solidFill>
             <a:prstDash val="solid"/>
           </a:ln>
@@ -33848,7 +36685,7 @@
       </p:sp>
       <p:sp>
         <p:nvSpPr>
-          <p:cNvPr id="11" name="Text 9"/>
+          <p:cNvPr id="88" name="Text 86"/>
           <p:cNvSpPr txBox="1"/>
           <p:nvPr/>
         </p:nvSpPr>
@@ -33879,7 +36716,7 @@
                 <a:ea typeface="Arial" pitchFamily="34" charset="-122"/>
                 <a:cs typeface="Arial" pitchFamily="34" charset="-120"/>
               </a:rPr>
-              <a:t>NGƯỜI 2 · PEG+</a:t>
+              <a:t>NGƯỜI 1 · PEG-F</a:t>
             </a:r>
             <a:endParaRPr lang="en-US" sz="1100" dirty="0"/>
           </a:p>
@@ -33887,7 +36724,7 @@
       </p:sp>
       <p:sp>
         <p:nvSpPr>
-          <p:cNvPr id="12" name="Text 10"/>
+          <p:cNvPr id="89" name="Text 87"/>
           <p:cNvSpPr txBox="1"/>
           <p:nvPr/>
         </p:nvSpPr>
@@ -33958,6 +36795,592 @@
       </p:grpSpPr>
       <p:sp>
         <p:nvSpPr>
+          <p:cNvPr id="2" name="Text 0"/>
+          <p:cNvSpPr txBox="1"/>
+          <p:nvPr/>
+        </p:nvSpPr>
+        <p:spPr>
+          <a:xfrm>
+            <a:off x="548640" y="320040"/>
+            <a:ext cx="8229600" cy="320040"/>
+          </a:xfrm>
+          <a:prstGeom prst="rect">
+            <a:avLst/>
+          </a:prstGeom>
+          <a:noFill/>
+          <a:ln/>
+        </p:spPr>
+        <p:txBody>
+          <a:bodyPr wrap="square" lIns="0" tIns="0" rIns="0" bIns="0" rtlCol="0" anchor="ctr"/>
+          <a:lstStyle/>
+          <a:p>
+            <a:pPr indent="0" marL="0">
+              <a:buNone/>
+            </a:pPr>
+            <a:r>
+              <a:rPr lang="en-US" sz="1300" b="1" spc="200" kern="0" dirty="0">
+                <a:solidFill>
+                  <a:srgbClr val="F2A900"/>
+                </a:solidFill>
+                <a:latin typeface="Arial" pitchFamily="34" charset="0"/>
+                <a:ea typeface="Arial" pitchFamily="34" charset="-122"/>
+                <a:cs typeface="Arial" pitchFamily="34" charset="-120"/>
+              </a:rPr>
+              <a:t>TỔNG KẾT</a:t>
+            </a:r>
+            <a:endParaRPr lang="en-US" sz="1300" dirty="0"/>
+          </a:p>
+        </p:txBody>
+      </p:sp>
+      <p:sp>
+        <p:nvSpPr>
+          <p:cNvPr id="3" name="Text 1"/>
+          <p:cNvSpPr txBox="1"/>
+          <p:nvPr/>
+        </p:nvSpPr>
+        <p:spPr>
+          <a:xfrm>
+            <a:off x="548640" y="640080"/>
+            <a:ext cx="11064240" cy="731520"/>
+          </a:xfrm>
+          <a:prstGeom prst="rect">
+            <a:avLst/>
+          </a:prstGeom>
+          <a:noFill/>
+          <a:ln/>
+        </p:spPr>
+        <p:txBody>
+          <a:bodyPr wrap="square" lIns="0" tIns="0" rIns="0" bIns="0" rtlCol="0" anchor="t"/>
+          <a:lstStyle/>
+          <a:p>
+            <a:pPr indent="0" marL="0">
+              <a:buNone/>
+            </a:pPr>
+            <a:r>
+              <a:rPr lang="en-US" sz="3000" b="1" dirty="0">
+                <a:solidFill>
+                  <a:srgbClr val="F2F2F2"/>
+                </a:solidFill>
+                <a:latin typeface="Arial" pitchFamily="34" charset="0"/>
+                <a:ea typeface="Arial" pitchFamily="34" charset="-122"/>
+                <a:cs typeface="Arial" pitchFamily="34" charset="-120"/>
+              </a:rPr>
+              <a:t>Kết luận và bài học</a:t>
+            </a:r>
+            <a:endParaRPr lang="en-US" sz="3000" dirty="0"/>
+          </a:p>
+        </p:txBody>
+      </p:sp>
+      <p:sp>
+        <p:nvSpPr>
+          <p:cNvPr id="4" name="Shape 2"/>
+          <p:cNvSpPr/>
+          <p:nvPr/>
+        </p:nvSpPr>
+        <p:spPr>
+          <a:xfrm>
+            <a:off x="548640" y="1508760"/>
+            <a:ext cx="5486400" cy="4480560"/>
+          </a:xfrm>
+          <a:prstGeom prst="roundRect">
+            <a:avLst>
+              <a:gd name="adj" fmla="val 2449"/>
+            </a:avLst>
+          </a:prstGeom>
+          <a:solidFill>
+            <a:srgbClr val="22252B"/>
+          </a:solidFill>
+          <a:ln w="12700">
+            <a:solidFill>
+              <a:srgbClr val="22252B"/>
+            </a:solidFill>
+            <a:prstDash val="solid"/>
+          </a:ln>
+        </p:spPr>
+      </p:sp>
+      <p:sp>
+        <p:nvSpPr>
+          <p:cNvPr id="5" name="Text 3"/>
+          <p:cNvSpPr txBox="1"/>
+          <p:nvPr/>
+        </p:nvSpPr>
+        <p:spPr>
+          <a:xfrm>
+            <a:off x="822960" y="1600200"/>
+            <a:ext cx="4937760" cy="365760"/>
+          </a:xfrm>
+          <a:prstGeom prst="rect">
+            <a:avLst/>
+          </a:prstGeom>
+          <a:noFill/>
+          <a:ln/>
+        </p:spPr>
+        <p:txBody>
+          <a:bodyPr wrap="square" lIns="0" tIns="0" rIns="0" bIns="0" rtlCol="0" anchor="t"/>
+          <a:lstStyle/>
+          <a:p>
+            <a:pPr indent="0" marL="0">
+              <a:buNone/>
+            </a:pPr>
+            <a:r>
+              <a:rPr lang="en-US" sz="2000" b="1" dirty="0">
+                <a:solidFill>
+                  <a:srgbClr val="F2A900"/>
+                </a:solidFill>
+                <a:latin typeface="Arial" pitchFamily="34" charset="0"/>
+                <a:ea typeface="Arial" pitchFamily="34" charset="-122"/>
+                <a:cs typeface="Arial" pitchFamily="34" charset="-120"/>
+              </a:rPr>
+              <a:t>Kết quả</a:t>
+            </a:r>
+            <a:endParaRPr lang="en-US" sz="2000" dirty="0"/>
+          </a:p>
+        </p:txBody>
+      </p:sp>
+      <p:sp>
+        <p:nvSpPr>
+          <p:cNvPr id="6" name="Text 4"/>
+          <p:cNvSpPr txBox="1"/>
+          <p:nvPr/>
+        </p:nvSpPr>
+        <p:spPr>
+          <a:xfrm>
+            <a:off x="822960" y="2103120"/>
+            <a:ext cx="4983480" cy="3749040"/>
+          </a:xfrm>
+          <a:prstGeom prst="rect">
+            <a:avLst/>
+          </a:prstGeom>
+          <a:noFill/>
+          <a:ln/>
+        </p:spPr>
+        <p:txBody>
+          <a:bodyPr wrap="square" lIns="0" tIns="0" rIns="0" bIns="0" rtlCol="0" anchor="t"/>
+          <a:lstStyle/>
+          <a:p>
+            <a:pPr marL="342900" indent="-342900">
+              <a:spcAft>
+                <a:spcPts val="800"/>
+              </a:spcAft>
+              <a:buSzPct val="100000"/>
+              <a:buChar char="•"/>
+            </a:pPr>
+            <a:r>
+              <a:rPr lang="en-US" sz="1500" dirty="0">
+                <a:solidFill>
+                  <a:srgbClr val="F2F2F2"/>
+                </a:solidFill>
+                <a:latin typeface="Arial" pitchFamily="34" charset="0"/>
+                <a:ea typeface="Arial" pitchFamily="34" charset="-122"/>
+                <a:cs typeface="Arial" pitchFamily="34" charset="-120"/>
+              </a:rPr>
+              <a:t>PEG-F v1: tái hiện được, nhưng cùng cấu hình chỉ +0.49 HOTA; 2 lần đổi ID quyết định bảng.</a:t>
+            </a:r>
+            <a:endParaRPr lang="en-US" sz="1500" dirty="0"/>
+          </a:p>
+          <a:p>
+            <a:pPr marL="342900" indent="-342900">
+              <a:spcAft>
+                <a:spcPts val="800"/>
+              </a:spcAft>
+              <a:buSzPct val="100000"/>
+              <a:buChar char="•"/>
+            </a:pPr>
+            <a:r>
+              <a:rPr lang="en-US" sz="1500" dirty="0">
+                <a:solidFill>
+                  <a:srgbClr val="F2F2F2"/>
+                </a:solidFill>
+                <a:latin typeface="Arial" pitchFamily="34" charset="0"/>
+                <a:ea typeface="Arial" pitchFamily="34" charset="-122"/>
+                <a:cs typeface="Arial" pitchFamily="34" charset="-120"/>
+              </a:rPr>
+              <a:t>PEG-F v2: Table I đúng 14/14, nhưng Thạch chỉnh và chọn trên test. Chọn lại, rồi tune lại từ đầu trên val: không method nào qua → giữ PEG.</a:t>
+            </a:r>
+            <a:endParaRPr lang="en-US" sz="1500" dirty="0"/>
+          </a:p>
+          <a:p>
+            <a:pPr marL="342900" indent="-342900">
+              <a:spcAft>
+                <a:spcPts val="800"/>
+              </a:spcAft>
+              <a:buSzPct val="100000"/>
+              <a:buChar char="•"/>
+            </a:pPr>
+            <a:r>
+              <a:rPr lang="en-US" sz="1500" dirty="0">
+                <a:solidFill>
+                  <a:srgbClr val="F2F2F2"/>
+                </a:solidFill>
+                <a:latin typeface="Arial" pitchFamily="34" charset="0"/>
+                <a:ea typeface="Arial" pitchFamily="34" charset="-122"/>
+                <a:cs typeface="Arial" pitchFamily="34" charset="-120"/>
+              </a:rPr>
+              <a:t>v2: M1 × M5 làm Table III sụt (76.2 → 53.6 test, 67.6 → 37.1 val): box trượt ngang.</a:t>
+            </a:r>
+            <a:endParaRPr lang="en-US" sz="1500" dirty="0"/>
+          </a:p>
+          <a:p>
+            <a:pPr marL="342900" indent="-342900">
+              <a:spcAft>
+                <a:spcPts val="800"/>
+              </a:spcAft>
+              <a:buSzPct val="100000"/>
+              <a:buChar char="•"/>
+            </a:pPr>
+            <a:r>
+              <a:rPr lang="en-US" sz="1500" dirty="0">
+                <a:solidFill>
+                  <a:srgbClr val="F2F2F2"/>
+                </a:solidFill>
+                <a:latin typeface="Arial" pitchFamily="34" charset="0"/>
+                <a:ea typeface="Arial" pitchFamily="34" charset="-122"/>
+                <a:cs typeface="Arial" pitchFamily="34" charset="-120"/>
+              </a:rPr>
+              <a:t>PEG+: Rcv test +5.6, val −0.4, gộp +3.2: chỉ giúp khi box co lại lúc coast.</a:t>
+            </a:r>
+            <a:endParaRPr lang="en-US" sz="1500" dirty="0"/>
+          </a:p>
+          <a:p>
+            <a:pPr marL="342900" indent="-342900">
+              <a:spcAft>
+                <a:spcPts val="800"/>
+              </a:spcAft>
+              <a:buSzPct val="100000"/>
+              <a:buChar char="•"/>
+            </a:pPr>
+            <a:r>
+              <a:rPr lang="en-US" sz="1500" dirty="0">
+                <a:solidFill>
+                  <a:srgbClr val="F2F2F2"/>
+                </a:solidFill>
+                <a:latin typeface="Arial" pitchFamily="34" charset="0"/>
+                <a:ea typeface="Arial" pitchFamily="34" charset="-122"/>
+                <a:cs typeface="Arial" pitchFamily="34" charset="-120"/>
+              </a:rPr>
+              <a:t>Table I một mình dễ đánh lừa → luôn đo đủ 3 bảng, chọn trên val, báo test 1 lần.</a:t>
+            </a:r>
+            <a:endParaRPr lang="en-US" sz="1500" dirty="0"/>
+          </a:p>
+        </p:txBody>
+      </p:sp>
+      <p:sp>
+        <p:nvSpPr>
+          <p:cNvPr id="7" name="Shape 5"/>
+          <p:cNvSpPr/>
+          <p:nvPr/>
+        </p:nvSpPr>
+        <p:spPr>
+          <a:xfrm>
+            <a:off x="6199632" y="1508760"/>
+            <a:ext cx="5440680" cy="4480560"/>
+          </a:xfrm>
+          <a:prstGeom prst="roundRect">
+            <a:avLst>
+              <a:gd name="adj" fmla="val 2449"/>
+            </a:avLst>
+          </a:prstGeom>
+          <a:solidFill>
+            <a:srgbClr val="2B2F36"/>
+          </a:solidFill>
+          <a:ln w="12700">
+            <a:solidFill>
+              <a:srgbClr val="2B2F36"/>
+            </a:solidFill>
+            <a:prstDash val="solid"/>
+          </a:ln>
+        </p:spPr>
+      </p:sp>
+      <p:sp>
+        <p:nvSpPr>
+          <p:cNvPr id="8" name="Text 6"/>
+          <p:cNvSpPr txBox="1"/>
+          <p:nvPr/>
+        </p:nvSpPr>
+        <p:spPr>
+          <a:xfrm>
+            <a:off x="6473952" y="1600200"/>
+            <a:ext cx="4937760" cy="365760"/>
+          </a:xfrm>
+          <a:prstGeom prst="rect">
+            <a:avLst/>
+          </a:prstGeom>
+          <a:noFill/>
+          <a:ln/>
+        </p:spPr>
+        <p:txBody>
+          <a:bodyPr wrap="square" lIns="0" tIns="0" rIns="0" bIns="0" rtlCol="0" anchor="t"/>
+          <a:lstStyle/>
+          <a:p>
+            <a:pPr indent="0" marL="0">
+              <a:buNone/>
+            </a:pPr>
+            <a:r>
+              <a:rPr lang="en-US" sz="2000" b="1" dirty="0">
+                <a:solidFill>
+                  <a:srgbClr val="19A35F"/>
+                </a:solidFill>
+                <a:latin typeface="Arial" pitchFamily="34" charset="0"/>
+                <a:ea typeface="Arial" pitchFamily="34" charset="-122"/>
+                <a:cs typeface="Arial" pitchFamily="34" charset="-120"/>
+              </a:rPr>
+              <a:t>Hướng tiếp theo</a:t>
+            </a:r>
+            <a:endParaRPr lang="en-US" sz="2000" dirty="0"/>
+          </a:p>
+        </p:txBody>
+      </p:sp>
+      <p:sp>
+        <p:nvSpPr>
+          <p:cNvPr id="9" name="Text 7"/>
+          <p:cNvSpPr txBox="1"/>
+          <p:nvPr/>
+        </p:nvSpPr>
+        <p:spPr>
+          <a:xfrm>
+            <a:off x="6473952" y="2103120"/>
+            <a:ext cx="4937760" cy="3749040"/>
+          </a:xfrm>
+          <a:prstGeom prst="rect">
+            <a:avLst/>
+          </a:prstGeom>
+          <a:noFill/>
+          <a:ln/>
+        </p:spPr>
+        <p:txBody>
+          <a:bodyPr wrap="square" lIns="0" tIns="0" rIns="0" bIns="0" rtlCol="0" anchor="t"/>
+          <a:lstStyle/>
+          <a:p>
+            <a:pPr marL="342900" indent="-342900">
+              <a:spcAft>
+                <a:spcPts val="1800"/>
+              </a:spcAft>
+              <a:buSzPct val="100000"/>
+              <a:buFont typeface="+mj-lt"/>
+              <a:buAutoNum type="arabicPeriod" startAt="1"/>
+            </a:pPr>
+            <a:r>
+              <a:rPr lang="en-US" sz="1900" dirty="0">
+                <a:solidFill>
+                  <a:srgbClr val="F2F2F2"/>
+                </a:solidFill>
+                <a:latin typeface="Arial" pitchFamily="34" charset="0"/>
+                <a:ea typeface="Arial" pitchFamily="34" charset="-122"/>
+                <a:cs typeface="Arial" pitchFamily="34" charset="-120"/>
+              </a:rPr>
+              <a:t>Chọn bằng khoảng tin cậy hoặc cross-validation, không bằng ngưỡng cứng</a:t>
+            </a:r>
+            <a:endParaRPr lang="en-US" sz="1900" dirty="0"/>
+          </a:p>
+          <a:p>
+            <a:pPr marL="342900" indent="-342900">
+              <a:spcAft>
+                <a:spcPts val="1800"/>
+              </a:spcAft>
+              <a:buSzPct val="100000"/>
+              <a:buFont typeface="+mj-lt"/>
+              <a:buAutoNum type="arabicPeriod" startAt="1"/>
+            </a:pPr>
+            <a:r>
+              <a:rPr lang="en-US" sz="1900" dirty="0">
+                <a:solidFill>
+                  <a:srgbClr val="F2F2F2"/>
+                </a:solidFill>
+                <a:latin typeface="Arial" pitchFamily="34" charset="0"/>
+                <a:ea typeface="Arial" pitchFamily="34" charset="-122"/>
+                <a:cs typeface="Arial" pitchFamily="34" charset="-120"/>
+              </a:rPr>
+              <a:t>Thêm dữ liệu val: hiện 1–2 video quyết định mọi mức tăng</a:t>
+            </a:r>
+            <a:endParaRPr lang="en-US" sz="1900" dirty="0"/>
+          </a:p>
+          <a:p>
+            <a:pPr marL="342900" indent="-342900">
+              <a:spcAft>
+                <a:spcPts val="1800"/>
+              </a:spcAft>
+              <a:buSzPct val="100000"/>
+              <a:buFont typeface="+mj-lt"/>
+              <a:buAutoNum type="arabicPeriod" startAt="1"/>
+            </a:pPr>
+            <a:r>
+              <a:rPr lang="en-US" sz="1900" dirty="0">
+                <a:solidFill>
+                  <a:srgbClr val="F2F2F2"/>
+                </a:solidFill>
+                <a:latin typeface="Arial" pitchFamily="34" charset="0"/>
+                <a:ea typeface="Arial" pitchFamily="34" charset="-122"/>
+                <a:cs typeface="Arial" pitchFamily="34" charset="-120"/>
+              </a:rPr>
+              <a:t>Neo đèn (M5) với độ tin không phụ thuộc độ bất định Kalman</a:t>
+            </a:r>
+            <a:endParaRPr lang="en-US" sz="1900" dirty="0"/>
+          </a:p>
+          <a:p>
+            <a:pPr marL="342900" indent="-342900">
+              <a:spcAft>
+                <a:spcPts val="1800"/>
+              </a:spcAft>
+              <a:buSzPct val="100000"/>
+              <a:buFont typeface="+mj-lt"/>
+              <a:buAutoNum type="arabicPeriod" startAt="1"/>
+            </a:pPr>
+            <a:r>
+              <a:rPr lang="en-US" sz="1900" dirty="0">
+                <a:solidFill>
+                  <a:srgbClr val="F2F2F2"/>
+                </a:solidFill>
+                <a:latin typeface="Arial" pitchFamily="34" charset="0"/>
+                <a:ea typeface="Arial" pitchFamily="34" charset="-122"/>
+                <a:cs typeface="Arial" pitchFamily="34" charset="-120"/>
+              </a:rPr>
+              <a:t>M6 (tone-map): thử lại khi val có nhiều ca chói quanh người hơn</a:t>
+            </a:r>
+            <a:endParaRPr lang="en-US" sz="1900" dirty="0"/>
+          </a:p>
+        </p:txBody>
+      </p:sp>
+      <p:sp>
+        <p:nvSpPr>
+          <p:cNvPr id="10" name="Shape 8"/>
+          <p:cNvSpPr/>
+          <p:nvPr/>
+        </p:nvSpPr>
+        <p:spPr>
+          <a:xfrm>
+            <a:off x="9646920" y="274320"/>
+            <a:ext cx="1993392" cy="329184"/>
+          </a:xfrm>
+          <a:prstGeom prst="roundRect">
+            <a:avLst>
+              <a:gd name="adj" fmla="val 50000"/>
+            </a:avLst>
+          </a:prstGeom>
+          <a:solidFill>
+            <a:srgbClr val="19A35F">
+              <a:alpha val="22000"/>
+            </a:srgbClr>
+          </a:solidFill>
+          <a:ln w="15875">
+            <a:solidFill>
+              <a:srgbClr val="19A35F"/>
+            </a:solidFill>
+            <a:prstDash val="solid"/>
+          </a:ln>
+        </p:spPr>
+      </p:sp>
+      <p:sp>
+        <p:nvSpPr>
+          <p:cNvPr id="11" name="Text 9"/>
+          <p:cNvSpPr txBox="1"/>
+          <p:nvPr/>
+        </p:nvSpPr>
+        <p:spPr>
+          <a:xfrm>
+            <a:off x="9646920" y="274320"/>
+            <a:ext cx="1993392" cy="329184"/>
+          </a:xfrm>
+          <a:prstGeom prst="rect">
+            <a:avLst/>
+          </a:prstGeom>
+          <a:noFill/>
+          <a:ln/>
+        </p:spPr>
+        <p:txBody>
+          <a:bodyPr wrap="square" lIns="0" tIns="0" rIns="0" bIns="0" rtlCol="0" anchor="ctr"/>
+          <a:lstStyle/>
+          <a:p>
+            <a:pPr algn="ctr" indent="0" marL="0">
+              <a:buNone/>
+            </a:pPr>
+            <a:r>
+              <a:rPr lang="en-US" sz="1100" b="1" dirty="0">
+                <a:solidFill>
+                  <a:srgbClr val="F2F2F2"/>
+                </a:solidFill>
+                <a:latin typeface="Arial" pitchFamily="34" charset="0"/>
+                <a:ea typeface="Arial" pitchFamily="34" charset="-122"/>
+                <a:cs typeface="Arial" pitchFamily="34" charset="-120"/>
+              </a:rPr>
+              <a:t>NGƯỜI 2 · PEG+</a:t>
+            </a:r>
+            <a:endParaRPr lang="en-US" sz="1100" dirty="0"/>
+          </a:p>
+        </p:txBody>
+      </p:sp>
+      <p:sp>
+        <p:nvSpPr>
+          <p:cNvPr id="12" name="Text 10"/>
+          <p:cNvSpPr txBox="1"/>
+          <p:nvPr/>
+        </p:nvSpPr>
+        <p:spPr>
+          <a:xfrm>
+            <a:off x="11155680" y="6446520"/>
+            <a:ext cx="502920" cy="274320"/>
+          </a:xfrm>
+          <a:prstGeom prst="rect">
+            <a:avLst/>
+          </a:prstGeom>
+          <a:noFill/>
+          <a:ln/>
+        </p:spPr>
+        <p:txBody>
+          <a:bodyPr wrap="square" lIns="0" tIns="0" rIns="0" bIns="0" rtlCol="0" anchor="ctr"/>
+          <a:lstStyle/>
+          <a:p>
+            <a:pPr algn="r" indent="0" marL="0">
+              <a:buNone/>
+            </a:pPr>
+            <a:r>
+              <a:rPr lang="en-US" sz="1100" dirty="0">
+                <a:solidFill>
+                  <a:srgbClr val="A3A8B0"/>
+                </a:solidFill>
+                <a:latin typeface="Arial" pitchFamily="34" charset="0"/>
+                <a:ea typeface="Arial" pitchFamily="34" charset="-122"/>
+                <a:cs typeface="Arial" pitchFamily="34" charset="-120"/>
+              </a:rPr>
+              <a:t>34</a:t>
+            </a:r>
+            <a:endParaRPr lang="en-US" sz="1100" dirty="0"/>
+          </a:p>
+        </p:txBody>
+      </p:sp>
+    </p:spTree>
+  </p:cSld>
+  <p:clrMapOvr>
+    <a:masterClrMapping/>
+  </p:clrMapOvr>
+</p:sld>
+</file>
+
+<file path=ppt/slides/slide35.xml><?xml version="1.0" encoding="utf-8"?>
+<p:sld xmlns:a="http://schemas.openxmlformats.org/drawingml/2006/main" xmlns:r="http://schemas.openxmlformats.org/officeDocument/2006/relationships" xmlns:p="http://schemas.openxmlformats.org/presentationml/2006/main">
+  <p:cSld name="Slide 35">
+    <p:bg>
+      <p:bgPr>
+        <a:solidFill>
+          <a:srgbClr val="15171B"/>
+        </a:solidFill>
+      </p:bgPr>
+    </p:bg>
+    <p:spTree>
+      <p:nvGrpSpPr>
+        <p:cNvPr id="1" name=""/>
+        <p:cNvGrpSpPr/>
+        <p:nvPr/>
+      </p:nvGrpSpPr>
+      <p:grpSpPr>
+        <a:xfrm>
+          <a:off x="0" y="0"/>
+          <a:ext cx="0" cy="0"/>
+          <a:chOff x="0" y="0"/>
+          <a:chExt cx="0" cy="0"/>
+        </a:xfrm>
+      </p:grpSpPr>
+      <p:sp>
+        <p:nvSpPr>
           <p:cNvPr id="2" name="Shape 0"/>
           <p:cNvSpPr/>
           <p:nvPr/>
@@ -34228,7 +37651,7 @@
                 <a:ea typeface="Arial" pitchFamily="34" charset="-122"/>
                 <a:cs typeface="Arial" pitchFamily="34" charset="-120"/>
               </a:rPr>
-              <a:t>34</a:t>
+              <a:t>35</a:t>
             </a:r>
             <a:endParaRPr lang="en-US" sz="1100" dirty="0"/>
           </a:p>

</xml_diff>

<commit_message>
Thach v2 tuning: test numbers per component (comparison only), slide 33 test column
Co-Authored-By: Claude Opus 5.5 <noreply@anthropic.com>
Claude-Session: https://claude.ai/code/session_01HL8W3BdZcU7eyXJvRAQqfT
</commit_message>
<xml_diff>
--- a/results/peg_f/PEG_F.pptx
+++ b/results/peg_f/PEG_F.pptx
@@ -2824,7 +2824,7 @@
           <a:p>
             <a:r>
               <a:rPr lang="en-US" dirty="0"/>
-              <a:t>Chọn lại trên val chưa đủ, vì các tham số bên trong method vẫn là số Thạch đã chỉnh trên test. Nên bọn mình tune lại từ đầu, chỉ trên val, với luật viết trước và đưa lên git trước khi chạy. Điểm xuất phát là PEG: bọn mình chép lại logic đổi ID gốc của PEG vào code của Thạch và kiểm tra là khi tắt hết method thì ra đúng từng số của PEG. Phần đổi ID mà Thạch viết lại cũng thành một thành phần để thử. Mỗi vòng, mỗi thành phần được thử với vài giá trị tham số, vòng đầu tổng cộng 26 lượt. Bảng này là giá trị tốt nhất của từng thành phần ở vòng đầu. Chỉ có hai thứ tăng quá ngưỡng: cone của M1, cộng 1.73, và phần hãm vận tốc, cộng 1.32. Nhưng khi bỏ đi một video hoặc một lần chói có lợi nhất, cone còn −0.01 và hãm vận tốc còn −0.60: toàn bộ mức tăng của cone nằm ở hai video, 156 và 147, còn của hãm vận tốc nằm ở một lần chói trong video 332. Phần nở vùng bất định, Re-ID và pool track ngủ không đổi gì khi đứng một mình; neo đèn và tone-map làm giảm. Nên không thành phần nào được nhận, cấu hình cuối cùng chính là PEG, và test một lần cho nó ra đúng số PEG: 68.34, 61.41 và 76.2.</a:t>
+              <a:t>Chọn lại trên val chưa đủ, vì các tham số bên trong method vẫn là số Thạch đã chỉnh trên test. Nên bọn mình tune lại từ đầu, chỉ trên val, với luật viết trước và đưa lên git trước khi chạy. Điểm xuất phát là PEG: bọn mình chép lại logic đổi ID gốc của PEG vào code của Thạch và kiểm tra là khi tắt hết method thì ra đúng từng số của PEG. Phần đổi ID mà Thạch viết lại cũng thành một thành phần để thử. Mỗi vòng, mỗi thành phần được thử với vài giá trị tham số, vòng đầu tổng cộng 26 lượt. Bảng này là giá trị tốt nhất của từng thành phần ở vòng đầu. Chỉ có hai thứ tăng quá ngưỡng: cone của M1, cộng 1.73, và phần hãm vận tốc, cộng 1.32. Nhưng khi bỏ đi một video hoặc một lần chói có lợi nhất, cone còn −0.01 và hãm vận tốc còn −0.60: toàn bộ mức tăng của cone nằm ở hai video, 156 và 147, còn của hãm vận tốc nằm ở một lần chói trong video 332. Phần nở vùng bất định, Re-ID và pool track ngủ không đổi gì khi đứng một mình; neo đèn và tone-map làm giảm. Nên không thành phần nào được nhận, cấu hình cuối cùng chính là PEG, và test một lần cho nó ra đúng số PEG: 68.34, 61.41 và 76.2. Cột cuối là số test của từng thành phần, chạy sau khi đã chốt, chỉ để đối chiếu. Trên test cũng vậy: M6 và phần đổi ID viết lại tăng gần như chỉ nhờ sửa đúng một lần đổi ID ở video 129, lần đó đáng hai mươi ba điểm HOTA ở video ấy; cone tăng chủ yếu nhờ video 204; còn hãm vận tốc giảm tám điểm rưỡi, nên val loại nó là đúng. Lưu ý là số test của M6 và phần đổi ID bị lạc quan, vì Thạch đã chỉnh chúng trên chính tập test.</a:t>
             </a:r>
             <a:endParaRPr lang="en-US" dirty="0"/>
           </a:p>
@@ -33585,7 +33585,7 @@
         <p:spPr>
           <a:xfrm>
             <a:off x="777240" y="1691640"/>
-            <a:ext cx="3200400" cy="274320"/>
+            <a:ext cx="2834640" cy="274320"/>
           </a:xfrm>
           <a:prstGeom prst="rect">
             <a:avLst/>
@@ -33623,8 +33623,8 @@
         </p:nvSpPr>
         <p:spPr>
           <a:xfrm>
-            <a:off x="3977640" y="1691640"/>
-            <a:ext cx="2011680" cy="274320"/>
+            <a:off x="3611880" y="1691640"/>
+            <a:ext cx="1828800" cy="274320"/>
           </a:xfrm>
           <a:prstGeom prst="rect">
             <a:avLst/>
@@ -33662,8 +33662,8 @@
         </p:nvSpPr>
         <p:spPr>
           <a:xfrm>
-            <a:off x="5989320" y="1691640"/>
-            <a:ext cx="1005840" cy="274320"/>
+            <a:off x="5440680" y="1691640"/>
+            <a:ext cx="868680" cy="274320"/>
           </a:xfrm>
           <a:prstGeom prst="rect">
             <a:avLst/>
@@ -33701,8 +33701,8 @@
         </p:nvSpPr>
         <p:spPr>
           <a:xfrm>
-            <a:off x="6995160" y="1691640"/>
-            <a:ext cx="1005840" cy="274320"/>
+            <a:off x="6309360" y="1691640"/>
+            <a:ext cx="868680" cy="274320"/>
           </a:xfrm>
           <a:prstGeom prst="rect">
             <a:avLst/>
@@ -33740,8 +33740,47 @@
         </p:nvSpPr>
         <p:spPr>
           <a:xfrm>
+            <a:off x="7178040" y="1691640"/>
+            <a:ext cx="822960" cy="274320"/>
+          </a:xfrm>
+          <a:prstGeom prst="rect">
+            <a:avLst/>
+          </a:prstGeom>
+          <a:noFill/>
+          <a:ln/>
+        </p:spPr>
+        <p:txBody>
+          <a:bodyPr wrap="square" lIns="0" tIns="0" rIns="0" bIns="0" rtlCol="0" anchor="t"/>
+          <a:lstStyle/>
+          <a:p>
+            <a:pPr algn="ctr" indent="0" marL="0">
+              <a:buNone/>
+            </a:pPr>
+            <a:r>
+              <a:rPr lang="en-US" sz="1100" b="1" dirty="0">
+                <a:solidFill>
+                  <a:srgbClr val="A3A8B0"/>
+                </a:solidFill>
+                <a:latin typeface="Arial" pitchFamily="34" charset="0"/>
+                <a:ea typeface="Arial" pitchFamily="34" charset="-122"/>
+                <a:cs typeface="Arial" pitchFamily="34" charset="-120"/>
+              </a:rPr>
+              <a:t>ΔT3 Rcv</a:t>
+            </a:r>
+            <a:endParaRPr lang="en-US" sz="1100" dirty="0"/>
+          </a:p>
+        </p:txBody>
+      </p:sp>
+      <p:sp>
+        <p:nvSpPr>
+          <p:cNvPr id="10" name="Text 8"/>
+          <p:cNvSpPr txBox="1"/>
+          <p:nvPr/>
+        </p:nvSpPr>
+        <p:spPr>
+          <a:xfrm>
             <a:off x="8001000" y="1691640"/>
-            <a:ext cx="960120" cy="274320"/>
+            <a:ext cx="914400" cy="274320"/>
           </a:xfrm>
           <a:prstGeom prst="rect">
             <a:avLst/>
@@ -33765,7 +33804,7 @@
                 <a:ea typeface="Arial" pitchFamily="34" charset="-122"/>
                 <a:cs typeface="Arial" pitchFamily="34" charset="-120"/>
               </a:rPr>
-              <a:t>ΔT3 Rcv</a:t>
+              <a:t>tổng (val)</a:t>
             </a:r>
             <a:endParaRPr lang="en-US" sz="1100" dirty="0"/>
           </a:p>
@@ -33773,14 +33812,14 @@
       </p:sp>
       <p:sp>
         <p:nvSpPr>
-          <p:cNvPr id="10" name="Text 8"/>
-          <p:cNvSpPr txBox="1"/>
-          <p:nvPr/>
-        </p:nvSpPr>
-        <p:spPr>
-          <a:xfrm>
-            <a:off x="8961120" y="1691640"/>
-            <a:ext cx="960120" cy="274320"/>
+          <p:cNvPr id="11" name="Text 9"/>
+          <p:cNvSpPr txBox="1"/>
+          <p:nvPr/>
+        </p:nvSpPr>
+        <p:spPr>
+          <a:xfrm>
+            <a:off x="8915400" y="1691640"/>
+            <a:ext cx="1554480" cy="274320"/>
           </a:xfrm>
           <a:prstGeom prst="rect">
             <a:avLst/>
@@ -33804,7 +33843,7 @@
                 <a:ea typeface="Arial" pitchFamily="34" charset="-122"/>
                 <a:cs typeface="Arial" pitchFamily="34" charset="-120"/>
               </a:rPr>
-              <a:t>tổng</a:t>
+              <a:t>bỏ 1 video / lần chói</a:t>
             </a:r>
             <a:endParaRPr lang="en-US" sz="1100" dirty="0"/>
           </a:p>
@@ -33812,14 +33851,14 @@
       </p:sp>
       <p:sp>
         <p:nvSpPr>
-          <p:cNvPr id="11" name="Text 9"/>
-          <p:cNvSpPr txBox="1"/>
-          <p:nvPr/>
-        </p:nvSpPr>
-        <p:spPr>
-          <a:xfrm>
-            <a:off x="9921240" y="1691640"/>
-            <a:ext cx="1691640" cy="274320"/>
+          <p:cNvPr id="12" name="Text 10"/>
+          <p:cNvSpPr txBox="1"/>
+          <p:nvPr/>
+        </p:nvSpPr>
+        <p:spPr>
+          <a:xfrm>
+            <a:off x="10469880" y="1691640"/>
+            <a:ext cx="1143000" cy="274320"/>
           </a:xfrm>
           <a:prstGeom prst="rect">
             <a:avLst/>
@@ -33843,7 +33882,7 @@
                 <a:ea typeface="Arial" pitchFamily="34" charset="-122"/>
                 <a:cs typeface="Arial" pitchFamily="34" charset="-120"/>
               </a:rPr>
-              <a:t>bỏ 1 video / lần chói</a:t>
+              <a:t>test (đối chiếu)</a:t>
             </a:r>
             <a:endParaRPr lang="en-US" sz="1100" dirty="0"/>
           </a:p>
@@ -33851,7 +33890,7 @@
       </p:sp>
       <p:sp>
         <p:nvSpPr>
-          <p:cNvPr id="12" name="Shape 10"/>
+          <p:cNvPr id="13" name="Shape 11"/>
           <p:cNvSpPr/>
           <p:nvPr/>
         </p:nvSpPr>
@@ -33878,14 +33917,14 @@
       </p:sp>
       <p:sp>
         <p:nvSpPr>
-          <p:cNvPr id="13" name="Text 11"/>
+          <p:cNvPr id="14" name="Text 12"/>
           <p:cNvSpPr txBox="1"/>
           <p:nvPr/>
         </p:nvSpPr>
         <p:spPr>
           <a:xfrm>
             <a:off x="777240" y="2011680"/>
-            <a:ext cx="3200400" cy="338328"/>
+            <a:ext cx="2834640" cy="338328"/>
           </a:xfrm>
           <a:prstGeom prst="rect">
             <a:avLst/>
@@ -33917,14 +33956,14 @@
       </p:sp>
       <p:sp>
         <p:nvSpPr>
-          <p:cNvPr id="14" name="Text 12"/>
-          <p:cNvSpPr txBox="1"/>
-          <p:nvPr/>
-        </p:nvSpPr>
-        <p:spPr>
-          <a:xfrm>
-            <a:off x="3977640" y="2011680"/>
-            <a:ext cx="2011680" cy="338328"/>
+          <p:cNvPr id="15" name="Text 13"/>
+          <p:cNvSpPr txBox="1"/>
+          <p:nvPr/>
+        </p:nvSpPr>
+        <p:spPr>
+          <a:xfrm>
+            <a:off x="3611880" y="2011680"/>
+            <a:ext cx="1828800" cy="338328"/>
           </a:xfrm>
           <a:prstGeom prst="rect">
             <a:avLst/>
@@ -33956,14 +33995,14 @@
       </p:sp>
       <p:sp>
         <p:nvSpPr>
-          <p:cNvPr id="15" name="Text 13"/>
-          <p:cNvSpPr txBox="1"/>
-          <p:nvPr/>
-        </p:nvSpPr>
-        <p:spPr>
-          <a:xfrm>
-            <a:off x="5989320" y="2011680"/>
-            <a:ext cx="1005840" cy="338328"/>
+          <p:cNvPr id="16" name="Text 14"/>
+          <p:cNvSpPr txBox="1"/>
+          <p:nvPr/>
+        </p:nvSpPr>
+        <p:spPr>
+          <a:xfrm>
+            <a:off x="5440680" y="2011680"/>
+            <a:ext cx="868680" cy="338328"/>
           </a:xfrm>
           <a:prstGeom prst="rect">
             <a:avLst/>
@@ -33995,14 +34034,14 @@
       </p:sp>
       <p:sp>
         <p:nvSpPr>
-          <p:cNvPr id="16" name="Text 14"/>
-          <p:cNvSpPr txBox="1"/>
-          <p:nvPr/>
-        </p:nvSpPr>
-        <p:spPr>
-          <a:xfrm>
-            <a:off x="6995160" y="2011680"/>
-            <a:ext cx="1005840" cy="338328"/>
+          <p:cNvPr id="17" name="Text 15"/>
+          <p:cNvSpPr txBox="1"/>
+          <p:nvPr/>
+        </p:nvSpPr>
+        <p:spPr>
+          <a:xfrm>
+            <a:off x="6309360" y="2011680"/>
+            <a:ext cx="868680" cy="338328"/>
           </a:xfrm>
           <a:prstGeom prst="rect">
             <a:avLst/>
@@ -34034,14 +34073,53 @@
       </p:sp>
       <p:sp>
         <p:nvSpPr>
-          <p:cNvPr id="17" name="Text 15"/>
+          <p:cNvPr id="18" name="Text 16"/>
+          <p:cNvSpPr txBox="1"/>
+          <p:nvPr/>
+        </p:nvSpPr>
+        <p:spPr>
+          <a:xfrm>
+            <a:off x="7178040" y="2011680"/>
+            <a:ext cx="822960" cy="338328"/>
+          </a:xfrm>
+          <a:prstGeom prst="rect">
+            <a:avLst/>
+          </a:prstGeom>
+          <a:noFill/>
+          <a:ln/>
+        </p:spPr>
+        <p:txBody>
+          <a:bodyPr wrap="square" lIns="0" tIns="0" rIns="0" bIns="0" rtlCol="0" anchor="ctr"/>
+          <a:lstStyle/>
+          <a:p>
+            <a:pPr algn="ctr" indent="0" marL="0">
+              <a:buNone/>
+            </a:pPr>
+            <a:r>
+              <a:rPr lang="en-US" sz="1200" dirty="0">
+                <a:solidFill>
+                  <a:srgbClr val="F2F2F2"/>
+                </a:solidFill>
+                <a:latin typeface="Arial" pitchFamily="34" charset="0"/>
+                <a:ea typeface="Arial" pitchFamily="34" charset="-122"/>
+                <a:cs typeface="Arial" pitchFamily="34" charset="-120"/>
+              </a:rPr>
+              <a:t>±0.0</a:t>
+            </a:r>
+            <a:endParaRPr lang="en-US" sz="1200" dirty="0"/>
+          </a:p>
+        </p:txBody>
+      </p:sp>
+      <p:sp>
+        <p:nvSpPr>
+          <p:cNvPr id="19" name="Text 17"/>
           <p:cNvSpPr txBox="1"/>
           <p:nvPr/>
         </p:nvSpPr>
         <p:spPr>
           <a:xfrm>
             <a:off x="8001000" y="2011680"/>
-            <a:ext cx="960120" cy="338328"/>
+            <a:ext cx="914400" cy="338328"/>
           </a:xfrm>
           <a:prstGeom prst="rect">
             <a:avLst/>
@@ -34057,15 +34135,54 @@
               <a:buNone/>
             </a:pPr>
             <a:r>
+              <a:rPr lang="en-US" sz="1200" b="1" dirty="0">
+                <a:solidFill>
+                  <a:srgbClr val="19A35F"/>
+                </a:solidFill>
+                <a:latin typeface="Arial" pitchFamily="34" charset="0"/>
+                <a:ea typeface="Arial" pitchFamily="34" charset="-122"/>
+                <a:cs typeface="Arial" pitchFamily="34" charset="-120"/>
+              </a:rPr>
+              <a:t>+1.73</a:t>
+            </a:r>
+            <a:endParaRPr lang="en-US" sz="1200" dirty="0"/>
+          </a:p>
+        </p:txBody>
+      </p:sp>
+      <p:sp>
+        <p:nvSpPr>
+          <p:cNvPr id="20" name="Text 18"/>
+          <p:cNvSpPr txBox="1"/>
+          <p:nvPr/>
+        </p:nvSpPr>
+        <p:spPr>
+          <a:xfrm>
+            <a:off x="8915400" y="2011680"/>
+            <a:ext cx="1554480" cy="338328"/>
+          </a:xfrm>
+          <a:prstGeom prst="rect">
+            <a:avLst/>
+          </a:prstGeom>
+          <a:noFill/>
+          <a:ln/>
+        </p:spPr>
+        <p:txBody>
+          <a:bodyPr wrap="square" lIns="0" tIns="0" rIns="0" bIns="0" rtlCol="0" anchor="ctr"/>
+          <a:lstStyle/>
+          <a:p>
+            <a:pPr algn="ctr" indent="0" marL="0">
+              <a:buNone/>
+            </a:pPr>
+            <a:r>
               <a:rPr lang="en-US" sz="1200" dirty="0">
                 <a:solidFill>
-                  <a:srgbClr val="F2F2F2"/>
-                </a:solidFill>
-                <a:latin typeface="Arial" pitchFamily="34" charset="0"/>
-                <a:ea typeface="Arial" pitchFamily="34" charset="-122"/>
-                <a:cs typeface="Arial" pitchFamily="34" charset="-120"/>
-              </a:rPr>
-              <a:t>±0.0</a:t>
+                  <a:srgbClr val="E66767"/>
+                </a:solidFill>
+                <a:latin typeface="Arial" pitchFamily="34" charset="0"/>
+                <a:ea typeface="Arial" pitchFamily="34" charset="-122"/>
+                <a:cs typeface="Arial" pitchFamily="34" charset="-120"/>
+              </a:rPr>
+              <a:t>còn −0.01</a:t>
             </a:r>
             <a:endParaRPr lang="en-US" sz="1200" dirty="0"/>
           </a:p>
@@ -34073,14 +34190,14 @@
       </p:sp>
       <p:sp>
         <p:nvSpPr>
-          <p:cNvPr id="18" name="Text 16"/>
-          <p:cNvSpPr txBox="1"/>
-          <p:nvPr/>
-        </p:nvSpPr>
-        <p:spPr>
-          <a:xfrm>
-            <a:off x="8961120" y="2011680"/>
-            <a:ext cx="960120" cy="338328"/>
+          <p:cNvPr id="21" name="Text 19"/>
+          <p:cNvSpPr txBox="1"/>
+          <p:nvPr/>
+        </p:nvSpPr>
+        <p:spPr>
+          <a:xfrm>
+            <a:off x="10469880" y="2011680"/>
+            <a:ext cx="1143000" cy="338328"/>
           </a:xfrm>
           <a:prstGeom prst="rect">
             <a:avLst/>
@@ -34096,15 +34213,15 @@
               <a:buNone/>
             </a:pPr>
             <a:r>
-              <a:rPr lang="en-US" sz="1200" b="1" dirty="0">
-                <a:solidFill>
-                  <a:srgbClr val="19A35F"/>
-                </a:solidFill>
-                <a:latin typeface="Arial" pitchFamily="34" charset="0"/>
-                <a:ea typeface="Arial" pitchFamily="34" charset="-122"/>
-                <a:cs typeface="Arial" pitchFamily="34" charset="-120"/>
-              </a:rPr>
-              <a:t>+1.73</a:t>
+              <a:rPr lang="en-US" sz="1200" dirty="0">
+                <a:solidFill>
+                  <a:srgbClr val="A3A8B0"/>
+                </a:solidFill>
+                <a:latin typeface="Arial" pitchFamily="34" charset="0"/>
+                <a:ea typeface="Arial" pitchFamily="34" charset="-122"/>
+                <a:cs typeface="Arial" pitchFamily="34" charset="-120"/>
+              </a:rPr>
+              <a:t>+2.53</a:t>
             </a:r>
             <a:endParaRPr lang="en-US" sz="1200" dirty="0"/>
           </a:p>
@@ -34112,46 +34229,7 @@
       </p:sp>
       <p:sp>
         <p:nvSpPr>
-          <p:cNvPr id="19" name="Text 17"/>
-          <p:cNvSpPr txBox="1"/>
-          <p:nvPr/>
-        </p:nvSpPr>
-        <p:spPr>
-          <a:xfrm>
-            <a:off x="9921240" y="2011680"/>
-            <a:ext cx="1691640" cy="338328"/>
-          </a:xfrm>
-          <a:prstGeom prst="rect">
-            <a:avLst/>
-          </a:prstGeom>
-          <a:noFill/>
-          <a:ln/>
-        </p:spPr>
-        <p:txBody>
-          <a:bodyPr wrap="square" lIns="0" tIns="0" rIns="0" bIns="0" rtlCol="0" anchor="ctr"/>
-          <a:lstStyle/>
-          <a:p>
-            <a:pPr algn="ctr" indent="0" marL="0">
-              <a:buNone/>
-            </a:pPr>
-            <a:r>
-              <a:rPr lang="en-US" sz="1200" dirty="0">
-                <a:solidFill>
-                  <a:srgbClr val="E66767"/>
-                </a:solidFill>
-                <a:latin typeface="Arial" pitchFamily="34" charset="0"/>
-                <a:ea typeface="Arial" pitchFamily="34" charset="-122"/>
-                <a:cs typeface="Arial" pitchFamily="34" charset="-120"/>
-              </a:rPr>
-              <a:t>còn −0.01</a:t>
-            </a:r>
-            <a:endParaRPr lang="en-US" sz="1200" dirty="0"/>
-          </a:p>
-        </p:txBody>
-      </p:sp>
-      <p:sp>
-        <p:nvSpPr>
-          <p:cNvPr id="20" name="Shape 18"/>
+          <p:cNvPr id="22" name="Shape 20"/>
           <p:cNvSpPr/>
           <p:nvPr/>
         </p:nvSpPr>
@@ -34178,14 +34256,14 @@
       </p:sp>
       <p:sp>
         <p:nvSpPr>
-          <p:cNvPr id="21" name="Text 19"/>
+          <p:cNvPr id="23" name="Text 21"/>
           <p:cNvSpPr txBox="1"/>
           <p:nvPr/>
         </p:nvSpPr>
         <p:spPr>
           <a:xfrm>
             <a:off x="777240" y="2395728"/>
-            <a:ext cx="3200400" cy="338328"/>
+            <a:ext cx="2834640" cy="338328"/>
           </a:xfrm>
           <a:prstGeom prst="rect">
             <a:avLst/>
@@ -34217,14 +34295,14 @@
       </p:sp>
       <p:sp>
         <p:nvSpPr>
-          <p:cNvPr id="22" name="Text 20"/>
-          <p:cNvSpPr txBox="1"/>
-          <p:nvPr/>
-        </p:nvSpPr>
-        <p:spPr>
-          <a:xfrm>
-            <a:off x="3977640" y="2395728"/>
-            <a:ext cx="2011680" cy="338328"/>
+          <p:cNvPr id="24" name="Text 22"/>
+          <p:cNvSpPr txBox="1"/>
+          <p:nvPr/>
+        </p:nvSpPr>
+        <p:spPr>
+          <a:xfrm>
+            <a:off x="3611880" y="2395728"/>
+            <a:ext cx="1828800" cy="338328"/>
           </a:xfrm>
           <a:prstGeom prst="rect">
             <a:avLst/>
@@ -34256,14 +34334,14 @@
       </p:sp>
       <p:sp>
         <p:nvSpPr>
-          <p:cNvPr id="23" name="Text 21"/>
-          <p:cNvSpPr txBox="1"/>
-          <p:nvPr/>
-        </p:nvSpPr>
-        <p:spPr>
-          <a:xfrm>
-            <a:off x="5989320" y="2395728"/>
-            <a:ext cx="1005840" cy="338328"/>
+          <p:cNvPr id="25" name="Text 23"/>
+          <p:cNvSpPr txBox="1"/>
+          <p:nvPr/>
+        </p:nvSpPr>
+        <p:spPr>
+          <a:xfrm>
+            <a:off x="5440680" y="2395728"/>
+            <a:ext cx="868680" cy="338328"/>
           </a:xfrm>
           <a:prstGeom prst="rect">
             <a:avLst/>
@@ -34295,14 +34373,14 @@
       </p:sp>
       <p:sp>
         <p:nvSpPr>
-          <p:cNvPr id="24" name="Text 22"/>
-          <p:cNvSpPr txBox="1"/>
-          <p:nvPr/>
-        </p:nvSpPr>
-        <p:spPr>
-          <a:xfrm>
-            <a:off x="6995160" y="2395728"/>
-            <a:ext cx="1005840" cy="338328"/>
+          <p:cNvPr id="26" name="Text 24"/>
+          <p:cNvSpPr txBox="1"/>
+          <p:nvPr/>
+        </p:nvSpPr>
+        <p:spPr>
+          <a:xfrm>
+            <a:off x="6309360" y="2395728"/>
+            <a:ext cx="868680" cy="338328"/>
           </a:xfrm>
           <a:prstGeom prst="rect">
             <a:avLst/>
@@ -34334,14 +34412,53 @@
       </p:sp>
       <p:sp>
         <p:nvSpPr>
-          <p:cNvPr id="25" name="Text 23"/>
+          <p:cNvPr id="27" name="Text 25"/>
+          <p:cNvSpPr txBox="1"/>
+          <p:nvPr/>
+        </p:nvSpPr>
+        <p:spPr>
+          <a:xfrm>
+            <a:off x="7178040" y="2395728"/>
+            <a:ext cx="822960" cy="338328"/>
+          </a:xfrm>
+          <a:prstGeom prst="rect">
+            <a:avLst/>
+          </a:prstGeom>
+          <a:noFill/>
+          <a:ln/>
+        </p:spPr>
+        <p:txBody>
+          <a:bodyPr wrap="square" lIns="0" tIns="0" rIns="0" bIns="0" rtlCol="0" anchor="ctr"/>
+          <a:lstStyle/>
+          <a:p>
+            <a:pPr algn="ctr" indent="0" marL="0">
+              <a:buNone/>
+            </a:pPr>
+            <a:r>
+              <a:rPr lang="en-US" sz="1200" dirty="0">
+                <a:solidFill>
+                  <a:srgbClr val="19A35F"/>
+                </a:solidFill>
+                <a:latin typeface="Arial" pitchFamily="34" charset="0"/>
+                <a:ea typeface="Arial" pitchFamily="34" charset="-122"/>
+                <a:cs typeface="Arial" pitchFamily="34" charset="-120"/>
+              </a:rPr>
+              <a:t>+1.8</a:t>
+            </a:r>
+            <a:endParaRPr lang="en-US" sz="1200" dirty="0"/>
+          </a:p>
+        </p:txBody>
+      </p:sp>
+      <p:sp>
+        <p:nvSpPr>
+          <p:cNvPr id="28" name="Text 26"/>
           <p:cNvSpPr txBox="1"/>
           <p:nvPr/>
         </p:nvSpPr>
         <p:spPr>
           <a:xfrm>
             <a:off x="8001000" y="2395728"/>
-            <a:ext cx="960120" cy="338328"/>
+            <a:ext cx="914400" cy="338328"/>
           </a:xfrm>
           <a:prstGeom prst="rect">
             <a:avLst/>
@@ -34357,15 +34474,54 @@
               <a:buNone/>
             </a:pPr>
             <a:r>
+              <a:rPr lang="en-US" sz="1200" b="1" dirty="0">
+                <a:solidFill>
+                  <a:srgbClr val="19A35F"/>
+                </a:solidFill>
+                <a:latin typeface="Arial" pitchFamily="34" charset="0"/>
+                <a:ea typeface="Arial" pitchFamily="34" charset="-122"/>
+                <a:cs typeface="Arial" pitchFamily="34" charset="-120"/>
+              </a:rPr>
+              <a:t>+1.32</a:t>
+            </a:r>
+            <a:endParaRPr lang="en-US" sz="1200" dirty="0"/>
+          </a:p>
+        </p:txBody>
+      </p:sp>
+      <p:sp>
+        <p:nvSpPr>
+          <p:cNvPr id="29" name="Text 27"/>
+          <p:cNvSpPr txBox="1"/>
+          <p:nvPr/>
+        </p:nvSpPr>
+        <p:spPr>
+          <a:xfrm>
+            <a:off x="8915400" y="2395728"/>
+            <a:ext cx="1554480" cy="338328"/>
+          </a:xfrm>
+          <a:prstGeom prst="rect">
+            <a:avLst/>
+          </a:prstGeom>
+          <a:noFill/>
+          <a:ln/>
+        </p:spPr>
+        <p:txBody>
+          <a:bodyPr wrap="square" lIns="0" tIns="0" rIns="0" bIns="0" rtlCol="0" anchor="ctr"/>
+          <a:lstStyle/>
+          <a:p>
+            <a:pPr algn="ctr" indent="0" marL="0">
+              <a:buNone/>
+            </a:pPr>
+            <a:r>
               <a:rPr lang="en-US" sz="1200" dirty="0">
                 <a:solidFill>
-                  <a:srgbClr val="19A35F"/>
-                </a:solidFill>
-                <a:latin typeface="Arial" pitchFamily="34" charset="0"/>
-                <a:ea typeface="Arial" pitchFamily="34" charset="-122"/>
-                <a:cs typeface="Arial" pitchFamily="34" charset="-120"/>
-              </a:rPr>
-              <a:t>+1.8</a:t>
+                  <a:srgbClr val="E66767"/>
+                </a:solidFill>
+                <a:latin typeface="Arial" pitchFamily="34" charset="0"/>
+                <a:ea typeface="Arial" pitchFamily="34" charset="-122"/>
+                <a:cs typeface="Arial" pitchFamily="34" charset="-120"/>
+              </a:rPr>
+              <a:t>còn −0.60</a:t>
             </a:r>
             <a:endParaRPr lang="en-US" sz="1200" dirty="0"/>
           </a:p>
@@ -34373,14 +34529,14 @@
       </p:sp>
       <p:sp>
         <p:nvSpPr>
-          <p:cNvPr id="26" name="Text 24"/>
-          <p:cNvSpPr txBox="1"/>
-          <p:nvPr/>
-        </p:nvSpPr>
-        <p:spPr>
-          <a:xfrm>
-            <a:off x="8961120" y="2395728"/>
-            <a:ext cx="960120" cy="338328"/>
+          <p:cNvPr id="30" name="Text 28"/>
+          <p:cNvSpPr txBox="1"/>
+          <p:nvPr/>
+        </p:nvSpPr>
+        <p:spPr>
+          <a:xfrm>
+            <a:off x="10469880" y="2395728"/>
+            <a:ext cx="1143000" cy="338328"/>
           </a:xfrm>
           <a:prstGeom prst="rect">
             <a:avLst/>
@@ -34396,15 +34552,15 @@
               <a:buNone/>
             </a:pPr>
             <a:r>
-              <a:rPr lang="en-US" sz="1200" b="1" dirty="0">
-                <a:solidFill>
-                  <a:srgbClr val="19A35F"/>
-                </a:solidFill>
-                <a:latin typeface="Arial" pitchFamily="34" charset="0"/>
-                <a:ea typeface="Arial" pitchFamily="34" charset="-122"/>
-                <a:cs typeface="Arial" pitchFamily="34" charset="-120"/>
-              </a:rPr>
-              <a:t>+1.32</a:t>
+              <a:rPr lang="en-US" sz="1200" dirty="0">
+                <a:solidFill>
+                  <a:srgbClr val="A3A8B0"/>
+                </a:solidFill>
+                <a:latin typeface="Arial" pitchFamily="34" charset="0"/>
+                <a:ea typeface="Arial" pitchFamily="34" charset="-122"/>
+                <a:cs typeface="Arial" pitchFamily="34" charset="-120"/>
+              </a:rPr>
+              <a:t>−8.52</a:t>
             </a:r>
             <a:endParaRPr lang="en-US" sz="1200" dirty="0"/>
           </a:p>
@@ -34412,46 +34568,7 @@
       </p:sp>
       <p:sp>
         <p:nvSpPr>
-          <p:cNvPr id="27" name="Text 25"/>
-          <p:cNvSpPr txBox="1"/>
-          <p:nvPr/>
-        </p:nvSpPr>
-        <p:spPr>
-          <a:xfrm>
-            <a:off x="9921240" y="2395728"/>
-            <a:ext cx="1691640" cy="338328"/>
-          </a:xfrm>
-          <a:prstGeom prst="rect">
-            <a:avLst/>
-          </a:prstGeom>
-          <a:noFill/>
-          <a:ln/>
-        </p:spPr>
-        <p:txBody>
-          <a:bodyPr wrap="square" lIns="0" tIns="0" rIns="0" bIns="0" rtlCol="0" anchor="ctr"/>
-          <a:lstStyle/>
-          <a:p>
-            <a:pPr algn="ctr" indent="0" marL="0">
-              <a:buNone/>
-            </a:pPr>
-            <a:r>
-              <a:rPr lang="en-US" sz="1200" dirty="0">
-                <a:solidFill>
-                  <a:srgbClr val="E66767"/>
-                </a:solidFill>
-                <a:latin typeface="Arial" pitchFamily="34" charset="0"/>
-                <a:ea typeface="Arial" pitchFamily="34" charset="-122"/>
-                <a:cs typeface="Arial" pitchFamily="34" charset="-120"/>
-              </a:rPr>
-              <a:t>còn −0.60</a:t>
-            </a:r>
-            <a:endParaRPr lang="en-US" sz="1200" dirty="0"/>
-          </a:p>
-        </p:txBody>
-      </p:sp>
-      <p:sp>
-        <p:nvSpPr>
-          <p:cNvPr id="28" name="Shape 26"/>
+          <p:cNvPr id="31" name="Shape 29"/>
           <p:cNvSpPr/>
           <p:nvPr/>
         </p:nvSpPr>
@@ -34478,14 +34595,14 @@
       </p:sp>
       <p:sp>
         <p:nvSpPr>
-          <p:cNvPr id="29" name="Text 27"/>
+          <p:cNvPr id="32" name="Text 30"/>
           <p:cNvSpPr txBox="1"/>
           <p:nvPr/>
         </p:nvSpPr>
         <p:spPr>
           <a:xfrm>
             <a:off x="777240" y="2779776"/>
-            <a:ext cx="3200400" cy="338328"/>
+            <a:ext cx="2834640" cy="338328"/>
           </a:xfrm>
           <a:prstGeom prst="rect">
             <a:avLst/>
@@ -34517,14 +34634,14 @@
       </p:sp>
       <p:sp>
         <p:nvSpPr>
-          <p:cNvPr id="30" name="Text 28"/>
-          <p:cNvSpPr txBox="1"/>
-          <p:nvPr/>
-        </p:nvSpPr>
-        <p:spPr>
-          <a:xfrm>
-            <a:off x="3977640" y="2779776"/>
-            <a:ext cx="2011680" cy="338328"/>
+          <p:cNvPr id="33" name="Text 31"/>
+          <p:cNvSpPr txBox="1"/>
+          <p:nvPr/>
+        </p:nvSpPr>
+        <p:spPr>
+          <a:xfrm>
+            <a:off x="3611880" y="2779776"/>
+            <a:ext cx="1828800" cy="338328"/>
           </a:xfrm>
           <a:prstGeom prst="rect">
             <a:avLst/>
@@ -34556,14 +34673,14 @@
       </p:sp>
       <p:sp>
         <p:nvSpPr>
-          <p:cNvPr id="31" name="Text 29"/>
-          <p:cNvSpPr txBox="1"/>
-          <p:nvPr/>
-        </p:nvSpPr>
-        <p:spPr>
-          <a:xfrm>
-            <a:off x="5989320" y="2779776"/>
-            <a:ext cx="1005840" cy="338328"/>
+          <p:cNvPr id="34" name="Text 32"/>
+          <p:cNvSpPr txBox="1"/>
+          <p:nvPr/>
+        </p:nvSpPr>
+        <p:spPr>
+          <a:xfrm>
+            <a:off x="5440680" y="2779776"/>
+            <a:ext cx="868680" cy="338328"/>
           </a:xfrm>
           <a:prstGeom prst="rect">
             <a:avLst/>
@@ -34595,14 +34712,14 @@
       </p:sp>
       <p:sp>
         <p:nvSpPr>
-          <p:cNvPr id="32" name="Text 30"/>
-          <p:cNvSpPr txBox="1"/>
-          <p:nvPr/>
-        </p:nvSpPr>
-        <p:spPr>
-          <a:xfrm>
-            <a:off x="6995160" y="2779776"/>
-            <a:ext cx="1005840" cy="338328"/>
+          <p:cNvPr id="35" name="Text 33"/>
+          <p:cNvSpPr txBox="1"/>
+          <p:nvPr/>
+        </p:nvSpPr>
+        <p:spPr>
+          <a:xfrm>
+            <a:off x="6309360" y="2779776"/>
+            <a:ext cx="868680" cy="338328"/>
           </a:xfrm>
           <a:prstGeom prst="rect">
             <a:avLst/>
@@ -34634,14 +34751,53 @@
       </p:sp>
       <p:sp>
         <p:nvSpPr>
-          <p:cNvPr id="33" name="Text 31"/>
+          <p:cNvPr id="36" name="Text 34"/>
+          <p:cNvSpPr txBox="1"/>
+          <p:nvPr/>
+        </p:nvSpPr>
+        <p:spPr>
+          <a:xfrm>
+            <a:off x="7178040" y="2779776"/>
+            <a:ext cx="822960" cy="338328"/>
+          </a:xfrm>
+          <a:prstGeom prst="rect">
+            <a:avLst/>
+          </a:prstGeom>
+          <a:noFill/>
+          <a:ln/>
+        </p:spPr>
+        <p:txBody>
+          <a:bodyPr wrap="square" lIns="0" tIns="0" rIns="0" bIns="0" rtlCol="0" anchor="ctr"/>
+          <a:lstStyle/>
+          <a:p>
+            <a:pPr algn="ctr" indent="0" marL="0">
+              <a:buNone/>
+            </a:pPr>
+            <a:r>
+              <a:rPr lang="en-US" sz="1200" dirty="0">
+                <a:solidFill>
+                  <a:srgbClr val="F2F2F2"/>
+                </a:solidFill>
+                <a:latin typeface="Arial" pitchFamily="34" charset="0"/>
+                <a:ea typeface="Arial" pitchFamily="34" charset="-122"/>
+                <a:cs typeface="Arial" pitchFamily="34" charset="-120"/>
+              </a:rPr>
+              <a:t>±0.0</a:t>
+            </a:r>
+            <a:endParaRPr lang="en-US" sz="1200" dirty="0"/>
+          </a:p>
+        </p:txBody>
+      </p:sp>
+      <p:sp>
+        <p:nvSpPr>
+          <p:cNvPr id="37" name="Text 35"/>
           <p:cNvSpPr txBox="1"/>
           <p:nvPr/>
         </p:nvSpPr>
         <p:spPr>
           <a:xfrm>
             <a:off x="8001000" y="2779776"/>
-            <a:ext cx="960120" cy="338328"/>
+            <a:ext cx="914400" cy="338328"/>
           </a:xfrm>
           <a:prstGeom prst="rect">
             <a:avLst/>
@@ -34657,15 +34813,54 @@
               <a:buNone/>
             </a:pPr>
             <a:r>
+              <a:rPr lang="en-US" sz="1200" b="1" dirty="0">
+                <a:solidFill>
+                  <a:srgbClr val="F2F2F2"/>
+                </a:solidFill>
+                <a:latin typeface="Arial" pitchFamily="34" charset="0"/>
+                <a:ea typeface="Arial" pitchFamily="34" charset="-122"/>
+                <a:cs typeface="Arial" pitchFamily="34" charset="-120"/>
+              </a:rPr>
+              <a:t>+0.04</a:t>
+            </a:r>
+            <a:endParaRPr lang="en-US" sz="1200" dirty="0"/>
+          </a:p>
+        </p:txBody>
+      </p:sp>
+      <p:sp>
+        <p:nvSpPr>
+          <p:cNvPr id="38" name="Text 36"/>
+          <p:cNvSpPr txBox="1"/>
+          <p:nvPr/>
+        </p:nvSpPr>
+        <p:spPr>
+          <a:xfrm>
+            <a:off x="8915400" y="2779776"/>
+            <a:ext cx="1554480" cy="338328"/>
+          </a:xfrm>
+          <a:prstGeom prst="rect">
+            <a:avLst/>
+          </a:prstGeom>
+          <a:noFill/>
+          <a:ln/>
+        </p:spPr>
+        <p:txBody>
+          <a:bodyPr wrap="square" lIns="0" tIns="0" rIns="0" bIns="0" rtlCol="0" anchor="ctr"/>
+          <a:lstStyle/>
+          <a:p>
+            <a:pPr algn="ctr" indent="0" marL="0">
+              <a:buNone/>
+            </a:pPr>
+            <a:r>
               <a:rPr lang="en-US" sz="1200" dirty="0">
                 <a:solidFill>
-                  <a:srgbClr val="F2F2F2"/>
-                </a:solidFill>
-                <a:latin typeface="Arial" pitchFamily="34" charset="0"/>
-                <a:ea typeface="Arial" pitchFamily="34" charset="-122"/>
-                <a:cs typeface="Arial" pitchFamily="34" charset="-120"/>
-              </a:rPr>
-              <a:t>±0.0</a:t>
+                  <a:srgbClr val="A3A8B0"/>
+                </a:solidFill>
+                <a:latin typeface="Arial" pitchFamily="34" charset="0"/>
+                <a:ea typeface="Arial" pitchFamily="34" charset="-122"/>
+                <a:cs typeface="Arial" pitchFamily="34" charset="-120"/>
+              </a:rPr>
+              <a:t>tăng &lt; 0.5</a:t>
             </a:r>
             <a:endParaRPr lang="en-US" sz="1200" dirty="0"/>
           </a:p>
@@ -34673,14 +34868,14 @@
       </p:sp>
       <p:sp>
         <p:nvSpPr>
-          <p:cNvPr id="34" name="Text 32"/>
-          <p:cNvSpPr txBox="1"/>
-          <p:nvPr/>
-        </p:nvSpPr>
-        <p:spPr>
-          <a:xfrm>
-            <a:off x="8961120" y="2779776"/>
-            <a:ext cx="960120" cy="338328"/>
+          <p:cNvPr id="39" name="Text 37"/>
+          <p:cNvSpPr txBox="1"/>
+          <p:nvPr/>
+        </p:nvSpPr>
+        <p:spPr>
+          <a:xfrm>
+            <a:off x="10469880" y="2779776"/>
+            <a:ext cx="1143000" cy="338328"/>
           </a:xfrm>
           <a:prstGeom prst="rect">
             <a:avLst/>
@@ -34696,15 +34891,15 @@
               <a:buNone/>
             </a:pPr>
             <a:r>
-              <a:rPr lang="en-US" sz="1200" b="1" dirty="0">
-                <a:solidFill>
-                  <a:srgbClr val="F2F2F2"/>
-                </a:solidFill>
-                <a:latin typeface="Arial" pitchFamily="34" charset="0"/>
-                <a:ea typeface="Arial" pitchFamily="34" charset="-122"/>
-                <a:cs typeface="Arial" pitchFamily="34" charset="-120"/>
-              </a:rPr>
-              <a:t>+0.04</a:t>
+              <a:rPr lang="en-US" sz="1200" dirty="0">
+                <a:solidFill>
+                  <a:srgbClr val="A3A8B0"/>
+                </a:solidFill>
+                <a:latin typeface="Arial" pitchFamily="34" charset="0"/>
+                <a:ea typeface="Arial" pitchFamily="34" charset="-122"/>
+                <a:cs typeface="Arial" pitchFamily="34" charset="-120"/>
+              </a:rPr>
+              <a:t>+0.46</a:t>
             </a:r>
             <a:endParaRPr lang="en-US" sz="1200" dirty="0"/>
           </a:p>
@@ -34712,46 +34907,7 @@
       </p:sp>
       <p:sp>
         <p:nvSpPr>
-          <p:cNvPr id="35" name="Text 33"/>
-          <p:cNvSpPr txBox="1"/>
-          <p:nvPr/>
-        </p:nvSpPr>
-        <p:spPr>
-          <a:xfrm>
-            <a:off x="9921240" y="2779776"/>
-            <a:ext cx="1691640" cy="338328"/>
-          </a:xfrm>
-          <a:prstGeom prst="rect">
-            <a:avLst/>
-          </a:prstGeom>
-          <a:noFill/>
-          <a:ln/>
-        </p:spPr>
-        <p:txBody>
-          <a:bodyPr wrap="square" lIns="0" tIns="0" rIns="0" bIns="0" rtlCol="0" anchor="ctr"/>
-          <a:lstStyle/>
-          <a:p>
-            <a:pPr algn="ctr" indent="0" marL="0">
-              <a:buNone/>
-            </a:pPr>
-            <a:r>
-              <a:rPr lang="en-US" sz="1200" dirty="0">
-                <a:solidFill>
-                  <a:srgbClr val="A3A8B0"/>
-                </a:solidFill>
-                <a:latin typeface="Arial" pitchFamily="34" charset="0"/>
-                <a:ea typeface="Arial" pitchFamily="34" charset="-122"/>
-                <a:cs typeface="Arial" pitchFamily="34" charset="-120"/>
-              </a:rPr>
-              <a:t>tăng &lt; 0.5</a:t>
-            </a:r>
-            <a:endParaRPr lang="en-US" sz="1200" dirty="0"/>
-          </a:p>
-        </p:txBody>
-      </p:sp>
-      <p:sp>
-        <p:nvSpPr>
-          <p:cNvPr id="36" name="Shape 34"/>
+          <p:cNvPr id="40" name="Shape 38"/>
           <p:cNvSpPr/>
           <p:nvPr/>
         </p:nvSpPr>
@@ -34778,14 +34934,14 @@
       </p:sp>
       <p:sp>
         <p:nvSpPr>
-          <p:cNvPr id="37" name="Text 35"/>
+          <p:cNvPr id="41" name="Text 39"/>
           <p:cNvSpPr txBox="1"/>
           <p:nvPr/>
         </p:nvSpPr>
         <p:spPr>
           <a:xfrm>
             <a:off x="777240" y="3163824"/>
-            <a:ext cx="3200400" cy="338328"/>
+            <a:ext cx="2834640" cy="338328"/>
           </a:xfrm>
           <a:prstGeom prst="rect">
             <a:avLst/>
@@ -34817,14 +34973,14 @@
       </p:sp>
       <p:sp>
         <p:nvSpPr>
-          <p:cNvPr id="38" name="Text 36"/>
-          <p:cNvSpPr txBox="1"/>
-          <p:nvPr/>
-        </p:nvSpPr>
-        <p:spPr>
-          <a:xfrm>
-            <a:off x="3977640" y="3163824"/>
-            <a:ext cx="2011680" cy="338328"/>
+          <p:cNvPr id="42" name="Text 40"/>
+          <p:cNvSpPr txBox="1"/>
+          <p:nvPr/>
+        </p:nvSpPr>
+        <p:spPr>
+          <a:xfrm>
+            <a:off x="3611880" y="3163824"/>
+            <a:ext cx="1828800" cy="338328"/>
           </a:xfrm>
           <a:prstGeom prst="rect">
             <a:avLst/>
@@ -34856,14 +35012,14 @@
       </p:sp>
       <p:sp>
         <p:nvSpPr>
-          <p:cNvPr id="39" name="Text 37"/>
-          <p:cNvSpPr txBox="1"/>
-          <p:nvPr/>
-        </p:nvSpPr>
-        <p:spPr>
-          <a:xfrm>
-            <a:off x="5989320" y="3163824"/>
-            <a:ext cx="1005840" cy="338328"/>
+          <p:cNvPr id="43" name="Text 41"/>
+          <p:cNvSpPr txBox="1"/>
+          <p:nvPr/>
+        </p:nvSpPr>
+        <p:spPr>
+          <a:xfrm>
+            <a:off x="5440680" y="3163824"/>
+            <a:ext cx="868680" cy="338328"/>
           </a:xfrm>
           <a:prstGeom prst="rect">
             <a:avLst/>
@@ -34895,14 +35051,14 @@
       </p:sp>
       <p:sp>
         <p:nvSpPr>
-          <p:cNvPr id="40" name="Text 38"/>
-          <p:cNvSpPr txBox="1"/>
-          <p:nvPr/>
-        </p:nvSpPr>
-        <p:spPr>
-          <a:xfrm>
-            <a:off x="6995160" y="3163824"/>
-            <a:ext cx="1005840" cy="338328"/>
+          <p:cNvPr id="44" name="Text 42"/>
+          <p:cNvSpPr txBox="1"/>
+          <p:nvPr/>
+        </p:nvSpPr>
+        <p:spPr>
+          <a:xfrm>
+            <a:off x="6309360" y="3163824"/>
+            <a:ext cx="868680" cy="338328"/>
           </a:xfrm>
           <a:prstGeom prst="rect">
             <a:avLst/>
@@ -34934,14 +35090,53 @@
       </p:sp>
       <p:sp>
         <p:nvSpPr>
-          <p:cNvPr id="41" name="Text 39"/>
+          <p:cNvPr id="45" name="Text 43"/>
+          <p:cNvSpPr txBox="1"/>
+          <p:nvPr/>
+        </p:nvSpPr>
+        <p:spPr>
+          <a:xfrm>
+            <a:off x="7178040" y="3163824"/>
+            <a:ext cx="822960" cy="338328"/>
+          </a:xfrm>
+          <a:prstGeom prst="rect">
+            <a:avLst/>
+          </a:prstGeom>
+          <a:noFill/>
+          <a:ln/>
+        </p:spPr>
+        <p:txBody>
+          <a:bodyPr wrap="square" lIns="0" tIns="0" rIns="0" bIns="0" rtlCol="0" anchor="ctr"/>
+          <a:lstStyle/>
+          <a:p>
+            <a:pPr algn="ctr" indent="0" marL="0">
+              <a:buNone/>
+            </a:pPr>
+            <a:r>
+              <a:rPr lang="en-US" sz="1200" dirty="0">
+                <a:solidFill>
+                  <a:srgbClr val="F2F2F2"/>
+                </a:solidFill>
+                <a:latin typeface="Arial" pitchFamily="34" charset="0"/>
+                <a:ea typeface="Arial" pitchFamily="34" charset="-122"/>
+                <a:cs typeface="Arial" pitchFamily="34" charset="-120"/>
+              </a:rPr>
+              <a:t>±0.0</a:t>
+            </a:r>
+            <a:endParaRPr lang="en-US" sz="1200" dirty="0"/>
+          </a:p>
+        </p:txBody>
+      </p:sp>
+      <p:sp>
+        <p:nvSpPr>
+          <p:cNvPr id="46" name="Text 44"/>
           <p:cNvSpPr txBox="1"/>
           <p:nvPr/>
         </p:nvSpPr>
         <p:spPr>
           <a:xfrm>
             <a:off x="8001000" y="3163824"/>
-            <a:ext cx="960120" cy="338328"/>
+            <a:ext cx="914400" cy="338328"/>
           </a:xfrm>
           <a:prstGeom prst="rect">
             <a:avLst/>
@@ -34957,15 +35152,54 @@
               <a:buNone/>
             </a:pPr>
             <a:r>
+              <a:rPr lang="en-US" sz="1200" b="1" dirty="0">
+                <a:solidFill>
+                  <a:srgbClr val="F2F2F2"/>
+                </a:solidFill>
+                <a:latin typeface="Arial" pitchFamily="34" charset="0"/>
+                <a:ea typeface="Arial" pitchFamily="34" charset="-122"/>
+                <a:cs typeface="Arial" pitchFamily="34" charset="-120"/>
+              </a:rPr>
+              <a:t>±0.00</a:t>
+            </a:r>
+            <a:endParaRPr lang="en-US" sz="1200" dirty="0"/>
+          </a:p>
+        </p:txBody>
+      </p:sp>
+      <p:sp>
+        <p:nvSpPr>
+          <p:cNvPr id="47" name="Text 45"/>
+          <p:cNvSpPr txBox="1"/>
+          <p:nvPr/>
+        </p:nvSpPr>
+        <p:spPr>
+          <a:xfrm>
+            <a:off x="8915400" y="3163824"/>
+            <a:ext cx="1554480" cy="338328"/>
+          </a:xfrm>
+          <a:prstGeom prst="rect">
+            <a:avLst/>
+          </a:prstGeom>
+          <a:noFill/>
+          <a:ln/>
+        </p:spPr>
+        <p:txBody>
+          <a:bodyPr wrap="square" lIns="0" tIns="0" rIns="0" bIns="0" rtlCol="0" anchor="ctr"/>
+          <a:lstStyle/>
+          <a:p>
+            <a:pPr algn="ctr" indent="0" marL="0">
+              <a:buNone/>
+            </a:pPr>
+            <a:r>
               <a:rPr lang="en-US" sz="1200" dirty="0">
                 <a:solidFill>
-                  <a:srgbClr val="F2F2F2"/>
-                </a:solidFill>
-                <a:latin typeface="Arial" pitchFamily="34" charset="0"/>
-                <a:ea typeface="Arial" pitchFamily="34" charset="-122"/>
-                <a:cs typeface="Arial" pitchFamily="34" charset="-120"/>
-              </a:rPr>
-              <a:t>±0.0</a:t>
+                  <a:srgbClr val="A3A8B0"/>
+                </a:solidFill>
+                <a:latin typeface="Arial" pitchFamily="34" charset="0"/>
+                <a:ea typeface="Arial" pitchFamily="34" charset="-122"/>
+                <a:cs typeface="Arial" pitchFamily="34" charset="-120"/>
+              </a:rPr>
+              <a:t>tăng &lt; 0.5</a:t>
             </a:r>
             <a:endParaRPr lang="en-US" sz="1200" dirty="0"/>
           </a:p>
@@ -34973,14 +35207,14 @@
       </p:sp>
       <p:sp>
         <p:nvSpPr>
-          <p:cNvPr id="42" name="Text 40"/>
-          <p:cNvSpPr txBox="1"/>
-          <p:nvPr/>
-        </p:nvSpPr>
-        <p:spPr>
-          <a:xfrm>
-            <a:off x="8961120" y="3163824"/>
-            <a:ext cx="960120" cy="338328"/>
+          <p:cNvPr id="48" name="Text 46"/>
+          <p:cNvSpPr txBox="1"/>
+          <p:nvPr/>
+        </p:nvSpPr>
+        <p:spPr>
+          <a:xfrm>
+            <a:off x="10469880" y="3163824"/>
+            <a:ext cx="1143000" cy="338328"/>
           </a:xfrm>
           <a:prstGeom prst="rect">
             <a:avLst/>
@@ -34996,9 +35230,9 @@
               <a:buNone/>
             </a:pPr>
             <a:r>
-              <a:rPr lang="en-US" sz="1200" b="1" dirty="0">
-                <a:solidFill>
-                  <a:srgbClr val="F2F2F2"/>
+              <a:rPr lang="en-US" sz="1200" dirty="0">
+                <a:solidFill>
+                  <a:srgbClr val="A3A8B0"/>
                 </a:solidFill>
                 <a:latin typeface="Arial" pitchFamily="34" charset="0"/>
                 <a:ea typeface="Arial" pitchFamily="34" charset="-122"/>
@@ -35012,46 +35246,7 @@
       </p:sp>
       <p:sp>
         <p:nvSpPr>
-          <p:cNvPr id="43" name="Text 41"/>
-          <p:cNvSpPr txBox="1"/>
-          <p:nvPr/>
-        </p:nvSpPr>
-        <p:spPr>
-          <a:xfrm>
-            <a:off x="9921240" y="3163824"/>
-            <a:ext cx="1691640" cy="338328"/>
-          </a:xfrm>
-          <a:prstGeom prst="rect">
-            <a:avLst/>
-          </a:prstGeom>
-          <a:noFill/>
-          <a:ln/>
-        </p:spPr>
-        <p:txBody>
-          <a:bodyPr wrap="square" lIns="0" tIns="0" rIns="0" bIns="0" rtlCol="0" anchor="ctr"/>
-          <a:lstStyle/>
-          <a:p>
-            <a:pPr algn="ctr" indent="0" marL="0">
-              <a:buNone/>
-            </a:pPr>
-            <a:r>
-              <a:rPr lang="en-US" sz="1200" dirty="0">
-                <a:solidFill>
-                  <a:srgbClr val="A3A8B0"/>
-                </a:solidFill>
-                <a:latin typeface="Arial" pitchFamily="34" charset="0"/>
-                <a:ea typeface="Arial" pitchFamily="34" charset="-122"/>
-                <a:cs typeface="Arial" pitchFamily="34" charset="-120"/>
-              </a:rPr>
-              <a:t>tăng &lt; 0.5</a:t>
-            </a:r>
-            <a:endParaRPr lang="en-US" sz="1200" dirty="0"/>
-          </a:p>
-        </p:txBody>
-      </p:sp>
-      <p:sp>
-        <p:nvSpPr>
-          <p:cNvPr id="44" name="Shape 42"/>
+          <p:cNvPr id="49" name="Shape 47"/>
           <p:cNvSpPr/>
           <p:nvPr/>
         </p:nvSpPr>
@@ -35078,14 +35273,14 @@
       </p:sp>
       <p:sp>
         <p:nvSpPr>
-          <p:cNvPr id="45" name="Text 43"/>
+          <p:cNvPr id="50" name="Text 48"/>
           <p:cNvSpPr txBox="1"/>
           <p:nvPr/>
         </p:nvSpPr>
         <p:spPr>
           <a:xfrm>
             <a:off x="777240" y="3547872"/>
-            <a:ext cx="3200400" cy="338328"/>
+            <a:ext cx="2834640" cy="338328"/>
           </a:xfrm>
           <a:prstGeom prst="rect">
             <a:avLst/>
@@ -35117,14 +35312,14 @@
       </p:sp>
       <p:sp>
         <p:nvSpPr>
-          <p:cNvPr id="46" name="Text 44"/>
-          <p:cNvSpPr txBox="1"/>
-          <p:nvPr/>
-        </p:nvSpPr>
-        <p:spPr>
-          <a:xfrm>
-            <a:off x="3977640" y="3547872"/>
-            <a:ext cx="2011680" cy="338328"/>
+          <p:cNvPr id="51" name="Text 49"/>
+          <p:cNvSpPr txBox="1"/>
+          <p:nvPr/>
+        </p:nvSpPr>
+        <p:spPr>
+          <a:xfrm>
+            <a:off x="3611880" y="3547872"/>
+            <a:ext cx="1828800" cy="338328"/>
           </a:xfrm>
           <a:prstGeom prst="rect">
             <a:avLst/>
@@ -35156,14 +35351,14 @@
       </p:sp>
       <p:sp>
         <p:nvSpPr>
-          <p:cNvPr id="47" name="Text 45"/>
-          <p:cNvSpPr txBox="1"/>
-          <p:nvPr/>
-        </p:nvSpPr>
-        <p:spPr>
-          <a:xfrm>
-            <a:off x="5989320" y="3547872"/>
-            <a:ext cx="1005840" cy="338328"/>
+          <p:cNvPr id="52" name="Text 50"/>
+          <p:cNvSpPr txBox="1"/>
+          <p:nvPr/>
+        </p:nvSpPr>
+        <p:spPr>
+          <a:xfrm>
+            <a:off x="5440680" y="3547872"/>
+            <a:ext cx="868680" cy="338328"/>
           </a:xfrm>
           <a:prstGeom prst="rect">
             <a:avLst/>
@@ -35195,14 +35390,14 @@
       </p:sp>
       <p:sp>
         <p:nvSpPr>
-          <p:cNvPr id="48" name="Text 46"/>
-          <p:cNvSpPr txBox="1"/>
-          <p:nvPr/>
-        </p:nvSpPr>
-        <p:spPr>
-          <a:xfrm>
-            <a:off x="6995160" y="3547872"/>
-            <a:ext cx="1005840" cy="338328"/>
+          <p:cNvPr id="53" name="Text 51"/>
+          <p:cNvSpPr txBox="1"/>
+          <p:nvPr/>
+        </p:nvSpPr>
+        <p:spPr>
+          <a:xfrm>
+            <a:off x="6309360" y="3547872"/>
+            <a:ext cx="868680" cy="338328"/>
           </a:xfrm>
           <a:prstGeom prst="rect">
             <a:avLst/>
@@ -35234,14 +35429,53 @@
       </p:sp>
       <p:sp>
         <p:nvSpPr>
-          <p:cNvPr id="49" name="Text 47"/>
+          <p:cNvPr id="54" name="Text 52"/>
+          <p:cNvSpPr txBox="1"/>
+          <p:nvPr/>
+        </p:nvSpPr>
+        <p:spPr>
+          <a:xfrm>
+            <a:off x="7178040" y="3547872"/>
+            <a:ext cx="822960" cy="338328"/>
+          </a:xfrm>
+          <a:prstGeom prst="rect">
+            <a:avLst/>
+          </a:prstGeom>
+          <a:noFill/>
+          <a:ln/>
+        </p:spPr>
+        <p:txBody>
+          <a:bodyPr wrap="square" lIns="0" tIns="0" rIns="0" bIns="0" rtlCol="0" anchor="ctr"/>
+          <a:lstStyle/>
+          <a:p>
+            <a:pPr algn="ctr" indent="0" marL="0">
+              <a:buNone/>
+            </a:pPr>
+            <a:r>
+              <a:rPr lang="en-US" sz="1200" dirty="0">
+                <a:solidFill>
+                  <a:srgbClr val="F2F2F2"/>
+                </a:solidFill>
+                <a:latin typeface="Arial" pitchFamily="34" charset="0"/>
+                <a:ea typeface="Arial" pitchFamily="34" charset="-122"/>
+                <a:cs typeface="Arial" pitchFamily="34" charset="-120"/>
+              </a:rPr>
+              <a:t>±0.0</a:t>
+            </a:r>
+            <a:endParaRPr lang="en-US" sz="1200" dirty="0"/>
+          </a:p>
+        </p:txBody>
+      </p:sp>
+      <p:sp>
+        <p:nvSpPr>
+          <p:cNvPr id="55" name="Text 53"/>
           <p:cNvSpPr txBox="1"/>
           <p:nvPr/>
         </p:nvSpPr>
         <p:spPr>
           <a:xfrm>
             <a:off x="8001000" y="3547872"/>
-            <a:ext cx="960120" cy="338328"/>
+            <a:ext cx="914400" cy="338328"/>
           </a:xfrm>
           <a:prstGeom prst="rect">
             <a:avLst/>
@@ -35257,15 +35491,54 @@
               <a:buNone/>
             </a:pPr>
             <a:r>
+              <a:rPr lang="en-US" sz="1200" b="1" dirty="0">
+                <a:solidFill>
+                  <a:srgbClr val="F2F2F2"/>
+                </a:solidFill>
+                <a:latin typeface="Arial" pitchFamily="34" charset="0"/>
+                <a:ea typeface="Arial" pitchFamily="34" charset="-122"/>
+                <a:cs typeface="Arial" pitchFamily="34" charset="-120"/>
+              </a:rPr>
+              <a:t>±0.00</a:t>
+            </a:r>
+            <a:endParaRPr lang="en-US" sz="1200" dirty="0"/>
+          </a:p>
+        </p:txBody>
+      </p:sp>
+      <p:sp>
+        <p:nvSpPr>
+          <p:cNvPr id="56" name="Text 54"/>
+          <p:cNvSpPr txBox="1"/>
+          <p:nvPr/>
+        </p:nvSpPr>
+        <p:spPr>
+          <a:xfrm>
+            <a:off x="8915400" y="3547872"/>
+            <a:ext cx="1554480" cy="338328"/>
+          </a:xfrm>
+          <a:prstGeom prst="rect">
+            <a:avLst/>
+          </a:prstGeom>
+          <a:noFill/>
+          <a:ln/>
+        </p:spPr>
+        <p:txBody>
+          <a:bodyPr wrap="square" lIns="0" tIns="0" rIns="0" bIns="0" rtlCol="0" anchor="ctr"/>
+          <a:lstStyle/>
+          <a:p>
+            <a:pPr algn="ctr" indent="0" marL="0">
+              <a:buNone/>
+            </a:pPr>
+            <a:r>
               <a:rPr lang="en-US" sz="1200" dirty="0">
                 <a:solidFill>
-                  <a:srgbClr val="F2F2F2"/>
-                </a:solidFill>
-                <a:latin typeface="Arial" pitchFamily="34" charset="0"/>
-                <a:ea typeface="Arial" pitchFamily="34" charset="-122"/>
-                <a:cs typeface="Arial" pitchFamily="34" charset="-120"/>
-              </a:rPr>
-              <a:t>±0.0</a:t>
+                  <a:srgbClr val="A3A8B0"/>
+                </a:solidFill>
+                <a:latin typeface="Arial" pitchFamily="34" charset="0"/>
+                <a:ea typeface="Arial" pitchFamily="34" charset="-122"/>
+                <a:cs typeface="Arial" pitchFamily="34" charset="-120"/>
+              </a:rPr>
+              <a:t>tăng &lt; 0.5</a:t>
             </a:r>
             <a:endParaRPr lang="en-US" sz="1200" dirty="0"/>
           </a:p>
@@ -35273,14 +35546,14 @@
       </p:sp>
       <p:sp>
         <p:nvSpPr>
-          <p:cNvPr id="50" name="Text 48"/>
-          <p:cNvSpPr txBox="1"/>
-          <p:nvPr/>
-        </p:nvSpPr>
-        <p:spPr>
-          <a:xfrm>
-            <a:off x="8961120" y="3547872"/>
-            <a:ext cx="960120" cy="338328"/>
+          <p:cNvPr id="57" name="Text 55"/>
+          <p:cNvSpPr txBox="1"/>
+          <p:nvPr/>
+        </p:nvSpPr>
+        <p:spPr>
+          <a:xfrm>
+            <a:off x="10469880" y="3547872"/>
+            <a:ext cx="1143000" cy="338328"/>
           </a:xfrm>
           <a:prstGeom prst="rect">
             <a:avLst/>
@@ -35296,9 +35569,9 @@
               <a:buNone/>
             </a:pPr>
             <a:r>
-              <a:rPr lang="en-US" sz="1200" b="1" dirty="0">
-                <a:solidFill>
-                  <a:srgbClr val="F2F2F2"/>
+              <a:rPr lang="en-US" sz="1200" dirty="0">
+                <a:solidFill>
+                  <a:srgbClr val="A3A8B0"/>
                 </a:solidFill>
                 <a:latin typeface="Arial" pitchFamily="34" charset="0"/>
                 <a:ea typeface="Arial" pitchFamily="34" charset="-122"/>
@@ -35312,46 +35585,7 @@
       </p:sp>
       <p:sp>
         <p:nvSpPr>
-          <p:cNvPr id="51" name="Text 49"/>
-          <p:cNvSpPr txBox="1"/>
-          <p:nvPr/>
-        </p:nvSpPr>
-        <p:spPr>
-          <a:xfrm>
-            <a:off x="9921240" y="3547872"/>
-            <a:ext cx="1691640" cy="338328"/>
-          </a:xfrm>
-          <a:prstGeom prst="rect">
-            <a:avLst/>
-          </a:prstGeom>
-          <a:noFill/>
-          <a:ln/>
-        </p:spPr>
-        <p:txBody>
-          <a:bodyPr wrap="square" lIns="0" tIns="0" rIns="0" bIns="0" rtlCol="0" anchor="ctr"/>
-          <a:lstStyle/>
-          <a:p>
-            <a:pPr algn="ctr" indent="0" marL="0">
-              <a:buNone/>
-            </a:pPr>
-            <a:r>
-              <a:rPr lang="en-US" sz="1200" dirty="0">
-                <a:solidFill>
-                  <a:srgbClr val="A3A8B0"/>
-                </a:solidFill>
-                <a:latin typeface="Arial" pitchFamily="34" charset="0"/>
-                <a:ea typeface="Arial" pitchFamily="34" charset="-122"/>
-                <a:cs typeface="Arial" pitchFamily="34" charset="-120"/>
-              </a:rPr>
-              <a:t>tăng &lt; 0.5</a:t>
-            </a:r>
-            <a:endParaRPr lang="en-US" sz="1200" dirty="0"/>
-          </a:p>
-        </p:txBody>
-      </p:sp>
-      <p:sp>
-        <p:nvSpPr>
-          <p:cNvPr id="52" name="Shape 50"/>
+          <p:cNvPr id="58" name="Shape 56"/>
           <p:cNvSpPr/>
           <p:nvPr/>
         </p:nvSpPr>
@@ -35378,14 +35612,14 @@
       </p:sp>
       <p:sp>
         <p:nvSpPr>
-          <p:cNvPr id="53" name="Text 51"/>
+          <p:cNvPr id="59" name="Text 57"/>
           <p:cNvSpPr txBox="1"/>
           <p:nvPr/>
         </p:nvSpPr>
         <p:spPr>
           <a:xfrm>
             <a:off x="777240" y="3931920"/>
-            <a:ext cx="3200400" cy="338328"/>
+            <a:ext cx="2834640" cy="338328"/>
           </a:xfrm>
           <a:prstGeom prst="rect">
             <a:avLst/>
@@ -35417,14 +35651,14 @@
       </p:sp>
       <p:sp>
         <p:nvSpPr>
-          <p:cNvPr id="54" name="Text 52"/>
-          <p:cNvSpPr txBox="1"/>
-          <p:nvPr/>
-        </p:nvSpPr>
-        <p:spPr>
-          <a:xfrm>
-            <a:off x="3977640" y="3931920"/>
-            <a:ext cx="2011680" cy="338328"/>
+          <p:cNvPr id="60" name="Text 58"/>
+          <p:cNvSpPr txBox="1"/>
+          <p:nvPr/>
+        </p:nvSpPr>
+        <p:spPr>
+          <a:xfrm>
+            <a:off x="3611880" y="3931920"/>
+            <a:ext cx="1828800" cy="338328"/>
           </a:xfrm>
           <a:prstGeom prst="rect">
             <a:avLst/>
@@ -35456,14 +35690,14 @@
       </p:sp>
       <p:sp>
         <p:nvSpPr>
-          <p:cNvPr id="55" name="Text 53"/>
-          <p:cNvSpPr txBox="1"/>
-          <p:nvPr/>
-        </p:nvSpPr>
-        <p:spPr>
-          <a:xfrm>
-            <a:off x="5989320" y="3931920"/>
-            <a:ext cx="1005840" cy="338328"/>
+          <p:cNvPr id="61" name="Text 59"/>
+          <p:cNvSpPr txBox="1"/>
+          <p:nvPr/>
+        </p:nvSpPr>
+        <p:spPr>
+          <a:xfrm>
+            <a:off x="5440680" y="3931920"/>
+            <a:ext cx="868680" cy="338328"/>
           </a:xfrm>
           <a:prstGeom prst="rect">
             <a:avLst/>
@@ -35495,14 +35729,14 @@
       </p:sp>
       <p:sp>
         <p:nvSpPr>
-          <p:cNvPr id="56" name="Text 54"/>
-          <p:cNvSpPr txBox="1"/>
-          <p:nvPr/>
-        </p:nvSpPr>
-        <p:spPr>
-          <a:xfrm>
-            <a:off x="6995160" y="3931920"/>
-            <a:ext cx="1005840" cy="338328"/>
+          <p:cNvPr id="62" name="Text 60"/>
+          <p:cNvSpPr txBox="1"/>
+          <p:nvPr/>
+        </p:nvSpPr>
+        <p:spPr>
+          <a:xfrm>
+            <a:off x="6309360" y="3931920"/>
+            <a:ext cx="868680" cy="338328"/>
           </a:xfrm>
           <a:prstGeom prst="rect">
             <a:avLst/>
@@ -35534,14 +35768,53 @@
       </p:sp>
       <p:sp>
         <p:nvSpPr>
-          <p:cNvPr id="57" name="Text 55"/>
+          <p:cNvPr id="63" name="Text 61"/>
+          <p:cNvSpPr txBox="1"/>
+          <p:nvPr/>
+        </p:nvSpPr>
+        <p:spPr>
+          <a:xfrm>
+            <a:off x="7178040" y="3931920"/>
+            <a:ext cx="822960" cy="338328"/>
+          </a:xfrm>
+          <a:prstGeom prst="rect">
+            <a:avLst/>
+          </a:prstGeom>
+          <a:noFill/>
+          <a:ln/>
+        </p:spPr>
+        <p:txBody>
+          <a:bodyPr wrap="square" lIns="0" tIns="0" rIns="0" bIns="0" rtlCol="0" anchor="ctr"/>
+          <a:lstStyle/>
+          <a:p>
+            <a:pPr algn="ctr" indent="0" marL="0">
+              <a:buNone/>
+            </a:pPr>
+            <a:r>
+              <a:rPr lang="en-US" sz="1200" dirty="0">
+                <a:solidFill>
+                  <a:srgbClr val="F2F2F2"/>
+                </a:solidFill>
+                <a:latin typeface="Arial" pitchFamily="34" charset="0"/>
+                <a:ea typeface="Arial" pitchFamily="34" charset="-122"/>
+                <a:cs typeface="Arial" pitchFamily="34" charset="-120"/>
+              </a:rPr>
+              <a:t>±0.0</a:t>
+            </a:r>
+            <a:endParaRPr lang="en-US" sz="1200" dirty="0"/>
+          </a:p>
+        </p:txBody>
+      </p:sp>
+      <p:sp>
+        <p:nvSpPr>
+          <p:cNvPr id="64" name="Text 62"/>
           <p:cNvSpPr txBox="1"/>
           <p:nvPr/>
         </p:nvSpPr>
         <p:spPr>
           <a:xfrm>
             <a:off x="8001000" y="3931920"/>
-            <a:ext cx="960120" cy="338328"/>
+            <a:ext cx="914400" cy="338328"/>
           </a:xfrm>
           <a:prstGeom prst="rect">
             <a:avLst/>
@@ -35557,15 +35830,54 @@
               <a:buNone/>
             </a:pPr>
             <a:r>
+              <a:rPr lang="en-US" sz="1200" b="1" dirty="0">
+                <a:solidFill>
+                  <a:srgbClr val="F2F2F2"/>
+                </a:solidFill>
+                <a:latin typeface="Arial" pitchFamily="34" charset="0"/>
+                <a:ea typeface="Arial" pitchFamily="34" charset="-122"/>
+                <a:cs typeface="Arial" pitchFamily="34" charset="-120"/>
+              </a:rPr>
+              <a:t>±0.00</a:t>
+            </a:r>
+            <a:endParaRPr lang="en-US" sz="1200" dirty="0"/>
+          </a:p>
+        </p:txBody>
+      </p:sp>
+      <p:sp>
+        <p:nvSpPr>
+          <p:cNvPr id="65" name="Text 63"/>
+          <p:cNvSpPr txBox="1"/>
+          <p:nvPr/>
+        </p:nvSpPr>
+        <p:spPr>
+          <a:xfrm>
+            <a:off x="8915400" y="3931920"/>
+            <a:ext cx="1554480" cy="338328"/>
+          </a:xfrm>
+          <a:prstGeom prst="rect">
+            <a:avLst/>
+          </a:prstGeom>
+          <a:noFill/>
+          <a:ln/>
+        </p:spPr>
+        <p:txBody>
+          <a:bodyPr wrap="square" lIns="0" tIns="0" rIns="0" bIns="0" rtlCol="0" anchor="ctr"/>
+          <a:lstStyle/>
+          <a:p>
+            <a:pPr algn="ctr" indent="0" marL="0">
+              <a:buNone/>
+            </a:pPr>
+            <a:r>
               <a:rPr lang="en-US" sz="1200" dirty="0">
                 <a:solidFill>
-                  <a:srgbClr val="F2F2F2"/>
-                </a:solidFill>
-                <a:latin typeface="Arial" pitchFamily="34" charset="0"/>
-                <a:ea typeface="Arial" pitchFamily="34" charset="-122"/>
-                <a:cs typeface="Arial" pitchFamily="34" charset="-120"/>
-              </a:rPr>
-              <a:t>±0.0</a:t>
+                  <a:srgbClr val="A3A8B0"/>
+                </a:solidFill>
+                <a:latin typeface="Arial" pitchFamily="34" charset="0"/>
+                <a:ea typeface="Arial" pitchFamily="34" charset="-122"/>
+                <a:cs typeface="Arial" pitchFamily="34" charset="-120"/>
+              </a:rPr>
+              <a:t>tăng &lt; 0.5</a:t>
             </a:r>
             <a:endParaRPr lang="en-US" sz="1200" dirty="0"/>
           </a:p>
@@ -35573,14 +35885,14 @@
       </p:sp>
       <p:sp>
         <p:nvSpPr>
-          <p:cNvPr id="58" name="Text 56"/>
-          <p:cNvSpPr txBox="1"/>
-          <p:nvPr/>
-        </p:nvSpPr>
-        <p:spPr>
-          <a:xfrm>
-            <a:off x="8961120" y="3931920"/>
-            <a:ext cx="960120" cy="338328"/>
+          <p:cNvPr id="66" name="Text 64"/>
+          <p:cNvSpPr txBox="1"/>
+          <p:nvPr/>
+        </p:nvSpPr>
+        <p:spPr>
+          <a:xfrm>
+            <a:off x="10469880" y="3931920"/>
+            <a:ext cx="1143000" cy="338328"/>
           </a:xfrm>
           <a:prstGeom prst="rect">
             <a:avLst/>
@@ -35596,15 +35908,15 @@
               <a:buNone/>
             </a:pPr>
             <a:r>
-              <a:rPr lang="en-US" sz="1200" b="1" dirty="0">
-                <a:solidFill>
-                  <a:srgbClr val="F2F2F2"/>
-                </a:solidFill>
-                <a:latin typeface="Arial" pitchFamily="34" charset="0"/>
-                <a:ea typeface="Arial" pitchFamily="34" charset="-122"/>
-                <a:cs typeface="Arial" pitchFamily="34" charset="-120"/>
-              </a:rPr>
-              <a:t>±0.00</a:t>
+              <a:rPr lang="en-US" sz="1200" dirty="0">
+                <a:solidFill>
+                  <a:srgbClr val="A3A8B0"/>
+                </a:solidFill>
+                <a:latin typeface="Arial" pitchFamily="34" charset="0"/>
+                <a:ea typeface="Arial" pitchFamily="34" charset="-122"/>
+                <a:cs typeface="Arial" pitchFamily="34" charset="-120"/>
+              </a:rPr>
+              <a:t>+0.05</a:t>
             </a:r>
             <a:endParaRPr lang="en-US" sz="1200" dirty="0"/>
           </a:p>
@@ -35612,46 +35924,7 @@
       </p:sp>
       <p:sp>
         <p:nvSpPr>
-          <p:cNvPr id="59" name="Text 57"/>
-          <p:cNvSpPr txBox="1"/>
-          <p:nvPr/>
-        </p:nvSpPr>
-        <p:spPr>
-          <a:xfrm>
-            <a:off x="9921240" y="3931920"/>
-            <a:ext cx="1691640" cy="338328"/>
-          </a:xfrm>
-          <a:prstGeom prst="rect">
-            <a:avLst/>
-          </a:prstGeom>
-          <a:noFill/>
-          <a:ln/>
-        </p:spPr>
-        <p:txBody>
-          <a:bodyPr wrap="square" lIns="0" tIns="0" rIns="0" bIns="0" rtlCol="0" anchor="ctr"/>
-          <a:lstStyle/>
-          <a:p>
-            <a:pPr algn="ctr" indent="0" marL="0">
-              <a:buNone/>
-            </a:pPr>
-            <a:r>
-              <a:rPr lang="en-US" sz="1200" dirty="0">
-                <a:solidFill>
-                  <a:srgbClr val="A3A8B0"/>
-                </a:solidFill>
-                <a:latin typeface="Arial" pitchFamily="34" charset="0"/>
-                <a:ea typeface="Arial" pitchFamily="34" charset="-122"/>
-                <a:cs typeface="Arial" pitchFamily="34" charset="-120"/>
-              </a:rPr>
-              <a:t>tăng &lt; 0.5</a:t>
-            </a:r>
-            <a:endParaRPr lang="en-US" sz="1200" dirty="0"/>
-          </a:p>
-        </p:txBody>
-      </p:sp>
-      <p:sp>
-        <p:nvSpPr>
-          <p:cNvPr id="60" name="Shape 58"/>
+          <p:cNvPr id="67" name="Shape 65"/>
           <p:cNvSpPr/>
           <p:nvPr/>
         </p:nvSpPr>
@@ -35678,14 +35951,14 @@
       </p:sp>
       <p:sp>
         <p:nvSpPr>
-          <p:cNvPr id="61" name="Text 59"/>
+          <p:cNvPr id="68" name="Text 66"/>
           <p:cNvSpPr txBox="1"/>
           <p:nvPr/>
         </p:nvSpPr>
         <p:spPr>
           <a:xfrm>
             <a:off x="777240" y="4315968"/>
-            <a:ext cx="3200400" cy="338328"/>
+            <a:ext cx="2834640" cy="338328"/>
           </a:xfrm>
           <a:prstGeom prst="rect">
             <a:avLst/>
@@ -35717,14 +35990,14 @@
       </p:sp>
       <p:sp>
         <p:nvSpPr>
-          <p:cNvPr id="62" name="Text 60"/>
-          <p:cNvSpPr txBox="1"/>
-          <p:nvPr/>
-        </p:nvSpPr>
-        <p:spPr>
-          <a:xfrm>
-            <a:off x="3977640" y="4315968"/>
-            <a:ext cx="2011680" cy="338328"/>
+          <p:cNvPr id="69" name="Text 67"/>
+          <p:cNvSpPr txBox="1"/>
+          <p:nvPr/>
+        </p:nvSpPr>
+        <p:spPr>
+          <a:xfrm>
+            <a:off x="3611880" y="4315968"/>
+            <a:ext cx="1828800" cy="338328"/>
           </a:xfrm>
           <a:prstGeom prst="rect">
             <a:avLst/>
@@ -35756,14 +36029,14 @@
       </p:sp>
       <p:sp>
         <p:nvSpPr>
-          <p:cNvPr id="63" name="Text 61"/>
-          <p:cNvSpPr txBox="1"/>
-          <p:nvPr/>
-        </p:nvSpPr>
-        <p:spPr>
-          <a:xfrm>
-            <a:off x="5989320" y="4315968"/>
-            <a:ext cx="1005840" cy="338328"/>
+          <p:cNvPr id="70" name="Text 68"/>
+          <p:cNvSpPr txBox="1"/>
+          <p:nvPr/>
+        </p:nvSpPr>
+        <p:spPr>
+          <a:xfrm>
+            <a:off x="5440680" y="4315968"/>
+            <a:ext cx="868680" cy="338328"/>
           </a:xfrm>
           <a:prstGeom prst="rect">
             <a:avLst/>
@@ -35795,14 +36068,14 @@
       </p:sp>
       <p:sp>
         <p:nvSpPr>
-          <p:cNvPr id="64" name="Text 62"/>
-          <p:cNvSpPr txBox="1"/>
-          <p:nvPr/>
-        </p:nvSpPr>
-        <p:spPr>
-          <a:xfrm>
-            <a:off x="6995160" y="4315968"/>
-            <a:ext cx="1005840" cy="338328"/>
+          <p:cNvPr id="71" name="Text 69"/>
+          <p:cNvSpPr txBox="1"/>
+          <p:nvPr/>
+        </p:nvSpPr>
+        <p:spPr>
+          <a:xfrm>
+            <a:off x="6309360" y="4315968"/>
+            <a:ext cx="868680" cy="338328"/>
           </a:xfrm>
           <a:prstGeom prst="rect">
             <a:avLst/>
@@ -35834,14 +36107,53 @@
       </p:sp>
       <p:sp>
         <p:nvSpPr>
-          <p:cNvPr id="65" name="Text 63"/>
+          <p:cNvPr id="72" name="Text 70"/>
+          <p:cNvSpPr txBox="1"/>
+          <p:nvPr/>
+        </p:nvSpPr>
+        <p:spPr>
+          <a:xfrm>
+            <a:off x="7178040" y="4315968"/>
+            <a:ext cx="822960" cy="338328"/>
+          </a:xfrm>
+          <a:prstGeom prst="rect">
+            <a:avLst/>
+          </a:prstGeom>
+          <a:noFill/>
+          <a:ln/>
+        </p:spPr>
+        <p:txBody>
+          <a:bodyPr wrap="square" lIns="0" tIns="0" rIns="0" bIns="0" rtlCol="0" anchor="ctr"/>
+          <a:lstStyle/>
+          <a:p>
+            <a:pPr algn="ctr" indent="0" marL="0">
+              <a:buNone/>
+            </a:pPr>
+            <a:r>
+              <a:rPr lang="en-US" sz="1200" dirty="0">
+                <a:solidFill>
+                  <a:srgbClr val="E66767"/>
+                </a:solidFill>
+                <a:latin typeface="Arial" pitchFamily="34" charset="0"/>
+                <a:ea typeface="Arial" pitchFamily="34" charset="-122"/>
+                <a:cs typeface="Arial" pitchFamily="34" charset="-120"/>
+              </a:rPr>
+              <a:t>−0.2</a:t>
+            </a:r>
+            <a:endParaRPr lang="en-US" sz="1200" dirty="0"/>
+          </a:p>
+        </p:txBody>
+      </p:sp>
+      <p:sp>
+        <p:nvSpPr>
+          <p:cNvPr id="73" name="Text 71"/>
           <p:cNvSpPr txBox="1"/>
           <p:nvPr/>
         </p:nvSpPr>
         <p:spPr>
           <a:xfrm>
             <a:off x="8001000" y="4315968"/>
-            <a:ext cx="960120" cy="338328"/>
+            <a:ext cx="914400" cy="338328"/>
           </a:xfrm>
           <a:prstGeom prst="rect">
             <a:avLst/>
@@ -35857,15 +36169,54 @@
               <a:buNone/>
             </a:pPr>
             <a:r>
+              <a:rPr lang="en-US" sz="1200" b="1" dirty="0">
+                <a:solidFill>
+                  <a:srgbClr val="E66767"/>
+                </a:solidFill>
+                <a:latin typeface="Arial" pitchFamily="34" charset="0"/>
+                <a:ea typeface="Arial" pitchFamily="34" charset="-122"/>
+                <a:cs typeface="Arial" pitchFamily="34" charset="-120"/>
+              </a:rPr>
+              <a:t>−0.25</a:t>
+            </a:r>
+            <a:endParaRPr lang="en-US" sz="1200" dirty="0"/>
+          </a:p>
+        </p:txBody>
+      </p:sp>
+      <p:sp>
+        <p:nvSpPr>
+          <p:cNvPr id="74" name="Text 72"/>
+          <p:cNvSpPr txBox="1"/>
+          <p:nvPr/>
+        </p:nvSpPr>
+        <p:spPr>
+          <a:xfrm>
+            <a:off x="8915400" y="4315968"/>
+            <a:ext cx="1554480" cy="338328"/>
+          </a:xfrm>
+          <a:prstGeom prst="rect">
+            <a:avLst/>
+          </a:prstGeom>
+          <a:noFill/>
+          <a:ln/>
+        </p:spPr>
+        <p:txBody>
+          <a:bodyPr wrap="square" lIns="0" tIns="0" rIns="0" bIns="0" rtlCol="0" anchor="ctr"/>
+          <a:lstStyle/>
+          <a:p>
+            <a:pPr algn="ctr" indent="0" marL="0">
+              <a:buNone/>
+            </a:pPr>
+            <a:r>
               <a:rPr lang="en-US" sz="1200" dirty="0">
                 <a:solidFill>
-                  <a:srgbClr val="E66767"/>
-                </a:solidFill>
-                <a:latin typeface="Arial" pitchFamily="34" charset="0"/>
-                <a:ea typeface="Arial" pitchFamily="34" charset="-122"/>
-                <a:cs typeface="Arial" pitchFamily="34" charset="-120"/>
-              </a:rPr>
-              <a:t>−0.2</a:t>
+                  <a:srgbClr val="A3A8B0"/>
+                </a:solidFill>
+                <a:latin typeface="Arial" pitchFamily="34" charset="0"/>
+                <a:ea typeface="Arial" pitchFamily="34" charset="-122"/>
+                <a:cs typeface="Arial" pitchFamily="34" charset="-120"/>
+              </a:rPr>
+              <a:t>tăng &lt; 0.5</a:t>
             </a:r>
             <a:endParaRPr lang="en-US" sz="1200" dirty="0"/>
           </a:p>
@@ -35873,14 +36224,14 @@
       </p:sp>
       <p:sp>
         <p:nvSpPr>
-          <p:cNvPr id="66" name="Text 64"/>
-          <p:cNvSpPr txBox="1"/>
-          <p:nvPr/>
-        </p:nvSpPr>
-        <p:spPr>
-          <a:xfrm>
-            <a:off x="8961120" y="4315968"/>
-            <a:ext cx="960120" cy="338328"/>
+          <p:cNvPr id="75" name="Text 73"/>
+          <p:cNvSpPr txBox="1"/>
+          <p:nvPr/>
+        </p:nvSpPr>
+        <p:spPr>
+          <a:xfrm>
+            <a:off x="10469880" y="4315968"/>
+            <a:ext cx="1143000" cy="338328"/>
           </a:xfrm>
           <a:prstGeom prst="rect">
             <a:avLst/>
@@ -35896,15 +36247,15 @@
               <a:buNone/>
             </a:pPr>
             <a:r>
-              <a:rPr lang="en-US" sz="1200" b="1" dirty="0">
-                <a:solidFill>
-                  <a:srgbClr val="E66767"/>
-                </a:solidFill>
-                <a:latin typeface="Arial" pitchFamily="34" charset="0"/>
-                <a:ea typeface="Arial" pitchFamily="34" charset="-122"/>
-                <a:cs typeface="Arial" pitchFamily="34" charset="-120"/>
-              </a:rPr>
-              <a:t>−0.25</a:t>
+              <a:rPr lang="en-US" sz="1200" dirty="0">
+                <a:solidFill>
+                  <a:srgbClr val="A3A8B0"/>
+                </a:solidFill>
+                <a:latin typeface="Arial" pitchFamily="34" charset="0"/>
+                <a:ea typeface="Arial" pitchFamily="34" charset="-122"/>
+                <a:cs typeface="Arial" pitchFamily="34" charset="-120"/>
+              </a:rPr>
+              <a:t>+0.38</a:t>
             </a:r>
             <a:endParaRPr lang="en-US" sz="1200" dirty="0"/>
           </a:p>
@@ -35912,46 +36263,7 @@
       </p:sp>
       <p:sp>
         <p:nvSpPr>
-          <p:cNvPr id="67" name="Text 65"/>
-          <p:cNvSpPr txBox="1"/>
-          <p:nvPr/>
-        </p:nvSpPr>
-        <p:spPr>
-          <a:xfrm>
-            <a:off x="9921240" y="4315968"/>
-            <a:ext cx="1691640" cy="338328"/>
-          </a:xfrm>
-          <a:prstGeom prst="rect">
-            <a:avLst/>
-          </a:prstGeom>
-          <a:noFill/>
-          <a:ln/>
-        </p:spPr>
-        <p:txBody>
-          <a:bodyPr wrap="square" lIns="0" tIns="0" rIns="0" bIns="0" rtlCol="0" anchor="ctr"/>
-          <a:lstStyle/>
-          <a:p>
-            <a:pPr algn="ctr" indent="0" marL="0">
-              <a:buNone/>
-            </a:pPr>
-            <a:r>
-              <a:rPr lang="en-US" sz="1200" dirty="0">
-                <a:solidFill>
-                  <a:srgbClr val="A3A8B0"/>
-                </a:solidFill>
-                <a:latin typeface="Arial" pitchFamily="34" charset="0"/>
-                <a:ea typeface="Arial" pitchFamily="34" charset="-122"/>
-                <a:cs typeface="Arial" pitchFamily="34" charset="-120"/>
-              </a:rPr>
-              <a:t>tăng &lt; 0.5</a:t>
-            </a:r>
-            <a:endParaRPr lang="en-US" sz="1200" dirty="0"/>
-          </a:p>
-        </p:txBody>
-      </p:sp>
-      <p:sp>
-        <p:nvSpPr>
-          <p:cNvPr id="68" name="Shape 66"/>
+          <p:cNvPr id="76" name="Shape 74"/>
           <p:cNvSpPr/>
           <p:nvPr/>
         </p:nvSpPr>
@@ -35978,14 +36290,14 @@
       </p:sp>
       <p:sp>
         <p:nvSpPr>
-          <p:cNvPr id="69" name="Text 67"/>
+          <p:cNvPr id="77" name="Text 75"/>
           <p:cNvSpPr txBox="1"/>
           <p:nvPr/>
         </p:nvSpPr>
         <p:spPr>
           <a:xfrm>
             <a:off x="777240" y="4700016"/>
-            <a:ext cx="3200400" cy="338328"/>
+            <a:ext cx="2834640" cy="338328"/>
           </a:xfrm>
           <a:prstGeom prst="rect">
             <a:avLst/>
@@ -36017,14 +36329,14 @@
       </p:sp>
       <p:sp>
         <p:nvSpPr>
-          <p:cNvPr id="70" name="Text 68"/>
-          <p:cNvSpPr txBox="1"/>
-          <p:nvPr/>
-        </p:nvSpPr>
-        <p:spPr>
-          <a:xfrm>
-            <a:off x="3977640" y="4700016"/>
-            <a:ext cx="2011680" cy="338328"/>
+          <p:cNvPr id="78" name="Text 76"/>
+          <p:cNvSpPr txBox="1"/>
+          <p:nvPr/>
+        </p:nvSpPr>
+        <p:spPr>
+          <a:xfrm>
+            <a:off x="3611880" y="4700016"/>
+            <a:ext cx="1828800" cy="338328"/>
           </a:xfrm>
           <a:prstGeom prst="rect">
             <a:avLst/>
@@ -36056,14 +36368,14 @@
       </p:sp>
       <p:sp>
         <p:nvSpPr>
-          <p:cNvPr id="71" name="Text 69"/>
-          <p:cNvSpPr txBox="1"/>
-          <p:nvPr/>
-        </p:nvSpPr>
-        <p:spPr>
-          <a:xfrm>
-            <a:off x="5989320" y="4700016"/>
-            <a:ext cx="1005840" cy="338328"/>
+          <p:cNvPr id="79" name="Text 77"/>
+          <p:cNvSpPr txBox="1"/>
+          <p:nvPr/>
+        </p:nvSpPr>
+        <p:spPr>
+          <a:xfrm>
+            <a:off x="5440680" y="4700016"/>
+            <a:ext cx="868680" cy="338328"/>
           </a:xfrm>
           <a:prstGeom prst="rect">
             <a:avLst/>
@@ -36095,14 +36407,14 @@
       </p:sp>
       <p:sp>
         <p:nvSpPr>
-          <p:cNvPr id="72" name="Text 70"/>
-          <p:cNvSpPr txBox="1"/>
-          <p:nvPr/>
-        </p:nvSpPr>
-        <p:spPr>
-          <a:xfrm>
-            <a:off x="6995160" y="4700016"/>
-            <a:ext cx="1005840" cy="338328"/>
+          <p:cNvPr id="80" name="Text 78"/>
+          <p:cNvSpPr txBox="1"/>
+          <p:nvPr/>
+        </p:nvSpPr>
+        <p:spPr>
+          <a:xfrm>
+            <a:off x="6309360" y="4700016"/>
+            <a:ext cx="868680" cy="338328"/>
           </a:xfrm>
           <a:prstGeom prst="rect">
             <a:avLst/>
@@ -36134,14 +36446,53 @@
       </p:sp>
       <p:sp>
         <p:nvSpPr>
-          <p:cNvPr id="73" name="Text 71"/>
+          <p:cNvPr id="81" name="Text 79"/>
+          <p:cNvSpPr txBox="1"/>
+          <p:nvPr/>
+        </p:nvSpPr>
+        <p:spPr>
+          <a:xfrm>
+            <a:off x="7178040" y="4700016"/>
+            <a:ext cx="822960" cy="338328"/>
+          </a:xfrm>
+          <a:prstGeom prst="rect">
+            <a:avLst/>
+          </a:prstGeom>
+          <a:noFill/>
+          <a:ln/>
+        </p:spPr>
+        <p:txBody>
+          <a:bodyPr wrap="square" lIns="0" tIns="0" rIns="0" bIns="0" rtlCol="0" anchor="ctr"/>
+          <a:lstStyle/>
+          <a:p>
+            <a:pPr algn="ctr" indent="0" marL="0">
+              <a:buNone/>
+            </a:pPr>
+            <a:r>
+              <a:rPr lang="en-US" sz="1200" dirty="0">
+                <a:solidFill>
+                  <a:srgbClr val="F2F2F2"/>
+                </a:solidFill>
+                <a:latin typeface="Arial" pitchFamily="34" charset="0"/>
+                <a:ea typeface="Arial" pitchFamily="34" charset="-122"/>
+                <a:cs typeface="Arial" pitchFamily="34" charset="-120"/>
+              </a:rPr>
+              <a:t>±0.0</a:t>
+            </a:r>
+            <a:endParaRPr lang="en-US" sz="1200" dirty="0"/>
+          </a:p>
+        </p:txBody>
+      </p:sp>
+      <p:sp>
+        <p:nvSpPr>
+          <p:cNvPr id="82" name="Text 80"/>
           <p:cNvSpPr txBox="1"/>
           <p:nvPr/>
         </p:nvSpPr>
         <p:spPr>
           <a:xfrm>
             <a:off x="8001000" y="4700016"/>
-            <a:ext cx="960120" cy="338328"/>
+            <a:ext cx="914400" cy="338328"/>
           </a:xfrm>
           <a:prstGeom prst="rect">
             <a:avLst/>
@@ -36157,15 +36508,54 @@
               <a:buNone/>
             </a:pPr>
             <a:r>
+              <a:rPr lang="en-US" sz="1200" b="1" dirty="0">
+                <a:solidFill>
+                  <a:srgbClr val="E66767"/>
+                </a:solidFill>
+                <a:latin typeface="Arial" pitchFamily="34" charset="0"/>
+                <a:ea typeface="Arial" pitchFamily="34" charset="-122"/>
+                <a:cs typeface="Arial" pitchFamily="34" charset="-120"/>
+              </a:rPr>
+              <a:t>−0.26</a:t>
+            </a:r>
+            <a:endParaRPr lang="en-US" sz="1200" dirty="0"/>
+          </a:p>
+        </p:txBody>
+      </p:sp>
+      <p:sp>
+        <p:nvSpPr>
+          <p:cNvPr id="83" name="Text 81"/>
+          <p:cNvSpPr txBox="1"/>
+          <p:nvPr/>
+        </p:nvSpPr>
+        <p:spPr>
+          <a:xfrm>
+            <a:off x="8915400" y="4700016"/>
+            <a:ext cx="1554480" cy="338328"/>
+          </a:xfrm>
+          <a:prstGeom prst="rect">
+            <a:avLst/>
+          </a:prstGeom>
+          <a:noFill/>
+          <a:ln/>
+        </p:spPr>
+        <p:txBody>
+          <a:bodyPr wrap="square" lIns="0" tIns="0" rIns="0" bIns="0" rtlCol="0" anchor="ctr"/>
+          <a:lstStyle/>
+          <a:p>
+            <a:pPr algn="ctr" indent="0" marL="0">
+              <a:buNone/>
+            </a:pPr>
+            <a:r>
               <a:rPr lang="en-US" sz="1200" dirty="0">
                 <a:solidFill>
-                  <a:srgbClr val="F2F2F2"/>
-                </a:solidFill>
-                <a:latin typeface="Arial" pitchFamily="34" charset="0"/>
-                <a:ea typeface="Arial" pitchFamily="34" charset="-122"/>
-                <a:cs typeface="Arial" pitchFamily="34" charset="-120"/>
-              </a:rPr>
-              <a:t>±0.0</a:t>
+                  <a:srgbClr val="A3A8B0"/>
+                </a:solidFill>
+                <a:latin typeface="Arial" pitchFamily="34" charset="0"/>
+                <a:ea typeface="Arial" pitchFamily="34" charset="-122"/>
+                <a:cs typeface="Arial" pitchFamily="34" charset="-120"/>
+              </a:rPr>
+              <a:t>tăng &lt; 0.5</a:t>
             </a:r>
             <a:endParaRPr lang="en-US" sz="1200" dirty="0"/>
           </a:p>
@@ -36173,14 +36563,14 @@
       </p:sp>
       <p:sp>
         <p:nvSpPr>
-          <p:cNvPr id="74" name="Text 72"/>
-          <p:cNvSpPr txBox="1"/>
-          <p:nvPr/>
-        </p:nvSpPr>
-        <p:spPr>
-          <a:xfrm>
-            <a:off x="8961120" y="4700016"/>
-            <a:ext cx="960120" cy="338328"/>
+          <p:cNvPr id="84" name="Text 82"/>
+          <p:cNvSpPr txBox="1"/>
+          <p:nvPr/>
+        </p:nvSpPr>
+        <p:spPr>
+          <a:xfrm>
+            <a:off x="10469880" y="4700016"/>
+            <a:ext cx="1143000" cy="338328"/>
           </a:xfrm>
           <a:prstGeom prst="rect">
             <a:avLst/>
@@ -36196,15 +36586,15 @@
               <a:buNone/>
             </a:pPr>
             <a:r>
-              <a:rPr lang="en-US" sz="1200" b="1" dirty="0">
-                <a:solidFill>
-                  <a:srgbClr val="E66767"/>
-                </a:solidFill>
-                <a:latin typeface="Arial" pitchFamily="34" charset="0"/>
-                <a:ea typeface="Arial" pitchFamily="34" charset="-122"/>
-                <a:cs typeface="Arial" pitchFamily="34" charset="-120"/>
-              </a:rPr>
-              <a:t>−0.26</a:t>
+              <a:rPr lang="en-US" sz="1200" dirty="0">
+                <a:solidFill>
+                  <a:srgbClr val="A3A8B0"/>
+                </a:solidFill>
+                <a:latin typeface="Arial" pitchFamily="34" charset="0"/>
+                <a:ea typeface="Arial" pitchFamily="34" charset="-122"/>
+                <a:cs typeface="Arial" pitchFamily="34" charset="-120"/>
+              </a:rPr>
+              <a:t>+1.27</a:t>
             </a:r>
             <a:endParaRPr lang="en-US" sz="1200" dirty="0"/>
           </a:p>
@@ -36212,46 +36602,7 @@
       </p:sp>
       <p:sp>
         <p:nvSpPr>
-          <p:cNvPr id="75" name="Text 73"/>
-          <p:cNvSpPr txBox="1"/>
-          <p:nvPr/>
-        </p:nvSpPr>
-        <p:spPr>
-          <a:xfrm>
-            <a:off x="9921240" y="4700016"/>
-            <a:ext cx="1691640" cy="338328"/>
-          </a:xfrm>
-          <a:prstGeom prst="rect">
-            <a:avLst/>
-          </a:prstGeom>
-          <a:noFill/>
-          <a:ln/>
-        </p:spPr>
-        <p:txBody>
-          <a:bodyPr wrap="square" lIns="0" tIns="0" rIns="0" bIns="0" rtlCol="0" anchor="ctr"/>
-          <a:lstStyle/>
-          <a:p>
-            <a:pPr algn="ctr" indent="0" marL="0">
-              <a:buNone/>
-            </a:pPr>
-            <a:r>
-              <a:rPr lang="en-US" sz="1200" dirty="0">
-                <a:solidFill>
-                  <a:srgbClr val="A3A8B0"/>
-                </a:solidFill>
-                <a:latin typeface="Arial" pitchFamily="34" charset="0"/>
-                <a:ea typeface="Arial" pitchFamily="34" charset="-122"/>
-                <a:cs typeface="Arial" pitchFamily="34" charset="-120"/>
-              </a:rPr>
-              <a:t>tăng &lt; 0.5</a:t>
-            </a:r>
-            <a:endParaRPr lang="en-US" sz="1200" dirty="0"/>
-          </a:p>
-        </p:txBody>
-      </p:sp>
-      <p:sp>
-        <p:nvSpPr>
-          <p:cNvPr id="76" name="Shape 74"/>
+          <p:cNvPr id="85" name="Shape 83"/>
           <p:cNvSpPr/>
           <p:nvPr/>
         </p:nvSpPr>
@@ -36278,14 +36629,14 @@
       </p:sp>
       <p:sp>
         <p:nvSpPr>
-          <p:cNvPr id="77" name="Text 75"/>
+          <p:cNvPr id="86" name="Text 84"/>
           <p:cNvSpPr txBox="1"/>
           <p:nvPr/>
         </p:nvSpPr>
         <p:spPr>
           <a:xfrm>
             <a:off x="777240" y="5084064"/>
-            <a:ext cx="3200400" cy="338328"/>
+            <a:ext cx="2834640" cy="338328"/>
           </a:xfrm>
           <a:prstGeom prst="rect">
             <a:avLst/>
@@ -36317,14 +36668,14 @@
       </p:sp>
       <p:sp>
         <p:nvSpPr>
-          <p:cNvPr id="78" name="Text 76"/>
-          <p:cNvSpPr txBox="1"/>
-          <p:nvPr/>
-        </p:nvSpPr>
-        <p:spPr>
-          <a:xfrm>
-            <a:off x="3977640" y="5084064"/>
-            <a:ext cx="2011680" cy="338328"/>
+          <p:cNvPr id="87" name="Text 85"/>
+          <p:cNvSpPr txBox="1"/>
+          <p:nvPr/>
+        </p:nvSpPr>
+        <p:spPr>
+          <a:xfrm>
+            <a:off x="3611880" y="5084064"/>
+            <a:ext cx="1828800" cy="338328"/>
           </a:xfrm>
           <a:prstGeom prst="rect">
             <a:avLst/>
@@ -36356,14 +36707,14 @@
       </p:sp>
       <p:sp>
         <p:nvSpPr>
-          <p:cNvPr id="79" name="Text 77"/>
-          <p:cNvSpPr txBox="1"/>
-          <p:nvPr/>
-        </p:nvSpPr>
-        <p:spPr>
-          <a:xfrm>
-            <a:off x="5989320" y="5084064"/>
-            <a:ext cx="1005840" cy="338328"/>
+          <p:cNvPr id="88" name="Text 86"/>
+          <p:cNvSpPr txBox="1"/>
+          <p:nvPr/>
+        </p:nvSpPr>
+        <p:spPr>
+          <a:xfrm>
+            <a:off x="5440680" y="5084064"/>
+            <a:ext cx="868680" cy="338328"/>
           </a:xfrm>
           <a:prstGeom prst="rect">
             <a:avLst/>
@@ -36395,14 +36746,14 @@
       </p:sp>
       <p:sp>
         <p:nvSpPr>
-          <p:cNvPr id="80" name="Text 78"/>
-          <p:cNvSpPr txBox="1"/>
-          <p:nvPr/>
-        </p:nvSpPr>
-        <p:spPr>
-          <a:xfrm>
-            <a:off x="6995160" y="5084064"/>
-            <a:ext cx="1005840" cy="338328"/>
+          <p:cNvPr id="89" name="Text 87"/>
+          <p:cNvSpPr txBox="1"/>
+          <p:nvPr/>
+        </p:nvSpPr>
+        <p:spPr>
+          <a:xfrm>
+            <a:off x="6309360" y="5084064"/>
+            <a:ext cx="868680" cy="338328"/>
           </a:xfrm>
           <a:prstGeom prst="rect">
             <a:avLst/>
@@ -36434,14 +36785,53 @@
       </p:sp>
       <p:sp>
         <p:nvSpPr>
-          <p:cNvPr id="81" name="Text 79"/>
+          <p:cNvPr id="90" name="Text 88"/>
+          <p:cNvSpPr txBox="1"/>
+          <p:nvPr/>
+        </p:nvSpPr>
+        <p:spPr>
+          <a:xfrm>
+            <a:off x="7178040" y="5084064"/>
+            <a:ext cx="822960" cy="338328"/>
+          </a:xfrm>
+          <a:prstGeom prst="rect">
+            <a:avLst/>
+          </a:prstGeom>
+          <a:noFill/>
+          <a:ln/>
+        </p:spPr>
+        <p:txBody>
+          <a:bodyPr wrap="square" lIns="0" tIns="0" rIns="0" bIns="0" rtlCol="0" anchor="ctr"/>
+          <a:lstStyle/>
+          <a:p>
+            <a:pPr algn="ctr" indent="0" marL="0">
+              <a:buNone/>
+            </a:pPr>
+            <a:r>
+              <a:rPr lang="en-US" sz="1200" dirty="0">
+                <a:solidFill>
+                  <a:srgbClr val="E66767"/>
+                </a:solidFill>
+                <a:latin typeface="Arial" pitchFamily="34" charset="0"/>
+                <a:ea typeface="Arial" pitchFamily="34" charset="-122"/>
+                <a:cs typeface="Arial" pitchFamily="34" charset="-120"/>
+              </a:rPr>
+              <a:t>−0.7</a:t>
+            </a:r>
+            <a:endParaRPr lang="en-US" sz="1200" dirty="0"/>
+          </a:p>
+        </p:txBody>
+      </p:sp>
+      <p:sp>
+        <p:nvSpPr>
+          <p:cNvPr id="91" name="Text 89"/>
           <p:cNvSpPr txBox="1"/>
           <p:nvPr/>
         </p:nvSpPr>
         <p:spPr>
           <a:xfrm>
             <a:off x="8001000" y="5084064"/>
-            <a:ext cx="960120" cy="338328"/>
+            <a:ext cx="914400" cy="338328"/>
           </a:xfrm>
           <a:prstGeom prst="rect">
             <a:avLst/>
@@ -36457,15 +36847,54 @@
               <a:buNone/>
             </a:pPr>
             <a:r>
+              <a:rPr lang="en-US" sz="1200" b="1" dirty="0">
+                <a:solidFill>
+                  <a:srgbClr val="E66767"/>
+                </a:solidFill>
+                <a:latin typeface="Arial" pitchFamily="34" charset="0"/>
+                <a:ea typeface="Arial" pitchFamily="34" charset="-122"/>
+                <a:cs typeface="Arial" pitchFamily="34" charset="-120"/>
+              </a:rPr>
+              <a:t>−1.53</a:t>
+            </a:r>
+            <a:endParaRPr lang="en-US" sz="1200" dirty="0"/>
+          </a:p>
+        </p:txBody>
+      </p:sp>
+      <p:sp>
+        <p:nvSpPr>
+          <p:cNvPr id="92" name="Text 90"/>
+          <p:cNvSpPr txBox="1"/>
+          <p:nvPr/>
+        </p:nvSpPr>
+        <p:spPr>
+          <a:xfrm>
+            <a:off x="8915400" y="5084064"/>
+            <a:ext cx="1554480" cy="338328"/>
+          </a:xfrm>
+          <a:prstGeom prst="rect">
+            <a:avLst/>
+          </a:prstGeom>
+          <a:noFill/>
+          <a:ln/>
+        </p:spPr>
+        <p:txBody>
+          <a:bodyPr wrap="square" lIns="0" tIns="0" rIns="0" bIns="0" rtlCol="0" anchor="ctr"/>
+          <a:lstStyle/>
+          <a:p>
+            <a:pPr algn="ctr" indent="0" marL="0">
+              <a:buNone/>
+            </a:pPr>
+            <a:r>
               <a:rPr lang="en-US" sz="1200" dirty="0">
                 <a:solidFill>
-                  <a:srgbClr val="E66767"/>
-                </a:solidFill>
-                <a:latin typeface="Arial" pitchFamily="34" charset="0"/>
-                <a:ea typeface="Arial" pitchFamily="34" charset="-122"/>
-                <a:cs typeface="Arial" pitchFamily="34" charset="-120"/>
-              </a:rPr>
-              <a:t>−0.7</a:t>
+                  <a:srgbClr val="A3A8B0"/>
+                </a:solidFill>
+                <a:latin typeface="Arial" pitchFamily="34" charset="0"/>
+                <a:ea typeface="Arial" pitchFamily="34" charset="-122"/>
+                <a:cs typeface="Arial" pitchFamily="34" charset="-120"/>
+              </a:rPr>
+              <a:t>giảm &gt; 0.5</a:t>
             </a:r>
             <a:endParaRPr lang="en-US" sz="1200" dirty="0"/>
           </a:p>
@@ -36473,14 +36902,14 @@
       </p:sp>
       <p:sp>
         <p:nvSpPr>
-          <p:cNvPr id="82" name="Text 80"/>
-          <p:cNvSpPr txBox="1"/>
-          <p:nvPr/>
-        </p:nvSpPr>
-        <p:spPr>
-          <a:xfrm>
-            <a:off x="8961120" y="5084064"/>
-            <a:ext cx="960120" cy="338328"/>
+          <p:cNvPr id="93" name="Text 91"/>
+          <p:cNvSpPr txBox="1"/>
+          <p:nvPr/>
+        </p:nvSpPr>
+        <p:spPr>
+          <a:xfrm>
+            <a:off x="10469880" y="5084064"/>
+            <a:ext cx="1143000" cy="338328"/>
           </a:xfrm>
           <a:prstGeom prst="rect">
             <a:avLst/>
@@ -36496,15 +36925,15 @@
               <a:buNone/>
             </a:pPr>
             <a:r>
-              <a:rPr lang="en-US" sz="1200" b="1" dirty="0">
-                <a:solidFill>
-                  <a:srgbClr val="E66767"/>
-                </a:solidFill>
-                <a:latin typeface="Arial" pitchFamily="34" charset="0"/>
-                <a:ea typeface="Arial" pitchFamily="34" charset="-122"/>
-                <a:cs typeface="Arial" pitchFamily="34" charset="-120"/>
-              </a:rPr>
-              <a:t>−1.53</a:t>
+              <a:rPr lang="en-US" sz="1200" dirty="0">
+                <a:solidFill>
+                  <a:srgbClr val="A3A8B0"/>
+                </a:solidFill>
+                <a:latin typeface="Arial" pitchFamily="34" charset="0"/>
+                <a:ea typeface="Arial" pitchFamily="34" charset="-122"/>
+                <a:cs typeface="Arial" pitchFamily="34" charset="-120"/>
+              </a:rPr>
+              <a:t>+3.58</a:t>
             </a:r>
             <a:endParaRPr lang="en-US" sz="1200" dirty="0"/>
           </a:p>
@@ -36512,46 +36941,7 @@
       </p:sp>
       <p:sp>
         <p:nvSpPr>
-          <p:cNvPr id="83" name="Text 81"/>
-          <p:cNvSpPr txBox="1"/>
-          <p:nvPr/>
-        </p:nvSpPr>
-        <p:spPr>
-          <a:xfrm>
-            <a:off x="9921240" y="5084064"/>
-            <a:ext cx="1691640" cy="338328"/>
-          </a:xfrm>
-          <a:prstGeom prst="rect">
-            <a:avLst/>
-          </a:prstGeom>
-          <a:noFill/>
-          <a:ln/>
-        </p:spPr>
-        <p:txBody>
-          <a:bodyPr wrap="square" lIns="0" tIns="0" rIns="0" bIns="0" rtlCol="0" anchor="ctr"/>
-          <a:lstStyle/>
-          <a:p>
-            <a:pPr algn="ctr" indent="0" marL="0">
-              <a:buNone/>
-            </a:pPr>
-            <a:r>
-              <a:rPr lang="en-US" sz="1200" dirty="0">
-                <a:solidFill>
-                  <a:srgbClr val="A3A8B0"/>
-                </a:solidFill>
-                <a:latin typeface="Arial" pitchFamily="34" charset="0"/>
-                <a:ea typeface="Arial" pitchFamily="34" charset="-122"/>
-                <a:cs typeface="Arial" pitchFamily="34" charset="-120"/>
-              </a:rPr>
-              <a:t>giảm &gt; 0.5</a:t>
-            </a:r>
-            <a:endParaRPr lang="en-US" sz="1200" dirty="0"/>
-          </a:p>
-        </p:txBody>
-      </p:sp>
-      <p:sp>
-        <p:nvSpPr>
-          <p:cNvPr id="84" name="Shape 82"/>
+          <p:cNvPr id="94" name="Shape 92"/>
           <p:cNvSpPr/>
           <p:nvPr/>
         </p:nvSpPr>
@@ -36578,7 +36968,7 @@
       </p:sp>
       <p:sp>
         <p:nvSpPr>
-          <p:cNvPr id="85" name="Shape 83"/>
+          <p:cNvPr id="95" name="Shape 93"/>
           <p:cNvSpPr/>
           <p:nvPr/>
         </p:nvSpPr>
@@ -36603,7 +36993,7 @@
       </p:sp>
       <p:sp>
         <p:nvSpPr>
-          <p:cNvPr id="86" name="Text 84"/>
+          <p:cNvPr id="96" name="Text 94"/>
           <p:cNvSpPr txBox="1"/>
           <p:nvPr/>
         </p:nvSpPr>
@@ -36648,7 +37038,7 @@
                 <a:ea typeface="Arial" pitchFamily="34" charset="-122"/>
                 <a:cs typeface="Arial" pitchFamily="34" charset="-120"/>
               </a:rPr>
-              <a:t>Cone (M1) tăng nhờ đúng 1 video T1 (156) + 1 video T2 (147); hãm vận tốc tăng nhờ 1 lần chói (video 332). Test một lần cho cấu hình cuối = PEG: 68.34 · 61.41 · 76.2.</a:t>
+              <a:t>Test cho cấu hình cuối = PEG: 68.34 · 61.41 · 76.2. Cột test chỉ để đối chiếu (chạy sau khi đã chốt): trên test, M6 và đổi-ID viết lại tăng gần như chỉ nhờ 1 lần đổi ID ở video 129; cone nhờ video 204; hãm vận tốc −8.5 → val loại đúng.</a:t>
             </a:r>
             <a:endParaRPr lang="en-US" sz="1300" dirty="0"/>
           </a:p>
@@ -36656,7 +37046,7 @@
       </p:sp>
       <p:sp>
         <p:nvSpPr>
-          <p:cNvPr id="87" name="Shape 85"/>
+          <p:cNvPr id="97" name="Shape 95"/>
           <p:cNvSpPr/>
           <p:nvPr/>
         </p:nvSpPr>
@@ -36685,7 +37075,7 @@
       </p:sp>
       <p:sp>
         <p:nvSpPr>
-          <p:cNvPr id="88" name="Text 86"/>
+          <p:cNvPr id="98" name="Text 96"/>
           <p:cNvSpPr txBox="1"/>
           <p:nvPr/>
         </p:nvSpPr>
@@ -36724,7 +37114,7 @@
       </p:sp>
       <p:sp>
         <p:nvSpPr>
-          <p:cNvPr id="89" name="Text 87"/>
+          <p:cNvPr id="99" name="Text 97"/>
           <p:cNvSpPr txBox="1"/>
           <p:nvPr/>
         </p:nvSpPr>

</xml_diff>